<commit_message>
Corrige fidelidade visual das páginas 1, 2 e 14 do modelo
Adiciona fundo de textura de papel em tela cheia, usa o logo KA como
selo do rodapé e ajusta a geometria/tamanhos do título da capa (75pt),
do sumário (5+4 itens) e do divisor de seção (texto 100pt sem bloco
lateral), conforme o original. Inclui assets reaproveitados.

https://claude.ai/code/session_01ESkoLizKf58nxwpm6ofywL
</commit_message>
<xml_diff>
--- a/MODELO-BASE-ESTRATEGICA.pptx
+++ b/MODELO-BASE-ESTRATEGICA.pptx
@@ -3105,60 +3105,64 @@
         <p:nvPr/>
       </p:nvGrpSpPr>
       <p:grpSpPr/>
-      <p:sp>
-        <p:nvSpPr>
-          <p:cNvPr id="2" name="Rectangle 1"/>
-          <p:cNvSpPr/>
-          <p:nvPr/>
-        </p:nvSpPr>
+      <p:pic>
+        <p:nvPicPr>
+          <p:cNvPr id="2" name="Picture 1" descr="textura-papel.jpeg"/>
+          <p:cNvPicPr>
+            <a:picLocks noChangeAspect="1"/>
+          </p:cNvPicPr>
+          <p:nvPr/>
+        </p:nvPicPr>
+        <p:blipFill>
+          <a:blip r:embed="rId2"/>
+          <a:stretch>
+            <a:fillRect/>
+          </a:stretch>
+        </p:blipFill>
         <p:spPr>
           <a:xfrm>
             <a:off x="0" y="0"/>
-            <a:ext cx="320040" cy="10287000"/>
-          </a:xfrm>
-          <a:prstGeom prst="rect">
-            <a:avLst/>
-          </a:prstGeom>
-          <a:solidFill>
-            <a:srgbClr val="C8BFA8"/>
-          </a:solidFill>
-          <a:ln>
-            <a:noFill/>
-          </a:ln>
-          <a:effectLst/>
-        </p:spPr>
-        <p:style>
-          <a:lnRef idx="1">
-            <a:schemeClr val="accent1"/>
-          </a:lnRef>
-          <a:fillRef idx="3">
-            <a:schemeClr val="accent1"/>
-          </a:fillRef>
-          <a:effectRef idx="2">
-            <a:schemeClr val="accent1"/>
-          </a:effectRef>
-          <a:fontRef idx="minor">
-            <a:schemeClr val="lt1"/>
-          </a:fontRef>
-        </p:style>
-        <p:txBody>
-          <a:bodyPr rtlCol="0" anchor="ctr"/>
-          <a:lstStyle/>
-          <a:p>
-            <a:pPr algn="ctr"/>
-          </a:p>
-        </p:txBody>
-      </p:sp>
-      <p:sp>
-        <p:nvSpPr>
-          <p:cNvPr id="3" name="TextBox 2"/>
+            <a:ext cx="18288000" cy="10287000"/>
+          </a:xfrm>
+          <a:prstGeom prst="rect">
+            <a:avLst/>
+          </a:prstGeom>
+        </p:spPr>
+      </p:pic>
+      <p:pic>
+        <p:nvPicPr>
+          <p:cNvPr id="3" name="Picture 2" descr="logo-ka.png"/>
+          <p:cNvPicPr>
+            <a:picLocks noChangeAspect="1"/>
+          </p:cNvPicPr>
+          <p:nvPr/>
+        </p:nvPicPr>
+        <p:blipFill>
+          <a:blip r:embed="rId3"/>
+          <a:stretch>
+            <a:fillRect/>
+          </a:stretch>
+        </p:blipFill>
+        <p:spPr>
+          <a:xfrm>
+            <a:off x="365760" y="274320"/>
+            <a:ext cx="2926080" cy="914400"/>
+          </a:xfrm>
+          <a:prstGeom prst="rect">
+            <a:avLst/>
+          </a:prstGeom>
+        </p:spPr>
+      </p:pic>
+      <p:sp>
+        <p:nvSpPr>
+          <p:cNvPr id="4" name="TextBox 3"/>
           <p:cNvSpPr txBox="1"/>
           <p:nvPr/>
         </p:nvSpPr>
         <p:spPr>
           <a:xfrm>
-            <a:off x="1554480" y="3383280"/>
-            <a:ext cx="12801600" cy="2377440"/>
+            <a:off x="1536192" y="3593592"/>
+            <a:ext cx="11155680" cy="2194560"/>
           </a:xfrm>
           <a:prstGeom prst="rect">
             <a:avLst/>
@@ -3172,7 +3176,7 @@
           <a:lstStyle/>
           <a:p>
             <a:r>
-              <a:rPr sz="6000" b="1" i="0">
+              <a:rPr sz="7500" b="1" i="0">
                 <a:solidFill>
                   <a:srgbClr val="000000"/>
                 </a:solidFill>
@@ -3194,16 +3198,40 @@
           </a:p>
         </p:txBody>
       </p:sp>
-      <p:sp>
-        <p:nvSpPr>
-          <p:cNvPr id="4" name="TextBox 3"/>
+      <p:pic>
+        <p:nvPicPr>
+          <p:cNvPr id="5" name="Picture 4" descr="traco.png"/>
+          <p:cNvPicPr>
+            <a:picLocks noChangeAspect="1"/>
+          </p:cNvPicPr>
+          <p:nvPr/>
+        </p:nvPicPr>
+        <p:blipFill>
+          <a:blip r:embed="rId4"/>
+          <a:stretch>
+            <a:fillRect/>
+          </a:stretch>
+        </p:blipFill>
+        <p:spPr>
+          <a:xfrm>
+            <a:off x="11951208" y="3776472"/>
+            <a:ext cx="1490472" cy="1773936"/>
+          </a:xfrm>
+          <a:prstGeom prst="rect">
+            <a:avLst/>
+          </a:prstGeom>
+        </p:spPr>
+      </p:pic>
+      <p:sp>
+        <p:nvSpPr>
+          <p:cNvPr id="6" name="TextBox 5"/>
           <p:cNvSpPr txBox="1"/>
           <p:nvPr/>
         </p:nvSpPr>
         <p:spPr>
           <a:xfrm>
-            <a:off x="1554480" y="5943600"/>
-            <a:ext cx="12801600" cy="548640"/>
+            <a:off x="1536192" y="5824728"/>
+            <a:ext cx="11887200" cy="822960"/>
           </a:xfrm>
           <a:prstGeom prst="rect">
             <a:avLst/>
@@ -3217,27 +3245,36 @@
           <a:lstStyle/>
           <a:p>
             <a:r>
-              <a:rPr sz="2400" b="1" i="0">
+              <a:rPr sz="3000" b="0" i="0">
                 <a:solidFill>
                   <a:srgbClr val="1A1A1A"/>
                 </a:solidFill>
                 <a:latin typeface="Outfit"/>
               </a:rPr>
-              <a:t>Construção estratégica para clareza, consistência e expansão.</a:t>
-            </a:r>
-          </a:p>
-        </p:txBody>
-      </p:sp>
-      <p:sp>
-        <p:nvSpPr>
-          <p:cNvPr id="5" name="TextBox 4"/>
+              <a:t>Construção estratégica para </a:t>
+            </a:r>
+            <a:r>
+              <a:rPr sz="3000" b="1" i="0">
+                <a:solidFill>
+                  <a:srgbClr val="1A1A1A"/>
+                </a:solidFill>
+                <a:latin typeface="Outfit"/>
+              </a:rPr>
+              <a:t>clareza, consistência e expansão.</a:t>
+            </a:r>
+          </a:p>
+        </p:txBody>
+      </p:sp>
+      <p:sp>
+        <p:nvSpPr>
+          <p:cNvPr id="7" name="TextBox 6"/>
           <p:cNvSpPr txBox="1"/>
           <p:nvPr/>
         </p:nvSpPr>
         <p:spPr>
           <a:xfrm>
-            <a:off x="1554480" y="7863840"/>
-            <a:ext cx="9144000" cy="822960"/>
+            <a:off x="1536192" y="7790688"/>
+            <a:ext cx="7955279" cy="1005840"/>
           </a:xfrm>
           <a:prstGeom prst="rect">
             <a:avLst/>
@@ -3251,7 +3288,7 @@
           <a:lstStyle/>
           <a:p>
             <a:r>
-              <a:rPr sz="1800" b="0" i="0" spc="150">
+              <a:rPr sz="1950" b="0" i="0" spc="150">
                 <a:solidFill>
                   <a:srgbClr val="000000"/>
                 </a:solidFill>
@@ -3262,13 +3299,31 @@
           </a:p>
           <a:p>
             <a:r>
-              <a:rPr sz="1800" b="0" i="0">
+              <a:rPr sz="2650" b="0" i="0">
                 <a:solidFill>
                   <a:srgbClr val="1A1A1A"/>
                 </a:solidFill>
                 <a:latin typeface="Outfit"/>
               </a:rPr>
-              <a:t>Método Marca com Essência ©</a:t>
+              <a:t>Método </a:t>
+            </a:r>
+            <a:r>
+              <a:rPr sz="2650" b="1" i="0">
+                <a:solidFill>
+                  <a:srgbClr val="1A1A1A"/>
+                </a:solidFill>
+                <a:latin typeface="Outfit"/>
+              </a:rPr>
+              <a:t>Marca com Essência </a:t>
+            </a:r>
+            <a:r>
+              <a:rPr sz="1500" b="1" i="0">
+                <a:solidFill>
+                  <a:srgbClr val="1A1A1A"/>
+                </a:solidFill>
+                <a:latin typeface="Playfair Display"/>
+              </a:rPr>
+              <a:t>©</a:t>
             </a:r>
           </a:p>
         </p:txBody>
@@ -3299,50 +3354,30 @@
         <p:nvPr/>
       </p:nvGrpSpPr>
       <p:grpSpPr/>
-      <p:sp>
-        <p:nvSpPr>
-          <p:cNvPr id="2" name="Rectangle 1"/>
-          <p:cNvSpPr/>
-          <p:nvPr/>
-        </p:nvSpPr>
+      <p:pic>
+        <p:nvPicPr>
+          <p:cNvPr id="2" name="Picture 1" descr="textura-papel.jpeg"/>
+          <p:cNvPicPr>
+            <a:picLocks noChangeAspect="1"/>
+          </p:cNvPicPr>
+          <p:nvPr/>
+        </p:nvPicPr>
+        <p:blipFill>
+          <a:blip r:embed="rId2"/>
+          <a:stretch>
+            <a:fillRect/>
+          </a:stretch>
+        </p:blipFill>
         <p:spPr>
           <a:xfrm>
             <a:off x="0" y="0"/>
-            <a:ext cx="320040" cy="10287000"/>
-          </a:xfrm>
-          <a:prstGeom prst="rect">
-            <a:avLst/>
-          </a:prstGeom>
-          <a:solidFill>
-            <a:srgbClr val="C8BFA8"/>
-          </a:solidFill>
-          <a:ln>
-            <a:noFill/>
-          </a:ln>
-          <a:effectLst/>
-        </p:spPr>
-        <p:style>
-          <a:lnRef idx="1">
-            <a:schemeClr val="accent1"/>
-          </a:lnRef>
-          <a:fillRef idx="3">
-            <a:schemeClr val="accent1"/>
-          </a:fillRef>
-          <a:effectRef idx="2">
-            <a:schemeClr val="accent1"/>
-          </a:effectRef>
-          <a:fontRef idx="minor">
-            <a:schemeClr val="lt1"/>
-          </a:fontRef>
-        </p:style>
-        <p:txBody>
-          <a:bodyPr rtlCol="0" anchor="ctr"/>
-          <a:lstStyle/>
-          <a:p>
-            <a:pPr algn="ctr"/>
-          </a:p>
-        </p:txBody>
-      </p:sp>
+            <a:ext cx="18288000" cy="10287000"/>
+          </a:xfrm>
+          <a:prstGeom prst="rect">
+            <a:avLst/>
+          </a:prstGeom>
+        </p:spPr>
+      </p:pic>
       <p:sp>
         <p:nvSpPr>
           <p:cNvPr id="3" name="TextBox 2"/>
@@ -3411,40 +3446,30 @@
           </a:p>
         </p:txBody>
       </p:sp>
-      <p:sp>
-        <p:nvSpPr>
-          <p:cNvPr id="5" name="TextBox 4"/>
-          <p:cNvSpPr txBox="1"/>
-          <p:nvPr/>
-        </p:nvSpPr>
-        <p:spPr>
-          <a:xfrm>
-            <a:off x="1554480" y="8229600"/>
-            <a:ext cx="10972800" cy="640080"/>
-          </a:xfrm>
-          <a:prstGeom prst="rect">
-            <a:avLst/>
-          </a:prstGeom>
-          <a:noFill/>
-        </p:spPr>
-        <p:txBody>
-          <a:bodyPr wrap="square">
-            <a:spAutoFit/>
-          </a:bodyPr>
-          <a:lstStyle/>
-          <a:p>
-            <a:r>
-              <a:rPr sz="1800" b="1" i="0" spc="200">
-                <a:solidFill>
-                  <a:srgbClr val="7A7A72"/>
-                </a:solidFill>
-                <a:latin typeface="Outfit"/>
-              </a:rPr>
-              <a:t>KA · INTELIGÊNCIA PARA MARCAS</a:t>
-            </a:r>
-          </a:p>
-        </p:txBody>
-      </p:sp>
+      <p:pic>
+        <p:nvPicPr>
+          <p:cNvPr id="5" name="Picture 4" descr="logo-ka.png"/>
+          <p:cNvPicPr>
+            <a:picLocks noChangeAspect="1"/>
+          </p:cNvPicPr>
+          <p:nvPr/>
+        </p:nvPicPr>
+        <p:blipFill>
+          <a:blip r:embed="rId3"/>
+          <a:stretch>
+            <a:fillRect/>
+          </a:stretch>
+        </p:blipFill>
+        <p:spPr>
+          <a:xfrm>
+            <a:off x="1554480" y="8046720"/>
+            <a:ext cx="2926080" cy="914400"/>
+          </a:xfrm>
+          <a:prstGeom prst="rect">
+            <a:avLst/>
+          </a:prstGeom>
+        </p:spPr>
+      </p:pic>
     </p:spTree>
   </p:cSld>
   <p:clrMapOvr>
@@ -3471,15 +3496,39 @@
         <p:nvPr/>
       </p:nvGrpSpPr>
       <p:grpSpPr/>
-      <p:sp>
-        <p:nvSpPr>
-          <p:cNvPr id="2" name="TextBox 1"/>
+      <p:pic>
+        <p:nvPicPr>
+          <p:cNvPr id="2" name="Picture 1" descr="textura-papel.jpeg"/>
+          <p:cNvPicPr>
+            <a:picLocks noChangeAspect="1"/>
+          </p:cNvPicPr>
+          <p:nvPr/>
+        </p:nvPicPr>
+        <p:blipFill>
+          <a:blip r:embed="rId2"/>
+          <a:stretch>
+            <a:fillRect/>
+          </a:stretch>
+        </p:blipFill>
+        <p:spPr>
+          <a:xfrm>
+            <a:off x="0" y="0"/>
+            <a:ext cx="18288000" cy="10287000"/>
+          </a:xfrm>
+          <a:prstGeom prst="rect">
+            <a:avLst/>
+          </a:prstGeom>
+        </p:spPr>
+      </p:pic>
+      <p:sp>
+        <p:nvSpPr>
+          <p:cNvPr id="3" name="TextBox 2"/>
           <p:cNvSpPr txBox="1"/>
           <p:nvPr/>
         </p:nvSpPr>
         <p:spPr>
           <a:xfrm>
-            <a:off x="1554480" y="640080"/>
+            <a:off x="1737360" y="822960"/>
             <a:ext cx="9144000" cy="1463040"/>
           </a:xfrm>
           <a:prstGeom prst="rect">
@@ -3507,14 +3556,14 @@
       </p:sp>
       <p:sp>
         <p:nvSpPr>
-          <p:cNvPr id="3" name="TextBox 2"/>
+          <p:cNvPr id="4" name="TextBox 3"/>
           <p:cNvSpPr txBox="1"/>
           <p:nvPr/>
         </p:nvSpPr>
         <p:spPr>
           <a:xfrm>
-            <a:off x="1737360" y="2743200"/>
-            <a:ext cx="1188720" cy="914400"/>
+            <a:off x="1737360" y="2395728"/>
+            <a:ext cx="1280160" cy="914400"/>
           </a:xfrm>
           <a:prstGeom prst="rect">
             <a:avLst/>
@@ -3541,13 +3590,13 @@
       </p:sp>
       <p:sp>
         <p:nvSpPr>
-          <p:cNvPr id="4" name="TextBox 3"/>
+          <p:cNvPr id="5" name="TextBox 4"/>
           <p:cNvSpPr txBox="1"/>
           <p:nvPr/>
         </p:nvSpPr>
         <p:spPr>
           <a:xfrm>
-            <a:off x="2926080" y="2852928"/>
+            <a:off x="3063239" y="2560320"/>
             <a:ext cx="6217920" cy="914400"/>
           </a:xfrm>
           <a:prstGeom prst="rect">
@@ -3562,7 +3611,7 @@
           <a:lstStyle/>
           <a:p>
             <a:r>
-              <a:rPr sz="2600" b="0" i="0">
+              <a:rPr sz="3000" b="0" i="0">
                 <a:solidFill>
                   <a:srgbClr val="7A7A72"/>
                 </a:solidFill>
@@ -3575,14 +3624,14 @@
       </p:sp>
       <p:sp>
         <p:nvSpPr>
-          <p:cNvPr id="5" name="TextBox 4"/>
+          <p:cNvPr id="6" name="TextBox 5"/>
           <p:cNvSpPr txBox="1"/>
           <p:nvPr/>
         </p:nvSpPr>
         <p:spPr>
           <a:xfrm>
-            <a:off x="1737360" y="3886200"/>
-            <a:ext cx="1188720" cy="914400"/>
+            <a:off x="1737360" y="3456432"/>
+            <a:ext cx="1280160" cy="914400"/>
           </a:xfrm>
           <a:prstGeom prst="rect">
             <a:avLst/>
@@ -3609,13 +3658,13 @@
       </p:sp>
       <p:sp>
         <p:nvSpPr>
-          <p:cNvPr id="6" name="TextBox 5"/>
+          <p:cNvPr id="7" name="TextBox 6"/>
           <p:cNvSpPr txBox="1"/>
           <p:nvPr/>
         </p:nvSpPr>
         <p:spPr>
           <a:xfrm>
-            <a:off x="2926080" y="3995928"/>
+            <a:off x="3063239" y="3621024"/>
             <a:ext cx="6217920" cy="914400"/>
           </a:xfrm>
           <a:prstGeom prst="rect">
@@ -3630,7 +3679,7 @@
           <a:lstStyle/>
           <a:p>
             <a:r>
-              <a:rPr sz="2600" b="0" i="0">
+              <a:rPr sz="3000" b="0" i="0">
                 <a:solidFill>
                   <a:srgbClr val="7A7A72"/>
                 </a:solidFill>
@@ -3643,14 +3692,14 @@
       </p:sp>
       <p:sp>
         <p:nvSpPr>
-          <p:cNvPr id="7" name="TextBox 6"/>
+          <p:cNvPr id="8" name="TextBox 7"/>
           <p:cNvSpPr txBox="1"/>
           <p:nvPr/>
         </p:nvSpPr>
         <p:spPr>
           <a:xfrm>
-            <a:off x="1737360" y="5029200"/>
-            <a:ext cx="1188720" cy="914400"/>
+            <a:off x="1737360" y="4517136"/>
+            <a:ext cx="1280160" cy="914400"/>
           </a:xfrm>
           <a:prstGeom prst="rect">
             <a:avLst/>
@@ -3677,13 +3726,13 @@
       </p:sp>
       <p:sp>
         <p:nvSpPr>
-          <p:cNvPr id="8" name="TextBox 7"/>
+          <p:cNvPr id="9" name="TextBox 8"/>
           <p:cNvSpPr txBox="1"/>
           <p:nvPr/>
         </p:nvSpPr>
         <p:spPr>
           <a:xfrm>
-            <a:off x="2926080" y="5138928"/>
+            <a:off x="3063239" y="4681728"/>
             <a:ext cx="6217920" cy="914400"/>
           </a:xfrm>
           <a:prstGeom prst="rect">
@@ -3698,7 +3747,7 @@
           <a:lstStyle/>
           <a:p>
             <a:r>
-              <a:rPr sz="2600" b="0" i="0">
+              <a:rPr sz="3000" b="0" i="0">
                 <a:solidFill>
                   <a:srgbClr val="7A7A72"/>
                 </a:solidFill>
@@ -3711,14 +3760,14 @@
       </p:sp>
       <p:sp>
         <p:nvSpPr>
-          <p:cNvPr id="9" name="TextBox 8"/>
+          <p:cNvPr id="10" name="TextBox 9"/>
           <p:cNvSpPr txBox="1"/>
           <p:nvPr/>
         </p:nvSpPr>
         <p:spPr>
           <a:xfrm>
-            <a:off x="1737360" y="6172200"/>
-            <a:ext cx="1188720" cy="914400"/>
+            <a:off x="1737360" y="5577840"/>
+            <a:ext cx="1280160" cy="914400"/>
           </a:xfrm>
           <a:prstGeom prst="rect">
             <a:avLst/>
@@ -3745,13 +3794,13 @@
       </p:sp>
       <p:sp>
         <p:nvSpPr>
-          <p:cNvPr id="10" name="TextBox 9"/>
+          <p:cNvPr id="11" name="TextBox 10"/>
           <p:cNvSpPr txBox="1"/>
           <p:nvPr/>
         </p:nvSpPr>
         <p:spPr>
           <a:xfrm>
-            <a:off x="2926080" y="6281928"/>
+            <a:off x="3063239" y="5742431"/>
             <a:ext cx="6217920" cy="914400"/>
           </a:xfrm>
           <a:prstGeom prst="rect">
@@ -3766,7 +3815,7 @@
           <a:lstStyle/>
           <a:p>
             <a:r>
-              <a:rPr sz="2600" b="0" i="0">
+              <a:rPr sz="3000" b="0" i="0">
                 <a:solidFill>
                   <a:srgbClr val="7A7A72"/>
                 </a:solidFill>
@@ -3779,14 +3828,14 @@
       </p:sp>
       <p:sp>
         <p:nvSpPr>
-          <p:cNvPr id="11" name="TextBox 10"/>
+          <p:cNvPr id="12" name="TextBox 11"/>
           <p:cNvSpPr txBox="1"/>
           <p:nvPr/>
         </p:nvSpPr>
         <p:spPr>
           <a:xfrm>
-            <a:off x="1737360" y="7315200"/>
-            <a:ext cx="1188720" cy="914400"/>
+            <a:off x="1737360" y="6638544"/>
+            <a:ext cx="1280160" cy="914400"/>
           </a:xfrm>
           <a:prstGeom prst="rect">
             <a:avLst/>
@@ -3813,13 +3862,13 @@
       </p:sp>
       <p:sp>
         <p:nvSpPr>
-          <p:cNvPr id="12" name="TextBox 11"/>
+          <p:cNvPr id="13" name="TextBox 12"/>
           <p:cNvSpPr txBox="1"/>
           <p:nvPr/>
         </p:nvSpPr>
         <p:spPr>
           <a:xfrm>
-            <a:off x="2926080" y="7424927"/>
+            <a:off x="3063239" y="6803136"/>
             <a:ext cx="6217920" cy="914400"/>
           </a:xfrm>
           <a:prstGeom prst="rect">
@@ -3834,7 +3883,7 @@
           <a:lstStyle/>
           <a:p>
             <a:r>
-              <a:rPr sz="2600" b="0" i="0">
+              <a:rPr sz="3000" b="0" i="0">
                 <a:solidFill>
                   <a:srgbClr val="7A7A72"/>
                 </a:solidFill>
@@ -3847,14 +3896,14 @@
       </p:sp>
       <p:sp>
         <p:nvSpPr>
-          <p:cNvPr id="13" name="TextBox 12"/>
+          <p:cNvPr id="14" name="TextBox 13"/>
           <p:cNvSpPr txBox="1"/>
           <p:nvPr/>
         </p:nvSpPr>
         <p:spPr>
           <a:xfrm>
-            <a:off x="9692640" y="2743200"/>
-            <a:ext cx="1188720" cy="914400"/>
+            <a:off x="9701784" y="2395728"/>
+            <a:ext cx="1280160" cy="914400"/>
           </a:xfrm>
           <a:prstGeom prst="rect">
             <a:avLst/>
@@ -3881,13 +3930,13 @@
       </p:sp>
       <p:sp>
         <p:nvSpPr>
-          <p:cNvPr id="14" name="TextBox 13"/>
+          <p:cNvPr id="15" name="TextBox 14"/>
           <p:cNvSpPr txBox="1"/>
           <p:nvPr/>
         </p:nvSpPr>
         <p:spPr>
           <a:xfrm>
-            <a:off x="10881360" y="2852928"/>
+            <a:off x="11027663" y="2560320"/>
             <a:ext cx="6217920" cy="914400"/>
           </a:xfrm>
           <a:prstGeom prst="rect">
@@ -3902,7 +3951,7 @@
           <a:lstStyle/>
           <a:p>
             <a:r>
-              <a:rPr sz="2600" b="0" i="0">
+              <a:rPr sz="3000" b="0" i="0">
                 <a:solidFill>
                   <a:srgbClr val="7A7A72"/>
                 </a:solidFill>
@@ -3915,14 +3964,14 @@
       </p:sp>
       <p:sp>
         <p:nvSpPr>
-          <p:cNvPr id="15" name="TextBox 14"/>
+          <p:cNvPr id="16" name="TextBox 15"/>
           <p:cNvSpPr txBox="1"/>
           <p:nvPr/>
         </p:nvSpPr>
         <p:spPr>
           <a:xfrm>
-            <a:off x="9692640" y="3886200"/>
-            <a:ext cx="1188720" cy="914400"/>
+            <a:off x="9701784" y="3520440"/>
+            <a:ext cx="1280160" cy="914400"/>
           </a:xfrm>
           <a:prstGeom prst="rect">
             <a:avLst/>
@@ -3949,13 +3998,13 @@
       </p:sp>
       <p:sp>
         <p:nvSpPr>
-          <p:cNvPr id="16" name="TextBox 15"/>
+          <p:cNvPr id="17" name="TextBox 16"/>
           <p:cNvSpPr txBox="1"/>
           <p:nvPr/>
         </p:nvSpPr>
         <p:spPr>
           <a:xfrm>
-            <a:off x="10881360" y="3995928"/>
+            <a:off x="11027663" y="3685032"/>
             <a:ext cx="6217920" cy="914400"/>
           </a:xfrm>
           <a:prstGeom prst="rect">
@@ -3970,7 +4019,7 @@
           <a:lstStyle/>
           <a:p>
             <a:r>
-              <a:rPr sz="2600" b="0" i="0">
+              <a:rPr sz="3000" b="0" i="0">
                 <a:solidFill>
                   <a:srgbClr val="7A7A72"/>
                 </a:solidFill>
@@ -3983,14 +4032,14 @@
       </p:sp>
       <p:sp>
         <p:nvSpPr>
-          <p:cNvPr id="17" name="TextBox 16"/>
+          <p:cNvPr id="18" name="TextBox 17"/>
           <p:cNvSpPr txBox="1"/>
           <p:nvPr/>
         </p:nvSpPr>
         <p:spPr>
           <a:xfrm>
-            <a:off x="9692640" y="5029200"/>
-            <a:ext cx="1188720" cy="914400"/>
+            <a:off x="9701784" y="4645152"/>
+            <a:ext cx="1280160" cy="914400"/>
           </a:xfrm>
           <a:prstGeom prst="rect">
             <a:avLst/>
@@ -4017,13 +4066,13 @@
       </p:sp>
       <p:sp>
         <p:nvSpPr>
-          <p:cNvPr id="18" name="TextBox 17"/>
+          <p:cNvPr id="19" name="TextBox 18"/>
           <p:cNvSpPr txBox="1"/>
           <p:nvPr/>
         </p:nvSpPr>
         <p:spPr>
           <a:xfrm>
-            <a:off x="10881360" y="5138928"/>
+            <a:off x="11027663" y="4809744"/>
             <a:ext cx="6217920" cy="914400"/>
           </a:xfrm>
           <a:prstGeom prst="rect">
@@ -4038,7 +4087,7 @@
           <a:lstStyle/>
           <a:p>
             <a:r>
-              <a:rPr sz="2600" b="0" i="0">
+              <a:rPr sz="3000" b="0" i="0">
                 <a:solidFill>
                   <a:srgbClr val="7A7A72"/>
                 </a:solidFill>
@@ -4051,14 +4100,14 @@
       </p:sp>
       <p:sp>
         <p:nvSpPr>
-          <p:cNvPr id="19" name="TextBox 18"/>
+          <p:cNvPr id="20" name="TextBox 19"/>
           <p:cNvSpPr txBox="1"/>
           <p:nvPr/>
         </p:nvSpPr>
         <p:spPr>
           <a:xfrm>
-            <a:off x="9692640" y="6172200"/>
-            <a:ext cx="1188720" cy="914400"/>
+            <a:off x="9701784" y="5989320"/>
+            <a:ext cx="1280160" cy="914400"/>
           </a:xfrm>
           <a:prstGeom prst="rect">
             <a:avLst/>
@@ -4085,13 +4134,13 @@
       </p:sp>
       <p:sp>
         <p:nvSpPr>
-          <p:cNvPr id="20" name="TextBox 19"/>
+          <p:cNvPr id="21" name="TextBox 20"/>
           <p:cNvSpPr txBox="1"/>
           <p:nvPr/>
         </p:nvSpPr>
         <p:spPr>
           <a:xfrm>
-            <a:off x="10881360" y="6281928"/>
+            <a:off x="11027663" y="6153912"/>
             <a:ext cx="6217920" cy="914400"/>
           </a:xfrm>
           <a:prstGeom prst="rect">
@@ -4106,7 +4155,7 @@
           <a:lstStyle/>
           <a:p>
             <a:r>
-              <a:rPr sz="2600" b="0" i="0">
+              <a:rPr sz="3000" b="0" i="0">
                 <a:solidFill>
                   <a:srgbClr val="7A7A72"/>
                 </a:solidFill>
@@ -4119,13 +4168,13 @@
       </p:sp>
       <p:sp>
         <p:nvSpPr>
-          <p:cNvPr id="21" name="TextBox 20"/>
+          <p:cNvPr id="22" name="TextBox 21"/>
           <p:cNvSpPr txBox="1"/>
           <p:nvPr/>
         </p:nvSpPr>
         <p:spPr>
           <a:xfrm>
-            <a:off x="822960" y="9646920"/>
+            <a:off x="822960" y="9601200"/>
             <a:ext cx="10424160" cy="457200"/>
           </a:xfrm>
           <a:prstGeom prst="rect">
@@ -4169,59 +4218,30 @@
           </a:p>
         </p:txBody>
       </p:sp>
-      <p:sp>
-        <p:nvSpPr>
-          <p:cNvPr id="22" name="Rounded Rectangle 21"/>
-          <p:cNvSpPr/>
-          <p:nvPr/>
-        </p:nvSpPr>
-        <p:spPr>
-          <a:xfrm>
-            <a:off x="17007840" y="9646920"/>
-            <a:ext cx="640080" cy="411480"/>
-          </a:xfrm>
-          <a:prstGeom prst="roundRect">
-            <a:avLst/>
-          </a:prstGeom>
-          <a:solidFill>
-            <a:srgbClr val="C8BFA8"/>
-          </a:solidFill>
-          <a:ln>
-            <a:noFill/>
-          </a:ln>
-          <a:effectLst/>
-        </p:spPr>
-        <p:style>
-          <a:lnRef idx="1">
-            <a:schemeClr val="accent1"/>
-          </a:lnRef>
-          <a:fillRef idx="3">
-            <a:schemeClr val="accent1"/>
-          </a:fillRef>
-          <a:effectRef idx="2">
-            <a:schemeClr val="accent1"/>
-          </a:effectRef>
-          <a:fontRef idx="minor">
-            <a:schemeClr val="lt1"/>
-          </a:fontRef>
-        </p:style>
-        <p:txBody>
-          <a:bodyPr rtlCol="0" anchor="ctr" wrap="none"/>
-          <a:lstStyle/>
-          <a:p>
-            <a:pPr algn="ctr"/>
-            <a:r>
-              <a:rPr sz="1400" b="1" i="0">
-                <a:solidFill>
-                  <a:srgbClr val="1A1A1A"/>
-                </a:solidFill>
-                <a:latin typeface="Outfit"/>
-              </a:rPr>
-              <a:t>02</a:t>
-            </a:r>
-          </a:p>
-        </p:txBody>
-      </p:sp>
+      <p:pic>
+        <p:nvPicPr>
+          <p:cNvPr id="23" name="Picture 22" descr="logo-ka.png"/>
+          <p:cNvPicPr>
+            <a:picLocks noChangeAspect="1"/>
+          </p:cNvPicPr>
+          <p:nvPr/>
+        </p:nvPicPr>
+        <p:blipFill>
+          <a:blip r:embed="rId3"/>
+          <a:stretch>
+            <a:fillRect/>
+          </a:stretch>
+        </p:blipFill>
+        <p:spPr>
+          <a:xfrm>
+            <a:off x="16093440" y="9464040"/>
+            <a:ext cx="1737360" cy="566928"/>
+          </a:xfrm>
+          <a:prstGeom prst="rect">
+            <a:avLst/>
+          </a:prstGeom>
+        </p:spPr>
+      </p:pic>
     </p:spTree>
   </p:cSld>
   <p:clrMapOvr>
@@ -4248,50 +4268,30 @@
         <p:nvPr/>
       </p:nvGrpSpPr>
       <p:grpSpPr/>
-      <p:sp>
-        <p:nvSpPr>
-          <p:cNvPr id="2" name="Rectangle 1"/>
-          <p:cNvSpPr/>
-          <p:nvPr/>
-        </p:nvSpPr>
-        <p:spPr>
-          <a:xfrm>
-            <a:off x="11430000" y="0"/>
-            <a:ext cx="6858000" cy="10287000"/>
-          </a:xfrm>
-          <a:prstGeom prst="rect">
-            <a:avLst/>
-          </a:prstGeom>
-          <a:solidFill>
-            <a:srgbClr val="E8E4D8"/>
-          </a:solidFill>
-          <a:ln>
-            <a:noFill/>
-          </a:ln>
-          <a:effectLst/>
-        </p:spPr>
-        <p:style>
-          <a:lnRef idx="1">
-            <a:schemeClr val="accent1"/>
-          </a:lnRef>
-          <a:fillRef idx="3">
-            <a:schemeClr val="accent1"/>
-          </a:fillRef>
-          <a:effectRef idx="2">
-            <a:schemeClr val="accent1"/>
-          </a:effectRef>
-          <a:fontRef idx="minor">
-            <a:schemeClr val="lt1"/>
-          </a:fontRef>
-        </p:style>
-        <p:txBody>
-          <a:bodyPr rtlCol="0" anchor="ctr"/>
-          <a:lstStyle/>
-          <a:p>
-            <a:pPr algn="ctr"/>
-          </a:p>
-        </p:txBody>
-      </p:sp>
+      <p:pic>
+        <p:nvPicPr>
+          <p:cNvPr id="2" name="Picture 1" descr="textura-papel.jpeg"/>
+          <p:cNvPicPr>
+            <a:picLocks noChangeAspect="1"/>
+          </p:cNvPicPr>
+          <p:nvPr/>
+        </p:nvPicPr>
+        <p:blipFill>
+          <a:blip r:embed="rId2"/>
+          <a:stretch>
+            <a:fillRect/>
+          </a:stretch>
+        </p:blipFill>
+        <p:spPr>
+          <a:xfrm>
+            <a:off x="0" y="0"/>
+            <a:ext cx="18288000" cy="10287000"/>
+          </a:xfrm>
+          <a:prstGeom prst="rect">
+            <a:avLst/>
+          </a:prstGeom>
+        </p:spPr>
+      </p:pic>
       <p:sp>
         <p:nvSpPr>
           <p:cNvPr id="3" name="TextBox 2"/>
@@ -4300,8 +4300,8 @@
         </p:nvSpPr>
         <p:spPr>
           <a:xfrm>
-            <a:off x="1554480" y="3291840"/>
-            <a:ext cx="10058400" cy="3657600"/>
+            <a:off x="2313432" y="3941063"/>
+            <a:ext cx="14950440" cy="2596896"/>
           </a:xfrm>
           <a:prstGeom prst="rect">
             <a:avLst/>
@@ -4315,29 +4315,16 @@
           <a:lstStyle/>
           <a:p>
             <a:r>
-              <a:rPr sz="9200" b="1" i="0">
+              <a:rPr sz="10000" b="1" i="0">
                 <a:solidFill>
                   <a:srgbClr val="000000"/>
                 </a:solidFill>
                 <a:latin typeface="Outfit"/>
               </a:rPr>
-              <a:t>O MOMENTO</a:t>
-            </a:r>
-          </a:p>
-          <a:p>
-            <a:r>
-              <a:rPr sz="9200" b="1" i="0">
-                <a:solidFill>
-                  <a:srgbClr val="000000"/>
-                </a:solidFill>
-                <a:latin typeface="Outfit"/>
-              </a:rPr>
-              <a:t>ATUAL DA</a:t>
-            </a:r>
-          </a:p>
-          <a:p>
-            <a:r>
-              <a:rPr sz="9200" b="1" i="0">
+              <a:t>O MOMENTO ATUAL DA </a:t>
+            </a:r>
+            <a:r>
+              <a:rPr sz="10000" b="1" i="0">
                 <a:solidFill>
                   <a:srgbClr val="000000"/>
                 </a:solidFill>
@@ -4356,8 +4343,8 @@
         </p:nvSpPr>
         <p:spPr>
           <a:xfrm>
-            <a:off x="1554480" y="2468880"/>
-            <a:ext cx="10972800" cy="457200"/>
+            <a:off x="822960" y="9601200"/>
+            <a:ext cx="10424160" cy="457200"/>
           </a:xfrm>
           <a:prstGeom prst="rect">
             <a:avLst/>
@@ -4371,40 +4358,6 @@
           <a:lstStyle/>
           <a:p>
             <a:r>
-              <a:rPr sz="1650" b="0" i="0" spc="250">
-                <a:solidFill>
-                  <a:srgbClr val="7A7A72"/>
-                </a:solidFill>
-                <a:latin typeface="Outfit"/>
-              </a:rPr>
-              <a:t>SEÇÃO 01</a:t>
-            </a:r>
-          </a:p>
-        </p:txBody>
-      </p:sp>
-      <p:sp>
-        <p:nvSpPr>
-          <p:cNvPr id="5" name="TextBox 4"/>
-          <p:cNvSpPr txBox="1"/>
-          <p:nvPr/>
-        </p:nvSpPr>
-        <p:spPr>
-          <a:xfrm>
-            <a:off x="822960" y="9646920"/>
-            <a:ext cx="10424160" cy="457200"/>
-          </a:xfrm>
-          <a:prstGeom prst="rect">
-            <a:avLst/>
-          </a:prstGeom>
-          <a:noFill/>
-        </p:spPr>
-        <p:txBody>
-          <a:bodyPr wrap="square">
-            <a:spAutoFit/>
-          </a:bodyPr>
-          <a:lstStyle/>
-          <a:p>
-            <a:r>
               <a:rPr sz="1300" b="0" i="0" spc="150">
                 <a:solidFill>
                   <a:srgbClr val="000000"/>
@@ -4434,59 +4387,30 @@
           </a:p>
         </p:txBody>
       </p:sp>
-      <p:sp>
-        <p:nvSpPr>
-          <p:cNvPr id="6" name="Rounded Rectangle 5"/>
-          <p:cNvSpPr/>
-          <p:nvPr/>
-        </p:nvSpPr>
-        <p:spPr>
-          <a:xfrm>
-            <a:off x="17007840" y="9646920"/>
-            <a:ext cx="640080" cy="411480"/>
-          </a:xfrm>
-          <a:prstGeom prst="roundRect">
-            <a:avLst/>
-          </a:prstGeom>
-          <a:solidFill>
-            <a:srgbClr val="C8BFA8"/>
-          </a:solidFill>
-          <a:ln>
-            <a:noFill/>
-          </a:ln>
-          <a:effectLst/>
-        </p:spPr>
-        <p:style>
-          <a:lnRef idx="1">
-            <a:schemeClr val="accent1"/>
-          </a:lnRef>
-          <a:fillRef idx="3">
-            <a:schemeClr val="accent1"/>
-          </a:fillRef>
-          <a:effectRef idx="2">
-            <a:schemeClr val="accent1"/>
-          </a:effectRef>
-          <a:fontRef idx="minor">
-            <a:schemeClr val="lt1"/>
-          </a:fontRef>
-        </p:style>
-        <p:txBody>
-          <a:bodyPr rtlCol="0" anchor="ctr" wrap="none"/>
-          <a:lstStyle/>
-          <a:p>
-            <a:pPr algn="ctr"/>
-            <a:r>
-              <a:rPr sz="1400" b="1" i="0">
-                <a:solidFill>
-                  <a:srgbClr val="1A1A1A"/>
-                </a:solidFill>
-                <a:latin typeface="Outfit"/>
-              </a:rPr>
-              <a:t>03</a:t>
-            </a:r>
-          </a:p>
-        </p:txBody>
-      </p:sp>
+      <p:pic>
+        <p:nvPicPr>
+          <p:cNvPr id="5" name="Picture 4" descr="logo-ka.png"/>
+          <p:cNvPicPr>
+            <a:picLocks noChangeAspect="1"/>
+          </p:cNvPicPr>
+          <p:nvPr/>
+        </p:nvPicPr>
+        <p:blipFill>
+          <a:blip r:embed="rId3"/>
+          <a:stretch>
+            <a:fillRect/>
+          </a:stretch>
+        </p:blipFill>
+        <p:spPr>
+          <a:xfrm>
+            <a:off x="16093440" y="9464040"/>
+            <a:ext cx="1737360" cy="566928"/>
+          </a:xfrm>
+          <a:prstGeom prst="rect">
+            <a:avLst/>
+          </a:prstGeom>
+        </p:spPr>
+      </p:pic>
     </p:spTree>
   </p:cSld>
   <p:clrMapOvr>
@@ -4513,15 +4437,39 @@
         <p:nvPr/>
       </p:nvGrpSpPr>
       <p:grpSpPr/>
-      <p:sp>
-        <p:nvSpPr>
-          <p:cNvPr id="2" name="TextBox 1"/>
+      <p:pic>
+        <p:nvPicPr>
+          <p:cNvPr id="2" name="Picture 1" descr="textura-papel.jpeg"/>
+          <p:cNvPicPr>
+            <a:picLocks noChangeAspect="1"/>
+          </p:cNvPicPr>
+          <p:nvPr/>
+        </p:nvPicPr>
+        <p:blipFill>
+          <a:blip r:embed="rId2"/>
+          <a:stretch>
+            <a:fillRect/>
+          </a:stretch>
+        </p:blipFill>
+        <p:spPr>
+          <a:xfrm>
+            <a:off x="0" y="0"/>
+            <a:ext cx="18288000" cy="10287000"/>
+          </a:xfrm>
+          <a:prstGeom prst="rect">
+            <a:avLst/>
+          </a:prstGeom>
+        </p:spPr>
+      </p:pic>
+      <p:sp>
+        <p:nvSpPr>
+          <p:cNvPr id="3" name="TextBox 2"/>
           <p:cNvSpPr txBox="1"/>
           <p:nvPr/>
         </p:nvSpPr>
         <p:spPr>
           <a:xfrm>
-            <a:off x="1371600" y="1371600"/>
+            <a:off x="1371600" y="1188720"/>
             <a:ext cx="3657600" cy="2743200"/>
           </a:xfrm>
           <a:prstGeom prst="rect">
@@ -4549,7 +4497,7 @@
       </p:sp>
       <p:sp>
         <p:nvSpPr>
-          <p:cNvPr id="3" name="TextBox 2"/>
+          <p:cNvPr id="4" name="TextBox 3"/>
           <p:cNvSpPr txBox="1"/>
           <p:nvPr/>
         </p:nvSpPr>
@@ -4610,7 +4558,7 @@
       </p:sp>
       <p:sp>
         <p:nvSpPr>
-          <p:cNvPr id="4" name="TextBox 3"/>
+          <p:cNvPr id="5" name="TextBox 4"/>
           <p:cNvSpPr txBox="1"/>
           <p:nvPr/>
         </p:nvSpPr>
@@ -4644,13 +4592,13 @@
       </p:sp>
       <p:sp>
         <p:nvSpPr>
-          <p:cNvPr id="5" name="TextBox 4"/>
+          <p:cNvPr id="6" name="TextBox 5"/>
           <p:cNvSpPr txBox="1"/>
           <p:nvPr/>
         </p:nvSpPr>
         <p:spPr>
           <a:xfrm>
-            <a:off x="822960" y="9646920"/>
+            <a:off x="822960" y="9601200"/>
             <a:ext cx="10424160" cy="457200"/>
           </a:xfrm>
           <a:prstGeom prst="rect">
@@ -4694,59 +4642,30 @@
           </a:p>
         </p:txBody>
       </p:sp>
-      <p:sp>
-        <p:nvSpPr>
-          <p:cNvPr id="6" name="Rounded Rectangle 5"/>
-          <p:cNvSpPr/>
-          <p:nvPr/>
-        </p:nvSpPr>
-        <p:spPr>
-          <a:xfrm>
-            <a:off x="17007840" y="9646920"/>
-            <a:ext cx="640080" cy="411480"/>
-          </a:xfrm>
-          <a:prstGeom prst="roundRect">
-            <a:avLst/>
-          </a:prstGeom>
-          <a:solidFill>
-            <a:srgbClr val="C8BFA8"/>
-          </a:solidFill>
-          <a:ln>
-            <a:noFill/>
-          </a:ln>
-          <a:effectLst/>
-        </p:spPr>
-        <p:style>
-          <a:lnRef idx="1">
-            <a:schemeClr val="accent1"/>
-          </a:lnRef>
-          <a:fillRef idx="3">
-            <a:schemeClr val="accent1"/>
-          </a:fillRef>
-          <a:effectRef idx="2">
-            <a:schemeClr val="accent1"/>
-          </a:effectRef>
-          <a:fontRef idx="minor">
-            <a:schemeClr val="lt1"/>
-          </a:fontRef>
-        </p:style>
-        <p:txBody>
-          <a:bodyPr rtlCol="0" anchor="ctr" wrap="none"/>
-          <a:lstStyle/>
-          <a:p>
-            <a:pPr algn="ctr"/>
-            <a:r>
-              <a:rPr sz="1400" b="1" i="0">
-                <a:solidFill>
-                  <a:srgbClr val="1A1A1A"/>
-                </a:solidFill>
-                <a:latin typeface="Outfit"/>
-              </a:rPr>
-              <a:t>04</a:t>
-            </a:r>
-          </a:p>
-        </p:txBody>
-      </p:sp>
+      <p:pic>
+        <p:nvPicPr>
+          <p:cNvPr id="7" name="Picture 6" descr="logo-ka.png"/>
+          <p:cNvPicPr>
+            <a:picLocks noChangeAspect="1"/>
+          </p:cNvPicPr>
+          <p:nvPr/>
+        </p:nvPicPr>
+        <p:blipFill>
+          <a:blip r:embed="rId3"/>
+          <a:stretch>
+            <a:fillRect/>
+          </a:stretch>
+        </p:blipFill>
+        <p:spPr>
+          <a:xfrm>
+            <a:off x="16093440" y="9464040"/>
+            <a:ext cx="1737360" cy="566928"/>
+          </a:xfrm>
+          <a:prstGeom prst="rect">
+            <a:avLst/>
+          </a:prstGeom>
+        </p:spPr>
+      </p:pic>
     </p:spTree>
   </p:cSld>
   <p:clrMapOvr>
@@ -4773,9 +4692,33 @@
         <p:nvPr/>
       </p:nvGrpSpPr>
       <p:grpSpPr/>
-      <p:sp>
-        <p:nvSpPr>
-          <p:cNvPr id="2" name="Rectangle 1"/>
+      <p:pic>
+        <p:nvPicPr>
+          <p:cNvPr id="2" name="Picture 1" descr="textura-papel.jpeg"/>
+          <p:cNvPicPr>
+            <a:picLocks noChangeAspect="1"/>
+          </p:cNvPicPr>
+          <p:nvPr/>
+        </p:nvPicPr>
+        <p:blipFill>
+          <a:blip r:embed="rId2"/>
+          <a:stretch>
+            <a:fillRect/>
+          </a:stretch>
+        </p:blipFill>
+        <p:spPr>
+          <a:xfrm>
+            <a:off x="0" y="0"/>
+            <a:ext cx="18288000" cy="10287000"/>
+          </a:xfrm>
+          <a:prstGeom prst="rect">
+            <a:avLst/>
+          </a:prstGeom>
+        </p:spPr>
+      </p:pic>
+      <p:sp>
+        <p:nvSpPr>
+          <p:cNvPr id="3" name="Rectangle 2"/>
           <p:cNvSpPr/>
           <p:nvPr/>
         </p:nvSpPr>
@@ -4819,7 +4762,7 @@
       </p:sp>
       <p:sp>
         <p:nvSpPr>
-          <p:cNvPr id="3" name="TextBox 2"/>
+          <p:cNvPr id="4" name="TextBox 3"/>
           <p:cNvSpPr txBox="1"/>
           <p:nvPr/>
         </p:nvSpPr>
@@ -4853,7 +4796,7 @@
       </p:sp>
       <p:sp>
         <p:nvSpPr>
-          <p:cNvPr id="4" name="TextBox 3"/>
+          <p:cNvPr id="5" name="TextBox 4"/>
           <p:cNvSpPr txBox="1"/>
           <p:nvPr/>
         </p:nvSpPr>
@@ -4898,7 +4841,7 @@
       </p:sp>
       <p:sp>
         <p:nvSpPr>
-          <p:cNvPr id="5" name="TextBox 4"/>
+          <p:cNvPr id="6" name="TextBox 5"/>
           <p:cNvSpPr txBox="1"/>
           <p:nvPr/>
         </p:nvSpPr>
@@ -4954,7 +4897,7 @@
       </p:sp>
       <p:sp>
         <p:nvSpPr>
-          <p:cNvPr id="6" name="TextBox 5"/>
+          <p:cNvPr id="7" name="TextBox 6"/>
           <p:cNvSpPr txBox="1"/>
           <p:nvPr/>
         </p:nvSpPr>
@@ -4988,7 +4931,7 @@
       </p:sp>
       <p:sp>
         <p:nvSpPr>
-          <p:cNvPr id="7" name="TextBox 6"/>
+          <p:cNvPr id="8" name="TextBox 7"/>
           <p:cNvSpPr txBox="1"/>
           <p:nvPr/>
         </p:nvSpPr>
@@ -5022,13 +4965,13 @@
       </p:sp>
       <p:sp>
         <p:nvSpPr>
-          <p:cNvPr id="8" name="TextBox 7"/>
+          <p:cNvPr id="9" name="TextBox 8"/>
           <p:cNvSpPr txBox="1"/>
           <p:nvPr/>
         </p:nvSpPr>
         <p:spPr>
           <a:xfrm>
-            <a:off x="822960" y="9646920"/>
+            <a:off x="822960" y="9601200"/>
             <a:ext cx="10424160" cy="457200"/>
           </a:xfrm>
           <a:prstGeom prst="rect">
@@ -5072,59 +5015,30 @@
           </a:p>
         </p:txBody>
       </p:sp>
-      <p:sp>
-        <p:nvSpPr>
-          <p:cNvPr id="9" name="Rounded Rectangle 8"/>
-          <p:cNvSpPr/>
-          <p:nvPr/>
-        </p:nvSpPr>
-        <p:spPr>
-          <a:xfrm>
-            <a:off x="17007840" y="9646920"/>
-            <a:ext cx="640080" cy="411480"/>
-          </a:xfrm>
-          <a:prstGeom prst="roundRect">
-            <a:avLst/>
-          </a:prstGeom>
-          <a:solidFill>
-            <a:srgbClr val="C8BFA8"/>
-          </a:solidFill>
-          <a:ln>
-            <a:noFill/>
-          </a:ln>
-          <a:effectLst/>
-        </p:spPr>
-        <p:style>
-          <a:lnRef idx="1">
-            <a:schemeClr val="accent1"/>
-          </a:lnRef>
-          <a:fillRef idx="3">
-            <a:schemeClr val="accent1"/>
-          </a:fillRef>
-          <a:effectRef idx="2">
-            <a:schemeClr val="accent1"/>
-          </a:effectRef>
-          <a:fontRef idx="minor">
-            <a:schemeClr val="lt1"/>
-          </a:fontRef>
-        </p:style>
-        <p:txBody>
-          <a:bodyPr rtlCol="0" anchor="ctr" wrap="none"/>
-          <a:lstStyle/>
-          <a:p>
-            <a:pPr algn="ctr"/>
-            <a:r>
-              <a:rPr sz="1400" b="1" i="0">
-                <a:solidFill>
-                  <a:srgbClr val="1A1A1A"/>
-                </a:solidFill>
-                <a:latin typeface="Outfit"/>
-              </a:rPr>
-              <a:t>05</a:t>
-            </a:r>
-          </a:p>
-        </p:txBody>
-      </p:sp>
+      <p:pic>
+        <p:nvPicPr>
+          <p:cNvPr id="10" name="Picture 9" descr="logo-ka.png"/>
+          <p:cNvPicPr>
+            <a:picLocks noChangeAspect="1"/>
+          </p:cNvPicPr>
+          <p:nvPr/>
+        </p:nvPicPr>
+        <p:blipFill>
+          <a:blip r:embed="rId3"/>
+          <a:stretch>
+            <a:fillRect/>
+          </a:stretch>
+        </p:blipFill>
+        <p:spPr>
+          <a:xfrm>
+            <a:off x="16093440" y="9464040"/>
+            <a:ext cx="1737360" cy="566928"/>
+          </a:xfrm>
+          <a:prstGeom prst="rect">
+            <a:avLst/>
+          </a:prstGeom>
+        </p:spPr>
+      </p:pic>
     </p:spTree>
   </p:cSld>
   <p:clrMapOvr>
@@ -5151,9 +5065,33 @@
         <p:nvPr/>
       </p:nvGrpSpPr>
       <p:grpSpPr/>
-      <p:sp>
-        <p:nvSpPr>
-          <p:cNvPr id="2" name="Rectangle 1"/>
+      <p:pic>
+        <p:nvPicPr>
+          <p:cNvPr id="2" name="Picture 1" descr="textura-papel.jpeg"/>
+          <p:cNvPicPr>
+            <a:picLocks noChangeAspect="1"/>
+          </p:cNvPicPr>
+          <p:nvPr/>
+        </p:nvPicPr>
+        <p:blipFill>
+          <a:blip r:embed="rId2"/>
+          <a:stretch>
+            <a:fillRect/>
+          </a:stretch>
+        </p:blipFill>
+        <p:spPr>
+          <a:xfrm>
+            <a:off x="0" y="0"/>
+            <a:ext cx="18288000" cy="10287000"/>
+          </a:xfrm>
+          <a:prstGeom prst="rect">
+            <a:avLst/>
+          </a:prstGeom>
+        </p:spPr>
+      </p:pic>
+      <p:sp>
+        <p:nvSpPr>
+          <p:cNvPr id="3" name="Rectangle 2"/>
           <p:cNvSpPr/>
           <p:nvPr/>
         </p:nvSpPr>
@@ -5197,7 +5135,7 @@
       </p:sp>
       <p:sp>
         <p:nvSpPr>
-          <p:cNvPr id="3" name="TextBox 2"/>
+          <p:cNvPr id="4" name="TextBox 3"/>
           <p:cNvSpPr txBox="1"/>
           <p:nvPr/>
         </p:nvSpPr>
@@ -5231,7 +5169,7 @@
       </p:sp>
       <p:sp>
         <p:nvSpPr>
-          <p:cNvPr id="4" name="TextBox 3"/>
+          <p:cNvPr id="5" name="TextBox 4"/>
           <p:cNvSpPr txBox="1"/>
           <p:nvPr/>
         </p:nvSpPr>
@@ -5265,7 +5203,7 @@
       </p:sp>
       <p:sp>
         <p:nvSpPr>
-          <p:cNvPr id="5" name="TextBox 4"/>
+          <p:cNvPr id="6" name="TextBox 5"/>
           <p:cNvSpPr txBox="1"/>
           <p:nvPr/>
         </p:nvSpPr>
@@ -5368,7 +5306,7 @@
       </p:sp>
       <p:sp>
         <p:nvSpPr>
-          <p:cNvPr id="6" name="TextBox 5"/>
+          <p:cNvPr id="7" name="TextBox 6"/>
           <p:cNvSpPr txBox="1"/>
           <p:nvPr/>
         </p:nvSpPr>
@@ -5411,13 +5349,13 @@
       </p:sp>
       <p:sp>
         <p:nvSpPr>
-          <p:cNvPr id="7" name="TextBox 6"/>
+          <p:cNvPr id="8" name="TextBox 7"/>
           <p:cNvSpPr txBox="1"/>
           <p:nvPr/>
         </p:nvSpPr>
         <p:spPr>
           <a:xfrm>
-            <a:off x="822960" y="9646920"/>
+            <a:off x="822960" y="9601200"/>
             <a:ext cx="10424160" cy="457200"/>
           </a:xfrm>
           <a:prstGeom prst="rect">
@@ -5461,59 +5399,30 @@
           </a:p>
         </p:txBody>
       </p:sp>
-      <p:sp>
-        <p:nvSpPr>
-          <p:cNvPr id="8" name="Rounded Rectangle 7"/>
-          <p:cNvSpPr/>
-          <p:nvPr/>
-        </p:nvSpPr>
-        <p:spPr>
-          <a:xfrm>
-            <a:off x="17007840" y="9646920"/>
-            <a:ext cx="640080" cy="411480"/>
-          </a:xfrm>
-          <a:prstGeom prst="roundRect">
-            <a:avLst/>
-          </a:prstGeom>
-          <a:solidFill>
-            <a:srgbClr val="C8BFA8"/>
-          </a:solidFill>
-          <a:ln>
-            <a:noFill/>
-          </a:ln>
-          <a:effectLst/>
-        </p:spPr>
-        <p:style>
-          <a:lnRef idx="1">
-            <a:schemeClr val="accent1"/>
-          </a:lnRef>
-          <a:fillRef idx="3">
-            <a:schemeClr val="accent1"/>
-          </a:fillRef>
-          <a:effectRef idx="2">
-            <a:schemeClr val="accent1"/>
-          </a:effectRef>
-          <a:fontRef idx="minor">
-            <a:schemeClr val="lt1"/>
-          </a:fontRef>
-        </p:style>
-        <p:txBody>
-          <a:bodyPr rtlCol="0" anchor="ctr" wrap="none"/>
-          <a:lstStyle/>
-          <a:p>
-            <a:pPr algn="ctr"/>
-            <a:r>
-              <a:rPr sz="1400" b="1" i="0">
-                <a:solidFill>
-                  <a:srgbClr val="1A1A1A"/>
-                </a:solidFill>
-                <a:latin typeface="Outfit"/>
-              </a:rPr>
-              <a:t>06</a:t>
-            </a:r>
-          </a:p>
-        </p:txBody>
-      </p:sp>
+      <p:pic>
+        <p:nvPicPr>
+          <p:cNvPr id="9" name="Picture 8" descr="logo-ka.png"/>
+          <p:cNvPicPr>
+            <a:picLocks noChangeAspect="1"/>
+          </p:cNvPicPr>
+          <p:nvPr/>
+        </p:nvPicPr>
+        <p:blipFill>
+          <a:blip r:embed="rId3"/>
+          <a:stretch>
+            <a:fillRect/>
+          </a:stretch>
+        </p:blipFill>
+        <p:spPr>
+          <a:xfrm>
+            <a:off x="16093440" y="9464040"/>
+            <a:ext cx="1737360" cy="566928"/>
+          </a:xfrm>
+          <a:prstGeom prst="rect">
+            <a:avLst/>
+          </a:prstGeom>
+        </p:spPr>
+      </p:pic>
     </p:spTree>
   </p:cSld>
   <p:clrMapOvr>
@@ -5540,9 +5449,33 @@
         <p:nvPr/>
       </p:nvGrpSpPr>
       <p:grpSpPr/>
-      <p:sp>
-        <p:nvSpPr>
-          <p:cNvPr id="2" name="TextBox 1"/>
+      <p:pic>
+        <p:nvPicPr>
+          <p:cNvPr id="2" name="Picture 1" descr="textura-papel.jpeg"/>
+          <p:cNvPicPr>
+            <a:picLocks noChangeAspect="1"/>
+          </p:cNvPicPr>
+          <p:nvPr/>
+        </p:nvPicPr>
+        <p:blipFill>
+          <a:blip r:embed="rId2"/>
+          <a:stretch>
+            <a:fillRect/>
+          </a:stretch>
+        </p:blipFill>
+        <p:spPr>
+          <a:xfrm>
+            <a:off x="0" y="0"/>
+            <a:ext cx="18288000" cy="10287000"/>
+          </a:xfrm>
+          <a:prstGeom prst="rect">
+            <a:avLst/>
+          </a:prstGeom>
+        </p:spPr>
+      </p:pic>
+      <p:sp>
+        <p:nvSpPr>
+          <p:cNvPr id="3" name="TextBox 2"/>
           <p:cNvSpPr txBox="1"/>
           <p:nvPr/>
         </p:nvSpPr>
@@ -5576,7 +5509,7 @@
       </p:sp>
       <p:sp>
         <p:nvSpPr>
-          <p:cNvPr id="3" name="TextBox 2"/>
+          <p:cNvPr id="4" name="TextBox 3"/>
           <p:cNvSpPr txBox="1"/>
           <p:nvPr/>
         </p:nvSpPr>
@@ -5628,7 +5561,7 @@
       </p:sp>
       <p:sp>
         <p:nvSpPr>
-          <p:cNvPr id="4" name="Rectangle 3"/>
+          <p:cNvPr id="5" name="Rectangle 4"/>
           <p:cNvSpPr/>
           <p:nvPr/>
         </p:nvSpPr>
@@ -5672,7 +5605,7 @@
       </p:sp>
       <p:sp>
         <p:nvSpPr>
-          <p:cNvPr id="5" name="TextBox 4"/>
+          <p:cNvPr id="6" name="TextBox 5"/>
           <p:cNvSpPr txBox="1"/>
           <p:nvPr/>
         </p:nvSpPr>
@@ -5706,13 +5639,13 @@
       </p:sp>
       <p:sp>
         <p:nvSpPr>
-          <p:cNvPr id="6" name="TextBox 5"/>
+          <p:cNvPr id="7" name="TextBox 6"/>
           <p:cNvSpPr txBox="1"/>
           <p:nvPr/>
         </p:nvSpPr>
         <p:spPr>
           <a:xfrm>
-            <a:off x="822960" y="9646920"/>
+            <a:off x="822960" y="9601200"/>
             <a:ext cx="10424160" cy="457200"/>
           </a:xfrm>
           <a:prstGeom prst="rect">
@@ -5756,59 +5689,30 @@
           </a:p>
         </p:txBody>
       </p:sp>
-      <p:sp>
-        <p:nvSpPr>
-          <p:cNvPr id="7" name="Rounded Rectangle 6"/>
-          <p:cNvSpPr/>
-          <p:nvPr/>
-        </p:nvSpPr>
-        <p:spPr>
-          <a:xfrm>
-            <a:off x="17007840" y="9646920"/>
-            <a:ext cx="640080" cy="411480"/>
-          </a:xfrm>
-          <a:prstGeom prst="roundRect">
-            <a:avLst/>
-          </a:prstGeom>
-          <a:solidFill>
-            <a:srgbClr val="C8BFA8"/>
-          </a:solidFill>
-          <a:ln>
-            <a:noFill/>
-          </a:ln>
-          <a:effectLst/>
-        </p:spPr>
-        <p:style>
-          <a:lnRef idx="1">
-            <a:schemeClr val="accent1"/>
-          </a:lnRef>
-          <a:fillRef idx="3">
-            <a:schemeClr val="accent1"/>
-          </a:fillRef>
-          <a:effectRef idx="2">
-            <a:schemeClr val="accent1"/>
-          </a:effectRef>
-          <a:fontRef idx="minor">
-            <a:schemeClr val="lt1"/>
-          </a:fontRef>
-        </p:style>
-        <p:txBody>
-          <a:bodyPr rtlCol="0" anchor="ctr" wrap="none"/>
-          <a:lstStyle/>
-          <a:p>
-            <a:pPr algn="ctr"/>
-            <a:r>
-              <a:rPr sz="1400" b="1" i="0">
-                <a:solidFill>
-                  <a:srgbClr val="1A1A1A"/>
-                </a:solidFill>
-                <a:latin typeface="Outfit"/>
-              </a:rPr>
-              <a:t>07</a:t>
-            </a:r>
-          </a:p>
-        </p:txBody>
-      </p:sp>
+      <p:pic>
+        <p:nvPicPr>
+          <p:cNvPr id="8" name="Picture 7" descr="logo-ka.png"/>
+          <p:cNvPicPr>
+            <a:picLocks noChangeAspect="1"/>
+          </p:cNvPicPr>
+          <p:nvPr/>
+        </p:nvPicPr>
+        <p:blipFill>
+          <a:blip r:embed="rId3"/>
+          <a:stretch>
+            <a:fillRect/>
+          </a:stretch>
+        </p:blipFill>
+        <p:spPr>
+          <a:xfrm>
+            <a:off x="16093440" y="9464040"/>
+            <a:ext cx="1737360" cy="566928"/>
+          </a:xfrm>
+          <a:prstGeom prst="rect">
+            <a:avLst/>
+          </a:prstGeom>
+        </p:spPr>
+      </p:pic>
     </p:spTree>
   </p:cSld>
   <p:clrMapOvr>
@@ -5835,9 +5739,33 @@
         <p:nvPr/>
       </p:nvGrpSpPr>
       <p:grpSpPr/>
-      <p:sp>
-        <p:nvSpPr>
-          <p:cNvPr id="2" name="TextBox 1"/>
+      <p:pic>
+        <p:nvPicPr>
+          <p:cNvPr id="2" name="Picture 1" descr="textura-papel.jpeg"/>
+          <p:cNvPicPr>
+            <a:picLocks noChangeAspect="1"/>
+          </p:cNvPicPr>
+          <p:nvPr/>
+        </p:nvPicPr>
+        <p:blipFill>
+          <a:blip r:embed="rId2"/>
+          <a:stretch>
+            <a:fillRect/>
+          </a:stretch>
+        </p:blipFill>
+        <p:spPr>
+          <a:xfrm>
+            <a:off x="0" y="0"/>
+            <a:ext cx="18288000" cy="10287000"/>
+          </a:xfrm>
+          <a:prstGeom prst="rect">
+            <a:avLst/>
+          </a:prstGeom>
+        </p:spPr>
+      </p:pic>
+      <p:sp>
+        <p:nvSpPr>
+          <p:cNvPr id="3" name="TextBox 2"/>
           <p:cNvSpPr txBox="1"/>
           <p:nvPr/>
         </p:nvSpPr>
@@ -5871,7 +5799,7 @@
       </p:sp>
       <p:sp>
         <p:nvSpPr>
-          <p:cNvPr id="3" name="TextBox 2"/>
+          <p:cNvPr id="4" name="TextBox 3"/>
           <p:cNvSpPr txBox="1"/>
           <p:nvPr/>
         </p:nvSpPr>
@@ -5905,7 +5833,7 @@
       </p:sp>
       <p:sp>
         <p:nvSpPr>
-          <p:cNvPr id="4" name="Rectangle 3"/>
+          <p:cNvPr id="5" name="Rectangle 4"/>
           <p:cNvSpPr/>
           <p:nvPr/>
         </p:nvSpPr>
@@ -5949,7 +5877,7 @@
       </p:sp>
       <p:sp>
         <p:nvSpPr>
-          <p:cNvPr id="5" name="TextBox 4"/>
+          <p:cNvPr id="6" name="TextBox 5"/>
           <p:cNvSpPr txBox="1"/>
           <p:nvPr/>
         </p:nvSpPr>
@@ -6005,7 +5933,7 @@
       </p:sp>
       <p:sp>
         <p:nvSpPr>
-          <p:cNvPr id="6" name="Rectangle 5"/>
+          <p:cNvPr id="7" name="Rectangle 6"/>
           <p:cNvSpPr/>
           <p:nvPr/>
         </p:nvSpPr>
@@ -6049,7 +5977,7 @@
       </p:sp>
       <p:sp>
         <p:nvSpPr>
-          <p:cNvPr id="7" name="TextBox 6"/>
+          <p:cNvPr id="8" name="TextBox 7"/>
           <p:cNvSpPr txBox="1"/>
           <p:nvPr/>
         </p:nvSpPr>
@@ -6105,7 +6033,7 @@
       </p:sp>
       <p:sp>
         <p:nvSpPr>
-          <p:cNvPr id="8" name="Rectangle 7"/>
+          <p:cNvPr id="9" name="Rectangle 8"/>
           <p:cNvSpPr/>
           <p:nvPr/>
         </p:nvSpPr>
@@ -6149,7 +6077,7 @@
       </p:sp>
       <p:sp>
         <p:nvSpPr>
-          <p:cNvPr id="9" name="TextBox 8"/>
+          <p:cNvPr id="10" name="TextBox 9"/>
           <p:cNvSpPr txBox="1"/>
           <p:nvPr/>
         </p:nvSpPr>
@@ -6205,7 +6133,7 @@
       </p:sp>
       <p:sp>
         <p:nvSpPr>
-          <p:cNvPr id="10" name="Rectangle 9"/>
+          <p:cNvPr id="11" name="Rectangle 10"/>
           <p:cNvSpPr/>
           <p:nvPr/>
         </p:nvSpPr>
@@ -6249,7 +6177,7 @@
       </p:sp>
       <p:sp>
         <p:nvSpPr>
-          <p:cNvPr id="11" name="TextBox 10"/>
+          <p:cNvPr id="12" name="TextBox 11"/>
           <p:cNvSpPr txBox="1"/>
           <p:nvPr/>
         </p:nvSpPr>
@@ -6305,13 +6233,13 @@
       </p:sp>
       <p:sp>
         <p:nvSpPr>
-          <p:cNvPr id="12" name="TextBox 11"/>
+          <p:cNvPr id="13" name="TextBox 12"/>
           <p:cNvSpPr txBox="1"/>
           <p:nvPr/>
         </p:nvSpPr>
         <p:spPr>
           <a:xfrm>
-            <a:off x="822960" y="9646920"/>
+            <a:off x="822960" y="9601200"/>
             <a:ext cx="10424160" cy="457200"/>
           </a:xfrm>
           <a:prstGeom prst="rect">
@@ -6355,59 +6283,30 @@
           </a:p>
         </p:txBody>
       </p:sp>
-      <p:sp>
-        <p:nvSpPr>
-          <p:cNvPr id="13" name="Rounded Rectangle 12"/>
-          <p:cNvSpPr/>
-          <p:nvPr/>
-        </p:nvSpPr>
-        <p:spPr>
-          <a:xfrm>
-            <a:off x="17007840" y="9646920"/>
-            <a:ext cx="640080" cy="411480"/>
-          </a:xfrm>
-          <a:prstGeom prst="roundRect">
-            <a:avLst/>
-          </a:prstGeom>
-          <a:solidFill>
-            <a:srgbClr val="C8BFA8"/>
-          </a:solidFill>
-          <a:ln>
-            <a:noFill/>
-          </a:ln>
-          <a:effectLst/>
-        </p:spPr>
-        <p:style>
-          <a:lnRef idx="1">
-            <a:schemeClr val="accent1"/>
-          </a:lnRef>
-          <a:fillRef idx="3">
-            <a:schemeClr val="accent1"/>
-          </a:fillRef>
-          <a:effectRef idx="2">
-            <a:schemeClr val="accent1"/>
-          </a:effectRef>
-          <a:fontRef idx="minor">
-            <a:schemeClr val="lt1"/>
-          </a:fontRef>
-        </p:style>
-        <p:txBody>
-          <a:bodyPr rtlCol="0" anchor="ctr" wrap="none"/>
-          <a:lstStyle/>
-          <a:p>
-            <a:pPr algn="ctr"/>
-            <a:r>
-              <a:rPr sz="1400" b="1" i="0">
-                <a:solidFill>
-                  <a:srgbClr val="1A1A1A"/>
-                </a:solidFill>
-                <a:latin typeface="Outfit"/>
-              </a:rPr>
-              <a:t>08</a:t>
-            </a:r>
-          </a:p>
-        </p:txBody>
-      </p:sp>
+      <p:pic>
+        <p:nvPicPr>
+          <p:cNvPr id="14" name="Picture 13" descr="logo-ka.png"/>
+          <p:cNvPicPr>
+            <a:picLocks noChangeAspect="1"/>
+          </p:cNvPicPr>
+          <p:nvPr/>
+        </p:nvPicPr>
+        <p:blipFill>
+          <a:blip r:embed="rId3"/>
+          <a:stretch>
+            <a:fillRect/>
+          </a:stretch>
+        </p:blipFill>
+        <p:spPr>
+          <a:xfrm>
+            <a:off x="16093440" y="9464040"/>
+            <a:ext cx="1737360" cy="566928"/>
+          </a:xfrm>
+          <a:prstGeom prst="rect">
+            <a:avLst/>
+          </a:prstGeom>
+        </p:spPr>
+      </p:pic>
     </p:spTree>
   </p:cSld>
   <p:clrMapOvr>
@@ -6434,9 +6333,33 @@
         <p:nvPr/>
       </p:nvGrpSpPr>
       <p:grpSpPr/>
-      <p:sp>
-        <p:nvSpPr>
-          <p:cNvPr id="2" name="TextBox 1"/>
+      <p:pic>
+        <p:nvPicPr>
+          <p:cNvPr id="2" name="Picture 1" descr="textura-papel.jpeg"/>
+          <p:cNvPicPr>
+            <a:picLocks noChangeAspect="1"/>
+          </p:cNvPicPr>
+          <p:nvPr/>
+        </p:nvPicPr>
+        <p:blipFill>
+          <a:blip r:embed="rId2"/>
+          <a:stretch>
+            <a:fillRect/>
+          </a:stretch>
+        </p:blipFill>
+        <p:spPr>
+          <a:xfrm>
+            <a:off x="0" y="0"/>
+            <a:ext cx="18288000" cy="10287000"/>
+          </a:xfrm>
+          <a:prstGeom prst="rect">
+            <a:avLst/>
+          </a:prstGeom>
+        </p:spPr>
+      </p:pic>
+      <p:sp>
+        <p:nvSpPr>
+          <p:cNvPr id="3" name="TextBox 2"/>
           <p:cNvSpPr txBox="1"/>
           <p:nvPr/>
         </p:nvSpPr>
@@ -6470,7 +6393,7 @@
       </p:sp>
       <p:sp>
         <p:nvSpPr>
-          <p:cNvPr id="3" name="TextBox 2"/>
+          <p:cNvPr id="4" name="TextBox 3"/>
           <p:cNvSpPr txBox="1"/>
           <p:nvPr/>
         </p:nvSpPr>
@@ -6504,7 +6427,7 @@
       </p:sp>
       <p:sp>
         <p:nvSpPr>
-          <p:cNvPr id="4" name="Rectangle 3"/>
+          <p:cNvPr id="5" name="Rectangle 4"/>
           <p:cNvSpPr/>
           <p:nvPr/>
         </p:nvSpPr>
@@ -6548,7 +6471,7 @@
       </p:sp>
       <p:sp>
         <p:nvSpPr>
-          <p:cNvPr id="5" name="TextBox 4"/>
+          <p:cNvPr id="6" name="TextBox 5"/>
           <p:cNvSpPr txBox="1"/>
           <p:nvPr/>
         </p:nvSpPr>
@@ -6582,7 +6505,7 @@
       </p:sp>
       <p:sp>
         <p:nvSpPr>
-          <p:cNvPr id="6" name="TextBox 5"/>
+          <p:cNvPr id="7" name="TextBox 6"/>
           <p:cNvSpPr txBox="1"/>
           <p:nvPr/>
         </p:nvSpPr>
@@ -6660,7 +6583,7 @@
       </p:sp>
       <p:sp>
         <p:nvSpPr>
-          <p:cNvPr id="7" name="Rectangle 6"/>
+          <p:cNvPr id="8" name="Rectangle 7"/>
           <p:cNvSpPr/>
           <p:nvPr/>
         </p:nvSpPr>
@@ -6704,7 +6627,7 @@
       </p:sp>
       <p:sp>
         <p:nvSpPr>
-          <p:cNvPr id="8" name="TextBox 7"/>
+          <p:cNvPr id="9" name="TextBox 8"/>
           <p:cNvSpPr txBox="1"/>
           <p:nvPr/>
         </p:nvSpPr>
@@ -6738,7 +6661,7 @@
       </p:sp>
       <p:sp>
         <p:nvSpPr>
-          <p:cNvPr id="9" name="TextBox 8"/>
+          <p:cNvPr id="10" name="TextBox 9"/>
           <p:cNvSpPr txBox="1"/>
           <p:nvPr/>
         </p:nvSpPr>
@@ -6816,13 +6739,13 @@
       </p:sp>
       <p:sp>
         <p:nvSpPr>
-          <p:cNvPr id="10" name="TextBox 9"/>
+          <p:cNvPr id="11" name="TextBox 10"/>
           <p:cNvSpPr txBox="1"/>
           <p:nvPr/>
         </p:nvSpPr>
         <p:spPr>
           <a:xfrm>
-            <a:off x="822960" y="9646920"/>
+            <a:off x="822960" y="9601200"/>
             <a:ext cx="10424160" cy="457200"/>
           </a:xfrm>
           <a:prstGeom prst="rect">
@@ -6866,59 +6789,30 @@
           </a:p>
         </p:txBody>
       </p:sp>
-      <p:sp>
-        <p:nvSpPr>
-          <p:cNvPr id="11" name="Rounded Rectangle 10"/>
-          <p:cNvSpPr/>
-          <p:nvPr/>
-        </p:nvSpPr>
-        <p:spPr>
-          <a:xfrm>
-            <a:off x="17007840" y="9646920"/>
-            <a:ext cx="640080" cy="411480"/>
-          </a:xfrm>
-          <a:prstGeom prst="roundRect">
-            <a:avLst/>
-          </a:prstGeom>
-          <a:solidFill>
-            <a:srgbClr val="C8BFA8"/>
-          </a:solidFill>
-          <a:ln>
-            <a:noFill/>
-          </a:ln>
-          <a:effectLst/>
-        </p:spPr>
-        <p:style>
-          <a:lnRef idx="1">
-            <a:schemeClr val="accent1"/>
-          </a:lnRef>
-          <a:fillRef idx="3">
-            <a:schemeClr val="accent1"/>
-          </a:fillRef>
-          <a:effectRef idx="2">
-            <a:schemeClr val="accent1"/>
-          </a:effectRef>
-          <a:fontRef idx="minor">
-            <a:schemeClr val="lt1"/>
-          </a:fontRef>
-        </p:style>
-        <p:txBody>
-          <a:bodyPr rtlCol="0" anchor="ctr" wrap="none"/>
-          <a:lstStyle/>
-          <a:p>
-            <a:pPr algn="ctr"/>
-            <a:r>
-              <a:rPr sz="1400" b="1" i="0">
-                <a:solidFill>
-                  <a:srgbClr val="1A1A1A"/>
-                </a:solidFill>
-                <a:latin typeface="Outfit"/>
-              </a:rPr>
-              <a:t>09</a:t>
-            </a:r>
-          </a:p>
-        </p:txBody>
-      </p:sp>
+      <p:pic>
+        <p:nvPicPr>
+          <p:cNvPr id="12" name="Picture 11" descr="logo-ka.png"/>
+          <p:cNvPicPr>
+            <a:picLocks noChangeAspect="1"/>
+          </p:cNvPicPr>
+          <p:nvPr/>
+        </p:nvPicPr>
+        <p:blipFill>
+          <a:blip r:embed="rId3"/>
+          <a:stretch>
+            <a:fillRect/>
+          </a:stretch>
+        </p:blipFill>
+        <p:spPr>
+          <a:xfrm>
+            <a:off x="16093440" y="9464040"/>
+            <a:ext cx="1737360" cy="566928"/>
+          </a:xfrm>
+          <a:prstGeom prst="rect">
+            <a:avLst/>
+          </a:prstGeom>
+        </p:spPr>
+      </p:pic>
     </p:spTree>
   </p:cSld>
   <p:clrMapOvr>

</xml_diff>

<commit_message>
Aplica fundo cinza apenas nos divisores de tema
Capa, sumário e demais slides voltam ao fundo gelo (#F6F5F0); a textura
cinza fica restrita às páginas que separam grandes temas, conforme o
padrão do original.

https://claude.ai/code/session_01ESkoLizKf58nxwpm6ofywL
</commit_message>
<xml_diff>
--- a/MODELO-BASE-ESTRATEGICA.pptx
+++ b/MODELO-BASE-ESTRATEGICA.pptx
@@ -3107,7 +3107,7 @@
       <p:grpSpPr/>
       <p:pic>
         <p:nvPicPr>
-          <p:cNvPr id="2" name="Picture 1" descr="textura-papel.jpeg"/>
+          <p:cNvPr id="2" name="Picture 1" descr="logo-ka.png"/>
           <p:cNvPicPr>
             <a:picLocks noChangeAspect="1"/>
           </p:cNvPicPr>
@@ -3121,17 +3121,62 @@
         </p:blipFill>
         <p:spPr>
           <a:xfrm>
-            <a:off x="0" y="0"/>
-            <a:ext cx="18288000" cy="10287000"/>
+            <a:off x="365760" y="274320"/>
+            <a:ext cx="2926080" cy="914400"/>
           </a:xfrm>
           <a:prstGeom prst="rect">
             <a:avLst/>
           </a:prstGeom>
         </p:spPr>
       </p:pic>
+      <p:sp>
+        <p:nvSpPr>
+          <p:cNvPr id="3" name="TextBox 2"/>
+          <p:cNvSpPr txBox="1"/>
+          <p:nvPr/>
+        </p:nvSpPr>
+        <p:spPr>
+          <a:xfrm>
+            <a:off x="1536192" y="3593592"/>
+            <a:ext cx="11155680" cy="2194560"/>
+          </a:xfrm>
+          <a:prstGeom prst="rect">
+            <a:avLst/>
+          </a:prstGeom>
+          <a:noFill/>
+        </p:spPr>
+        <p:txBody>
+          <a:bodyPr wrap="square">
+            <a:spAutoFit/>
+          </a:bodyPr>
+          <a:lstStyle/>
+          <a:p>
+            <a:r>
+              <a:rPr sz="7500" b="1" i="0">
+                <a:solidFill>
+                  <a:srgbClr val="000000"/>
+                </a:solidFill>
+                <a:latin typeface="Outfit"/>
+              </a:rPr>
+              <a:t>BASE ESTRATÉGICA DA MARCA</a:t>
+            </a:r>
+          </a:p>
+          <a:p>
+            <a:r>
+              <a:rPr sz="7500" b="1" i="0" spc="100">
+                <a:solidFill>
+                  <a:srgbClr val="000000"/>
+                </a:solidFill>
+                <a:latin typeface="Outfit"/>
+              </a:rPr>
+              <a:t>YUFIL</a:t>
+            </a:r>
+          </a:p>
+        </p:txBody>
+      </p:sp>
       <p:pic>
         <p:nvPicPr>
-          <p:cNvPr id="3" name="Picture 2" descr="logo-ka.png"/>
+          <p:cNvPr id="4" name="Picture 3" descr="traco.png"/>
           <p:cNvPicPr>
             <a:picLocks noChangeAspect="1"/>
           </p:cNvPicPr>
@@ -3145,8 +3190,8 @@
         </p:blipFill>
         <p:spPr>
           <a:xfrm>
-            <a:off x="365760" y="274320"/>
-            <a:ext cx="2926080" cy="914400"/>
+            <a:off x="11951208" y="3776472"/>
+            <a:ext cx="1490472" cy="1773936"/>
           </a:xfrm>
           <a:prstGeom prst="rect">
             <a:avLst/>
@@ -3155,14 +3200,14 @@
       </p:pic>
       <p:sp>
         <p:nvSpPr>
-          <p:cNvPr id="4" name="TextBox 3"/>
+          <p:cNvPr id="5" name="TextBox 4"/>
           <p:cNvSpPr txBox="1"/>
           <p:nvPr/>
         </p:nvSpPr>
         <p:spPr>
           <a:xfrm>
-            <a:off x="1536192" y="3593592"/>
-            <a:ext cx="11155680" cy="2194560"/>
+            <a:off x="1536192" y="5824728"/>
+            <a:ext cx="11887200" cy="822960"/>
           </a:xfrm>
           <a:prstGeom prst="rect">
             <a:avLst/>
@@ -3176,98 +3221,29 @@
           <a:lstStyle/>
           <a:p>
             <a:r>
-              <a:rPr sz="7500" b="1" i="0">
-                <a:solidFill>
-                  <a:srgbClr val="000000"/>
-                </a:solidFill>
-                <a:latin typeface="Outfit"/>
-              </a:rPr>
-              <a:t>BASE ESTRATÉGICA DA MARCA</a:t>
-            </a:r>
-          </a:p>
-          <a:p>
-            <a:r>
-              <a:rPr sz="7500" b="1" i="0" spc="100">
-                <a:solidFill>
-                  <a:srgbClr val="000000"/>
-                </a:solidFill>
-                <a:latin typeface="Outfit"/>
-              </a:rPr>
-              <a:t>YUFIL</a:t>
-            </a:r>
-          </a:p>
-        </p:txBody>
-      </p:sp>
-      <p:pic>
-        <p:nvPicPr>
-          <p:cNvPr id="5" name="Picture 4" descr="traco.png"/>
-          <p:cNvPicPr>
-            <a:picLocks noChangeAspect="1"/>
-          </p:cNvPicPr>
-          <p:nvPr/>
-        </p:nvPicPr>
-        <p:blipFill>
-          <a:blip r:embed="rId4"/>
-          <a:stretch>
-            <a:fillRect/>
-          </a:stretch>
-        </p:blipFill>
-        <p:spPr>
-          <a:xfrm>
-            <a:off x="11951208" y="3776472"/>
-            <a:ext cx="1490472" cy="1773936"/>
-          </a:xfrm>
-          <a:prstGeom prst="rect">
-            <a:avLst/>
-          </a:prstGeom>
-        </p:spPr>
-      </p:pic>
+              <a:rPr sz="3000" b="0" i="0">
+                <a:solidFill>
+                  <a:srgbClr val="1A1A1A"/>
+                </a:solidFill>
+                <a:latin typeface="Outfit"/>
+              </a:rPr>
+              <a:t>Construção estratégica para </a:t>
+            </a:r>
+            <a:r>
+              <a:rPr sz="3000" b="1" i="0">
+                <a:solidFill>
+                  <a:srgbClr val="1A1A1A"/>
+                </a:solidFill>
+                <a:latin typeface="Outfit"/>
+              </a:rPr>
+              <a:t>clareza, consistência e expansão.</a:t>
+            </a:r>
+          </a:p>
+        </p:txBody>
+      </p:sp>
       <p:sp>
         <p:nvSpPr>
           <p:cNvPr id="6" name="TextBox 5"/>
-          <p:cNvSpPr txBox="1"/>
-          <p:nvPr/>
-        </p:nvSpPr>
-        <p:spPr>
-          <a:xfrm>
-            <a:off x="1536192" y="5824728"/>
-            <a:ext cx="11887200" cy="822960"/>
-          </a:xfrm>
-          <a:prstGeom prst="rect">
-            <a:avLst/>
-          </a:prstGeom>
-          <a:noFill/>
-        </p:spPr>
-        <p:txBody>
-          <a:bodyPr wrap="square">
-            <a:spAutoFit/>
-          </a:bodyPr>
-          <a:lstStyle/>
-          <a:p>
-            <a:r>
-              <a:rPr sz="3000" b="0" i="0">
-                <a:solidFill>
-                  <a:srgbClr val="1A1A1A"/>
-                </a:solidFill>
-                <a:latin typeface="Outfit"/>
-              </a:rPr>
-              <a:t>Construção estratégica para </a:t>
-            </a:r>
-            <a:r>
-              <a:rPr sz="3000" b="1" i="0">
-                <a:solidFill>
-                  <a:srgbClr val="1A1A1A"/>
-                </a:solidFill>
-                <a:latin typeface="Outfit"/>
-              </a:rPr>
-              <a:t>clareza, consistência e expansão.</a:t>
-            </a:r>
-          </a:p>
-        </p:txBody>
-      </p:sp>
-      <p:sp>
-        <p:nvSpPr>
-          <p:cNvPr id="7" name="TextBox 6"/>
           <p:cNvSpPr txBox="1"/>
           <p:nvPr/>
         </p:nvSpPr>
@@ -3354,9 +3330,77 @@
         <p:nvPr/>
       </p:nvGrpSpPr>
       <p:grpSpPr/>
+      <p:sp>
+        <p:nvSpPr>
+          <p:cNvPr id="2" name="TextBox 1"/>
+          <p:cNvSpPr txBox="1"/>
+          <p:nvPr/>
+        </p:nvSpPr>
+        <p:spPr>
+          <a:xfrm>
+            <a:off x="1554480" y="3657600"/>
+            <a:ext cx="14630400" cy="1828800"/>
+          </a:xfrm>
+          <a:prstGeom prst="rect">
+            <a:avLst/>
+          </a:prstGeom>
+          <a:noFill/>
+        </p:spPr>
+        <p:txBody>
+          <a:bodyPr wrap="square">
+            <a:spAutoFit/>
+          </a:bodyPr>
+          <a:lstStyle/>
+          <a:p>
+            <a:r>
+              <a:rPr sz="7000" b="0" i="0">
+                <a:solidFill>
+                  <a:srgbClr val="000000"/>
+                </a:solidFill>
+                <a:latin typeface="Outfit"/>
+              </a:rPr>
+              <a:t>MUITO OBRIGADA!</a:t>
+            </a:r>
+          </a:p>
+        </p:txBody>
+      </p:sp>
+      <p:sp>
+        <p:nvSpPr>
+          <p:cNvPr id="3" name="TextBox 2"/>
+          <p:cNvSpPr txBox="1"/>
+          <p:nvPr/>
+        </p:nvSpPr>
+        <p:spPr>
+          <a:xfrm>
+            <a:off x="1554480" y="5669280"/>
+            <a:ext cx="12801600" cy="1371600"/>
+          </a:xfrm>
+          <a:prstGeom prst="rect">
+            <a:avLst/>
+          </a:prstGeom>
+          <a:noFill/>
+        </p:spPr>
+        <p:txBody>
+          <a:bodyPr wrap="square">
+            <a:spAutoFit/>
+          </a:bodyPr>
+          <a:lstStyle/>
+          <a:p>
+            <a:r>
+              <a:rPr sz="3000" b="0" i="0">
+                <a:solidFill>
+                  <a:srgbClr val="1A1A1A"/>
+                </a:solidFill>
+                <a:latin typeface="Outfit"/>
+              </a:rPr>
+              <a:t>Aplicando os conteúdos deste documento na prática, você garante uma marca construída com consistência e clareza.</a:t>
+            </a:r>
+          </a:p>
+        </p:txBody>
+      </p:sp>
       <p:pic>
         <p:nvPicPr>
-          <p:cNvPr id="2" name="Picture 1" descr="textura-papel.jpeg"/>
+          <p:cNvPr id="4" name="Picture 3" descr="logo-ka.png"/>
           <p:cNvPicPr>
             <a:picLocks noChangeAspect="1"/>
           </p:cNvPicPr>
@@ -3364,98 +3408,6 @@
         </p:nvPicPr>
         <p:blipFill>
           <a:blip r:embed="rId2"/>
-          <a:stretch>
-            <a:fillRect/>
-          </a:stretch>
-        </p:blipFill>
-        <p:spPr>
-          <a:xfrm>
-            <a:off x="0" y="0"/>
-            <a:ext cx="18288000" cy="10287000"/>
-          </a:xfrm>
-          <a:prstGeom prst="rect">
-            <a:avLst/>
-          </a:prstGeom>
-        </p:spPr>
-      </p:pic>
-      <p:sp>
-        <p:nvSpPr>
-          <p:cNvPr id="3" name="TextBox 2"/>
-          <p:cNvSpPr txBox="1"/>
-          <p:nvPr/>
-        </p:nvSpPr>
-        <p:spPr>
-          <a:xfrm>
-            <a:off x="1554480" y="3657600"/>
-            <a:ext cx="14630400" cy="1828800"/>
-          </a:xfrm>
-          <a:prstGeom prst="rect">
-            <a:avLst/>
-          </a:prstGeom>
-          <a:noFill/>
-        </p:spPr>
-        <p:txBody>
-          <a:bodyPr wrap="square">
-            <a:spAutoFit/>
-          </a:bodyPr>
-          <a:lstStyle/>
-          <a:p>
-            <a:r>
-              <a:rPr sz="7000" b="0" i="0">
-                <a:solidFill>
-                  <a:srgbClr val="000000"/>
-                </a:solidFill>
-                <a:latin typeface="Outfit"/>
-              </a:rPr>
-              <a:t>MUITO OBRIGADA!</a:t>
-            </a:r>
-          </a:p>
-        </p:txBody>
-      </p:sp>
-      <p:sp>
-        <p:nvSpPr>
-          <p:cNvPr id="4" name="TextBox 3"/>
-          <p:cNvSpPr txBox="1"/>
-          <p:nvPr/>
-        </p:nvSpPr>
-        <p:spPr>
-          <a:xfrm>
-            <a:off x="1554480" y="5669280"/>
-            <a:ext cx="12801600" cy="1371600"/>
-          </a:xfrm>
-          <a:prstGeom prst="rect">
-            <a:avLst/>
-          </a:prstGeom>
-          <a:noFill/>
-        </p:spPr>
-        <p:txBody>
-          <a:bodyPr wrap="square">
-            <a:spAutoFit/>
-          </a:bodyPr>
-          <a:lstStyle/>
-          <a:p>
-            <a:r>
-              <a:rPr sz="3000" b="0" i="0">
-                <a:solidFill>
-                  <a:srgbClr val="1A1A1A"/>
-                </a:solidFill>
-                <a:latin typeface="Outfit"/>
-              </a:rPr>
-              <a:t>Aplicando os conteúdos deste documento na prática, você garante uma marca construída com consistência e clareza.</a:t>
-            </a:r>
-          </a:p>
-        </p:txBody>
-      </p:sp>
-      <p:pic>
-        <p:nvPicPr>
-          <p:cNvPr id="5" name="Picture 4" descr="logo-ka.png"/>
-          <p:cNvPicPr>
-            <a:picLocks noChangeAspect="1"/>
-          </p:cNvPicPr>
-          <p:nvPr/>
-        </p:nvPicPr>
-        <p:blipFill>
-          <a:blip r:embed="rId3"/>
           <a:stretch>
             <a:fillRect/>
           </a:stretch>
@@ -3496,9 +3448,707 @@
         <p:nvPr/>
       </p:nvGrpSpPr>
       <p:grpSpPr/>
+      <p:sp>
+        <p:nvSpPr>
+          <p:cNvPr id="2" name="TextBox 1"/>
+          <p:cNvSpPr txBox="1"/>
+          <p:nvPr/>
+        </p:nvSpPr>
+        <p:spPr>
+          <a:xfrm>
+            <a:off x="1737360" y="822960"/>
+            <a:ext cx="9144000" cy="1463040"/>
+          </a:xfrm>
+          <a:prstGeom prst="rect">
+            <a:avLst/>
+          </a:prstGeom>
+          <a:noFill/>
+        </p:spPr>
+        <p:txBody>
+          <a:bodyPr wrap="square">
+            <a:spAutoFit/>
+          </a:bodyPr>
+          <a:lstStyle/>
+          <a:p>
+            <a:r>
+              <a:rPr sz="7800" b="1" i="0">
+                <a:solidFill>
+                  <a:srgbClr val="000000"/>
+                </a:solidFill>
+                <a:latin typeface="Outfit"/>
+              </a:rPr>
+              <a:t>SUMÁRIO</a:t>
+            </a:r>
+          </a:p>
+        </p:txBody>
+      </p:sp>
+      <p:sp>
+        <p:nvSpPr>
+          <p:cNvPr id="3" name="TextBox 2"/>
+          <p:cNvSpPr txBox="1"/>
+          <p:nvPr/>
+        </p:nvSpPr>
+        <p:spPr>
+          <a:xfrm>
+            <a:off x="1737360" y="2395728"/>
+            <a:ext cx="1280160" cy="914400"/>
+          </a:xfrm>
+          <a:prstGeom prst="rect">
+            <a:avLst/>
+          </a:prstGeom>
+          <a:noFill/>
+        </p:spPr>
+        <p:txBody>
+          <a:bodyPr wrap="square">
+            <a:spAutoFit/>
+          </a:bodyPr>
+          <a:lstStyle/>
+          <a:p>
+            <a:r>
+              <a:rPr sz="4300" b="1" i="0">
+                <a:solidFill>
+                  <a:srgbClr val="1A1A1A"/>
+                </a:solidFill>
+                <a:latin typeface="Outfit"/>
+              </a:rPr>
+              <a:t>01</a:t>
+            </a:r>
+          </a:p>
+        </p:txBody>
+      </p:sp>
+      <p:sp>
+        <p:nvSpPr>
+          <p:cNvPr id="4" name="TextBox 3"/>
+          <p:cNvSpPr txBox="1"/>
+          <p:nvPr/>
+        </p:nvSpPr>
+        <p:spPr>
+          <a:xfrm>
+            <a:off x="3063239" y="2560320"/>
+            <a:ext cx="6217920" cy="914400"/>
+          </a:xfrm>
+          <a:prstGeom prst="rect">
+            <a:avLst/>
+          </a:prstGeom>
+          <a:noFill/>
+        </p:spPr>
+        <p:txBody>
+          <a:bodyPr wrap="square">
+            <a:spAutoFit/>
+          </a:bodyPr>
+          <a:lstStyle/>
+          <a:p>
+            <a:r>
+              <a:rPr sz="3000" b="0" i="0">
+                <a:solidFill>
+                  <a:srgbClr val="7A7A72"/>
+                </a:solidFill>
+                <a:latin typeface="Outfit"/>
+              </a:rPr>
+              <a:t>Leitura do momento da marca</a:t>
+            </a:r>
+          </a:p>
+        </p:txBody>
+      </p:sp>
+      <p:sp>
+        <p:nvSpPr>
+          <p:cNvPr id="5" name="TextBox 4"/>
+          <p:cNvSpPr txBox="1"/>
+          <p:nvPr/>
+        </p:nvSpPr>
+        <p:spPr>
+          <a:xfrm>
+            <a:off x="1737360" y="3456432"/>
+            <a:ext cx="1280160" cy="914400"/>
+          </a:xfrm>
+          <a:prstGeom prst="rect">
+            <a:avLst/>
+          </a:prstGeom>
+          <a:noFill/>
+        </p:spPr>
+        <p:txBody>
+          <a:bodyPr wrap="square">
+            <a:spAutoFit/>
+          </a:bodyPr>
+          <a:lstStyle/>
+          <a:p>
+            <a:r>
+              <a:rPr sz="4300" b="1" i="0">
+                <a:solidFill>
+                  <a:srgbClr val="1A1A1A"/>
+                </a:solidFill>
+                <a:latin typeface="Outfit"/>
+              </a:rPr>
+              <a:t>02</a:t>
+            </a:r>
+          </a:p>
+        </p:txBody>
+      </p:sp>
+      <p:sp>
+        <p:nvSpPr>
+          <p:cNvPr id="6" name="TextBox 5"/>
+          <p:cNvSpPr txBox="1"/>
+          <p:nvPr/>
+        </p:nvSpPr>
+        <p:spPr>
+          <a:xfrm>
+            <a:off x="3063239" y="3621024"/>
+            <a:ext cx="6217920" cy="914400"/>
+          </a:xfrm>
+          <a:prstGeom prst="rect">
+            <a:avLst/>
+          </a:prstGeom>
+          <a:noFill/>
+        </p:spPr>
+        <p:txBody>
+          <a:bodyPr wrap="square">
+            <a:spAutoFit/>
+          </a:bodyPr>
+          <a:lstStyle/>
+          <a:p>
+            <a:r>
+              <a:rPr sz="3000" b="0" i="0">
+                <a:solidFill>
+                  <a:srgbClr val="7A7A72"/>
+                </a:solidFill>
+                <a:latin typeface="Outfit"/>
+              </a:rPr>
+              <a:t>Definição central da marca</a:t>
+            </a:r>
+          </a:p>
+        </p:txBody>
+      </p:sp>
+      <p:sp>
+        <p:nvSpPr>
+          <p:cNvPr id="7" name="TextBox 6"/>
+          <p:cNvSpPr txBox="1"/>
+          <p:nvPr/>
+        </p:nvSpPr>
+        <p:spPr>
+          <a:xfrm>
+            <a:off x="1737360" y="4517136"/>
+            <a:ext cx="1280160" cy="914400"/>
+          </a:xfrm>
+          <a:prstGeom prst="rect">
+            <a:avLst/>
+          </a:prstGeom>
+          <a:noFill/>
+        </p:spPr>
+        <p:txBody>
+          <a:bodyPr wrap="square">
+            <a:spAutoFit/>
+          </a:bodyPr>
+          <a:lstStyle/>
+          <a:p>
+            <a:r>
+              <a:rPr sz="4300" b="1" i="0">
+                <a:solidFill>
+                  <a:srgbClr val="1A1A1A"/>
+                </a:solidFill>
+                <a:latin typeface="Outfit"/>
+              </a:rPr>
+              <a:t>03</a:t>
+            </a:r>
+          </a:p>
+        </p:txBody>
+      </p:sp>
+      <p:sp>
+        <p:nvSpPr>
+          <p:cNvPr id="8" name="TextBox 7"/>
+          <p:cNvSpPr txBox="1"/>
+          <p:nvPr/>
+        </p:nvSpPr>
+        <p:spPr>
+          <a:xfrm>
+            <a:off x="3063239" y="4681728"/>
+            <a:ext cx="6217920" cy="914400"/>
+          </a:xfrm>
+          <a:prstGeom prst="rect">
+            <a:avLst/>
+          </a:prstGeom>
+          <a:noFill/>
+        </p:spPr>
+        <p:txBody>
+          <a:bodyPr wrap="square">
+            <a:spAutoFit/>
+          </a:bodyPr>
+          <a:lstStyle/>
+          <a:p>
+            <a:r>
+              <a:rPr sz="3000" b="0" i="0">
+                <a:solidFill>
+                  <a:srgbClr val="7A7A72"/>
+                </a:solidFill>
+                <a:latin typeface="Outfit"/>
+              </a:rPr>
+              <a:t>Causa, liderança e tribo</a:t>
+            </a:r>
+          </a:p>
+        </p:txBody>
+      </p:sp>
+      <p:sp>
+        <p:nvSpPr>
+          <p:cNvPr id="9" name="TextBox 8"/>
+          <p:cNvSpPr txBox="1"/>
+          <p:nvPr/>
+        </p:nvSpPr>
+        <p:spPr>
+          <a:xfrm>
+            <a:off x="1737360" y="5577840"/>
+            <a:ext cx="1280160" cy="914400"/>
+          </a:xfrm>
+          <a:prstGeom prst="rect">
+            <a:avLst/>
+          </a:prstGeom>
+          <a:noFill/>
+        </p:spPr>
+        <p:txBody>
+          <a:bodyPr wrap="square">
+            <a:spAutoFit/>
+          </a:bodyPr>
+          <a:lstStyle/>
+          <a:p>
+            <a:r>
+              <a:rPr sz="4300" b="1" i="0">
+                <a:solidFill>
+                  <a:srgbClr val="1A1A1A"/>
+                </a:solidFill>
+                <a:latin typeface="Outfit"/>
+              </a:rPr>
+              <a:t>04</a:t>
+            </a:r>
+          </a:p>
+        </p:txBody>
+      </p:sp>
+      <p:sp>
+        <p:nvSpPr>
+          <p:cNvPr id="10" name="TextBox 9"/>
+          <p:cNvSpPr txBox="1"/>
+          <p:nvPr/>
+        </p:nvSpPr>
+        <p:spPr>
+          <a:xfrm>
+            <a:off x="3063239" y="5742431"/>
+            <a:ext cx="6217920" cy="914400"/>
+          </a:xfrm>
+          <a:prstGeom prst="rect">
+            <a:avLst/>
+          </a:prstGeom>
+          <a:noFill/>
+        </p:spPr>
+        <p:txBody>
+          <a:bodyPr wrap="square">
+            <a:spAutoFit/>
+          </a:bodyPr>
+          <a:lstStyle/>
+          <a:p>
+            <a:r>
+              <a:rPr sz="3000" b="0" i="0">
+                <a:solidFill>
+                  <a:srgbClr val="7A7A72"/>
+                </a:solidFill>
+                <a:latin typeface="Outfit"/>
+              </a:rPr>
+              <a:t>Golden Circle</a:t>
+            </a:r>
+          </a:p>
+        </p:txBody>
+      </p:sp>
+      <p:sp>
+        <p:nvSpPr>
+          <p:cNvPr id="11" name="TextBox 10"/>
+          <p:cNvSpPr txBox="1"/>
+          <p:nvPr/>
+        </p:nvSpPr>
+        <p:spPr>
+          <a:xfrm>
+            <a:off x="1737360" y="6638544"/>
+            <a:ext cx="1280160" cy="914400"/>
+          </a:xfrm>
+          <a:prstGeom prst="rect">
+            <a:avLst/>
+          </a:prstGeom>
+          <a:noFill/>
+        </p:spPr>
+        <p:txBody>
+          <a:bodyPr wrap="square">
+            <a:spAutoFit/>
+          </a:bodyPr>
+          <a:lstStyle/>
+          <a:p>
+            <a:r>
+              <a:rPr sz="4300" b="1" i="0">
+                <a:solidFill>
+                  <a:srgbClr val="1A1A1A"/>
+                </a:solidFill>
+                <a:latin typeface="Outfit"/>
+              </a:rPr>
+              <a:t>05</a:t>
+            </a:r>
+          </a:p>
+        </p:txBody>
+      </p:sp>
+      <p:sp>
+        <p:nvSpPr>
+          <p:cNvPr id="12" name="TextBox 11"/>
+          <p:cNvSpPr txBox="1"/>
+          <p:nvPr/>
+        </p:nvSpPr>
+        <p:spPr>
+          <a:xfrm>
+            <a:off x="3063239" y="6803136"/>
+            <a:ext cx="6217920" cy="914400"/>
+          </a:xfrm>
+          <a:prstGeom prst="rect">
+            <a:avLst/>
+          </a:prstGeom>
+          <a:noFill/>
+        </p:spPr>
+        <p:txBody>
+          <a:bodyPr wrap="square">
+            <a:spAutoFit/>
+          </a:bodyPr>
+          <a:lstStyle/>
+          <a:p>
+            <a:r>
+              <a:rPr sz="3000" b="0" i="0">
+                <a:solidFill>
+                  <a:srgbClr val="7A7A72"/>
+                </a:solidFill>
+                <a:latin typeface="Outfit"/>
+              </a:rPr>
+              <a:t>Proposta de valor e posicionamento</a:t>
+            </a:r>
+          </a:p>
+        </p:txBody>
+      </p:sp>
+      <p:sp>
+        <p:nvSpPr>
+          <p:cNvPr id="13" name="TextBox 12"/>
+          <p:cNvSpPr txBox="1"/>
+          <p:nvPr/>
+        </p:nvSpPr>
+        <p:spPr>
+          <a:xfrm>
+            <a:off x="9701784" y="2395728"/>
+            <a:ext cx="1280160" cy="914400"/>
+          </a:xfrm>
+          <a:prstGeom prst="rect">
+            <a:avLst/>
+          </a:prstGeom>
+          <a:noFill/>
+        </p:spPr>
+        <p:txBody>
+          <a:bodyPr wrap="square">
+            <a:spAutoFit/>
+          </a:bodyPr>
+          <a:lstStyle/>
+          <a:p>
+            <a:r>
+              <a:rPr sz="4300" b="1" i="0">
+                <a:solidFill>
+                  <a:srgbClr val="1A1A1A"/>
+                </a:solidFill>
+                <a:latin typeface="Outfit"/>
+              </a:rPr>
+              <a:t>06</a:t>
+            </a:r>
+          </a:p>
+        </p:txBody>
+      </p:sp>
+      <p:sp>
+        <p:nvSpPr>
+          <p:cNvPr id="14" name="TextBox 13"/>
+          <p:cNvSpPr txBox="1"/>
+          <p:nvPr/>
+        </p:nvSpPr>
+        <p:spPr>
+          <a:xfrm>
+            <a:off x="11027663" y="2560320"/>
+            <a:ext cx="6217920" cy="914400"/>
+          </a:xfrm>
+          <a:prstGeom prst="rect">
+            <a:avLst/>
+          </a:prstGeom>
+          <a:noFill/>
+        </p:spPr>
+        <p:txBody>
+          <a:bodyPr wrap="square">
+            <a:spAutoFit/>
+          </a:bodyPr>
+          <a:lstStyle/>
+          <a:p>
+            <a:r>
+              <a:rPr sz="3000" b="0" i="0">
+                <a:solidFill>
+                  <a:srgbClr val="7A7A72"/>
+                </a:solidFill>
+                <a:latin typeface="Outfit"/>
+              </a:rPr>
+              <a:t>Arquitetura de marca</a:t>
+            </a:r>
+          </a:p>
+        </p:txBody>
+      </p:sp>
+      <p:sp>
+        <p:nvSpPr>
+          <p:cNvPr id="15" name="TextBox 14"/>
+          <p:cNvSpPr txBox="1"/>
+          <p:nvPr/>
+        </p:nvSpPr>
+        <p:spPr>
+          <a:xfrm>
+            <a:off x="9701784" y="3520440"/>
+            <a:ext cx="1280160" cy="914400"/>
+          </a:xfrm>
+          <a:prstGeom prst="rect">
+            <a:avLst/>
+          </a:prstGeom>
+          <a:noFill/>
+        </p:spPr>
+        <p:txBody>
+          <a:bodyPr wrap="square">
+            <a:spAutoFit/>
+          </a:bodyPr>
+          <a:lstStyle/>
+          <a:p>
+            <a:r>
+              <a:rPr sz="4300" b="1" i="0">
+                <a:solidFill>
+                  <a:srgbClr val="1A1A1A"/>
+                </a:solidFill>
+                <a:latin typeface="Outfit"/>
+              </a:rPr>
+              <a:t>07</a:t>
+            </a:r>
+          </a:p>
+        </p:txBody>
+      </p:sp>
+      <p:sp>
+        <p:nvSpPr>
+          <p:cNvPr id="16" name="TextBox 15"/>
+          <p:cNvSpPr txBox="1"/>
+          <p:nvPr/>
+        </p:nvSpPr>
+        <p:spPr>
+          <a:xfrm>
+            <a:off x="11027663" y="3685032"/>
+            <a:ext cx="6217920" cy="914400"/>
+          </a:xfrm>
+          <a:prstGeom prst="rect">
+            <a:avLst/>
+          </a:prstGeom>
+          <a:noFill/>
+        </p:spPr>
+        <p:txBody>
+          <a:bodyPr wrap="square">
+            <a:spAutoFit/>
+          </a:bodyPr>
+          <a:lstStyle/>
+          <a:p>
+            <a:r>
+              <a:rPr sz="3000" b="0" i="0">
+                <a:solidFill>
+                  <a:srgbClr val="7A7A72"/>
+                </a:solidFill>
+                <a:latin typeface="Outfit"/>
+              </a:rPr>
+              <a:t>Territórios, pilares e público</a:t>
+            </a:r>
+          </a:p>
+        </p:txBody>
+      </p:sp>
+      <p:sp>
+        <p:nvSpPr>
+          <p:cNvPr id="17" name="TextBox 16"/>
+          <p:cNvSpPr txBox="1"/>
+          <p:nvPr/>
+        </p:nvSpPr>
+        <p:spPr>
+          <a:xfrm>
+            <a:off x="9701784" y="4645152"/>
+            <a:ext cx="1280160" cy="914400"/>
+          </a:xfrm>
+          <a:prstGeom prst="rect">
+            <a:avLst/>
+          </a:prstGeom>
+          <a:noFill/>
+        </p:spPr>
+        <p:txBody>
+          <a:bodyPr wrap="square">
+            <a:spAutoFit/>
+          </a:bodyPr>
+          <a:lstStyle/>
+          <a:p>
+            <a:r>
+              <a:rPr sz="4300" b="1" i="0">
+                <a:solidFill>
+                  <a:srgbClr val="1A1A1A"/>
+                </a:solidFill>
+                <a:latin typeface="Outfit"/>
+              </a:rPr>
+              <a:t>08</a:t>
+            </a:r>
+          </a:p>
+        </p:txBody>
+      </p:sp>
+      <p:sp>
+        <p:nvSpPr>
+          <p:cNvPr id="18" name="TextBox 17"/>
+          <p:cNvSpPr txBox="1"/>
+          <p:nvPr/>
+        </p:nvSpPr>
+        <p:spPr>
+          <a:xfrm>
+            <a:off x="11027663" y="4809744"/>
+            <a:ext cx="6217920" cy="914400"/>
+          </a:xfrm>
+          <a:prstGeom prst="rect">
+            <a:avLst/>
+          </a:prstGeom>
+          <a:noFill/>
+        </p:spPr>
+        <p:txBody>
+          <a:bodyPr wrap="square">
+            <a:spAutoFit/>
+          </a:bodyPr>
+          <a:lstStyle/>
+          <a:p>
+            <a:r>
+              <a:rPr sz="3000" b="0" i="0">
+                <a:solidFill>
+                  <a:srgbClr val="7A7A72"/>
+                </a:solidFill>
+                <a:latin typeface="Outfit"/>
+              </a:rPr>
+              <a:t>Personalidade e tom de voz</a:t>
+            </a:r>
+          </a:p>
+        </p:txBody>
+      </p:sp>
+      <p:sp>
+        <p:nvSpPr>
+          <p:cNvPr id="19" name="TextBox 18"/>
+          <p:cNvSpPr txBox="1"/>
+          <p:nvPr/>
+        </p:nvSpPr>
+        <p:spPr>
+          <a:xfrm>
+            <a:off x="9701784" y="5989320"/>
+            <a:ext cx="1280160" cy="914400"/>
+          </a:xfrm>
+          <a:prstGeom prst="rect">
+            <a:avLst/>
+          </a:prstGeom>
+          <a:noFill/>
+        </p:spPr>
+        <p:txBody>
+          <a:bodyPr wrap="square">
+            <a:spAutoFit/>
+          </a:bodyPr>
+          <a:lstStyle/>
+          <a:p>
+            <a:r>
+              <a:rPr sz="4300" b="1" i="0">
+                <a:solidFill>
+                  <a:srgbClr val="1A1A1A"/>
+                </a:solidFill>
+                <a:latin typeface="Outfit"/>
+              </a:rPr>
+              <a:t>09</a:t>
+            </a:r>
+          </a:p>
+        </p:txBody>
+      </p:sp>
+      <p:sp>
+        <p:nvSpPr>
+          <p:cNvPr id="20" name="TextBox 19"/>
+          <p:cNvSpPr txBox="1"/>
+          <p:nvPr/>
+        </p:nvSpPr>
+        <p:spPr>
+          <a:xfrm>
+            <a:off x="11027663" y="6153912"/>
+            <a:ext cx="6217920" cy="914400"/>
+          </a:xfrm>
+          <a:prstGeom prst="rect">
+            <a:avLst/>
+          </a:prstGeom>
+          <a:noFill/>
+        </p:spPr>
+        <p:txBody>
+          <a:bodyPr wrap="square">
+            <a:spAutoFit/>
+          </a:bodyPr>
+          <a:lstStyle/>
+          <a:p>
+            <a:r>
+              <a:rPr sz="3000" b="0" i="0">
+                <a:solidFill>
+                  <a:srgbClr val="7A7A72"/>
+                </a:solidFill>
+                <a:latin typeface="Outfit"/>
+              </a:rPr>
+              <a:t>Manifesto e síntese final</a:t>
+            </a:r>
+          </a:p>
+        </p:txBody>
+      </p:sp>
+      <p:sp>
+        <p:nvSpPr>
+          <p:cNvPr id="21" name="TextBox 20"/>
+          <p:cNvSpPr txBox="1"/>
+          <p:nvPr/>
+        </p:nvSpPr>
+        <p:spPr>
+          <a:xfrm>
+            <a:off x="822960" y="9601200"/>
+            <a:ext cx="10424160" cy="457200"/>
+          </a:xfrm>
+          <a:prstGeom prst="rect">
+            <a:avLst/>
+          </a:prstGeom>
+          <a:noFill/>
+        </p:spPr>
+        <p:txBody>
+          <a:bodyPr wrap="square">
+            <a:spAutoFit/>
+          </a:bodyPr>
+          <a:lstStyle/>
+          <a:p>
+            <a:r>
+              <a:rPr sz="1300" b="0" i="0" spc="150">
+                <a:solidFill>
+                  <a:srgbClr val="000000"/>
+                </a:solidFill>
+                <a:latin typeface="Outfit"/>
+              </a:rPr>
+              <a:t>BASE ESTRATÉGICA DA MARCA</a:t>
+            </a:r>
+            <a:r>
+              <a:rPr sz="1300" b="0" i="0">
+                <a:solidFill>
+                  <a:srgbClr val="000000"/>
+                </a:solidFill>
+                <a:latin typeface="Outfit"/>
+              </a:rPr>
+              <a:t>   |   </a:t>
+            </a:r>
+            <a:r>
+              <a:rPr sz="1300" b="1" i="0" spc="150">
+                <a:solidFill>
+                  <a:srgbClr val="000000"/>
+                </a:solidFill>
+                <a:latin typeface="Outfit"/>
+              </a:rPr>
+              <a:t>YUFIL</a:t>
+            </a:r>
+          </a:p>
+        </p:txBody>
+      </p:sp>
       <p:pic>
         <p:nvPicPr>
-          <p:cNvPr id="2" name="Picture 1" descr="textura-papel.jpeg"/>
+          <p:cNvPr id="22" name="Picture 21" descr="logo-ka.png"/>
           <p:cNvPicPr>
             <a:picLocks noChangeAspect="1"/>
           </p:cNvPicPr>
@@ -3506,728 +4156,6 @@
         </p:nvPicPr>
         <p:blipFill>
           <a:blip r:embed="rId2"/>
-          <a:stretch>
-            <a:fillRect/>
-          </a:stretch>
-        </p:blipFill>
-        <p:spPr>
-          <a:xfrm>
-            <a:off x="0" y="0"/>
-            <a:ext cx="18288000" cy="10287000"/>
-          </a:xfrm>
-          <a:prstGeom prst="rect">
-            <a:avLst/>
-          </a:prstGeom>
-        </p:spPr>
-      </p:pic>
-      <p:sp>
-        <p:nvSpPr>
-          <p:cNvPr id="3" name="TextBox 2"/>
-          <p:cNvSpPr txBox="1"/>
-          <p:nvPr/>
-        </p:nvSpPr>
-        <p:spPr>
-          <a:xfrm>
-            <a:off x="1737360" y="822960"/>
-            <a:ext cx="9144000" cy="1463040"/>
-          </a:xfrm>
-          <a:prstGeom prst="rect">
-            <a:avLst/>
-          </a:prstGeom>
-          <a:noFill/>
-        </p:spPr>
-        <p:txBody>
-          <a:bodyPr wrap="square">
-            <a:spAutoFit/>
-          </a:bodyPr>
-          <a:lstStyle/>
-          <a:p>
-            <a:r>
-              <a:rPr sz="7800" b="1" i="0">
-                <a:solidFill>
-                  <a:srgbClr val="000000"/>
-                </a:solidFill>
-                <a:latin typeface="Outfit"/>
-              </a:rPr>
-              <a:t>SUMÁRIO</a:t>
-            </a:r>
-          </a:p>
-        </p:txBody>
-      </p:sp>
-      <p:sp>
-        <p:nvSpPr>
-          <p:cNvPr id="4" name="TextBox 3"/>
-          <p:cNvSpPr txBox="1"/>
-          <p:nvPr/>
-        </p:nvSpPr>
-        <p:spPr>
-          <a:xfrm>
-            <a:off x="1737360" y="2395728"/>
-            <a:ext cx="1280160" cy="914400"/>
-          </a:xfrm>
-          <a:prstGeom prst="rect">
-            <a:avLst/>
-          </a:prstGeom>
-          <a:noFill/>
-        </p:spPr>
-        <p:txBody>
-          <a:bodyPr wrap="square">
-            <a:spAutoFit/>
-          </a:bodyPr>
-          <a:lstStyle/>
-          <a:p>
-            <a:r>
-              <a:rPr sz="4300" b="1" i="0">
-                <a:solidFill>
-                  <a:srgbClr val="1A1A1A"/>
-                </a:solidFill>
-                <a:latin typeface="Outfit"/>
-              </a:rPr>
-              <a:t>01</a:t>
-            </a:r>
-          </a:p>
-        </p:txBody>
-      </p:sp>
-      <p:sp>
-        <p:nvSpPr>
-          <p:cNvPr id="5" name="TextBox 4"/>
-          <p:cNvSpPr txBox="1"/>
-          <p:nvPr/>
-        </p:nvSpPr>
-        <p:spPr>
-          <a:xfrm>
-            <a:off x="3063239" y="2560320"/>
-            <a:ext cx="6217920" cy="914400"/>
-          </a:xfrm>
-          <a:prstGeom prst="rect">
-            <a:avLst/>
-          </a:prstGeom>
-          <a:noFill/>
-        </p:spPr>
-        <p:txBody>
-          <a:bodyPr wrap="square">
-            <a:spAutoFit/>
-          </a:bodyPr>
-          <a:lstStyle/>
-          <a:p>
-            <a:r>
-              <a:rPr sz="3000" b="0" i="0">
-                <a:solidFill>
-                  <a:srgbClr val="7A7A72"/>
-                </a:solidFill>
-                <a:latin typeface="Outfit"/>
-              </a:rPr>
-              <a:t>Leitura do momento da marca</a:t>
-            </a:r>
-          </a:p>
-        </p:txBody>
-      </p:sp>
-      <p:sp>
-        <p:nvSpPr>
-          <p:cNvPr id="6" name="TextBox 5"/>
-          <p:cNvSpPr txBox="1"/>
-          <p:nvPr/>
-        </p:nvSpPr>
-        <p:spPr>
-          <a:xfrm>
-            <a:off x="1737360" y="3456432"/>
-            <a:ext cx="1280160" cy="914400"/>
-          </a:xfrm>
-          <a:prstGeom prst="rect">
-            <a:avLst/>
-          </a:prstGeom>
-          <a:noFill/>
-        </p:spPr>
-        <p:txBody>
-          <a:bodyPr wrap="square">
-            <a:spAutoFit/>
-          </a:bodyPr>
-          <a:lstStyle/>
-          <a:p>
-            <a:r>
-              <a:rPr sz="4300" b="1" i="0">
-                <a:solidFill>
-                  <a:srgbClr val="1A1A1A"/>
-                </a:solidFill>
-                <a:latin typeface="Outfit"/>
-              </a:rPr>
-              <a:t>02</a:t>
-            </a:r>
-          </a:p>
-        </p:txBody>
-      </p:sp>
-      <p:sp>
-        <p:nvSpPr>
-          <p:cNvPr id="7" name="TextBox 6"/>
-          <p:cNvSpPr txBox="1"/>
-          <p:nvPr/>
-        </p:nvSpPr>
-        <p:spPr>
-          <a:xfrm>
-            <a:off x="3063239" y="3621024"/>
-            <a:ext cx="6217920" cy="914400"/>
-          </a:xfrm>
-          <a:prstGeom prst="rect">
-            <a:avLst/>
-          </a:prstGeom>
-          <a:noFill/>
-        </p:spPr>
-        <p:txBody>
-          <a:bodyPr wrap="square">
-            <a:spAutoFit/>
-          </a:bodyPr>
-          <a:lstStyle/>
-          <a:p>
-            <a:r>
-              <a:rPr sz="3000" b="0" i="0">
-                <a:solidFill>
-                  <a:srgbClr val="7A7A72"/>
-                </a:solidFill>
-                <a:latin typeface="Outfit"/>
-              </a:rPr>
-              <a:t>Definição central da marca</a:t>
-            </a:r>
-          </a:p>
-        </p:txBody>
-      </p:sp>
-      <p:sp>
-        <p:nvSpPr>
-          <p:cNvPr id="8" name="TextBox 7"/>
-          <p:cNvSpPr txBox="1"/>
-          <p:nvPr/>
-        </p:nvSpPr>
-        <p:spPr>
-          <a:xfrm>
-            <a:off x="1737360" y="4517136"/>
-            <a:ext cx="1280160" cy="914400"/>
-          </a:xfrm>
-          <a:prstGeom prst="rect">
-            <a:avLst/>
-          </a:prstGeom>
-          <a:noFill/>
-        </p:spPr>
-        <p:txBody>
-          <a:bodyPr wrap="square">
-            <a:spAutoFit/>
-          </a:bodyPr>
-          <a:lstStyle/>
-          <a:p>
-            <a:r>
-              <a:rPr sz="4300" b="1" i="0">
-                <a:solidFill>
-                  <a:srgbClr val="1A1A1A"/>
-                </a:solidFill>
-                <a:latin typeface="Outfit"/>
-              </a:rPr>
-              <a:t>03</a:t>
-            </a:r>
-          </a:p>
-        </p:txBody>
-      </p:sp>
-      <p:sp>
-        <p:nvSpPr>
-          <p:cNvPr id="9" name="TextBox 8"/>
-          <p:cNvSpPr txBox="1"/>
-          <p:nvPr/>
-        </p:nvSpPr>
-        <p:spPr>
-          <a:xfrm>
-            <a:off x="3063239" y="4681728"/>
-            <a:ext cx="6217920" cy="914400"/>
-          </a:xfrm>
-          <a:prstGeom prst="rect">
-            <a:avLst/>
-          </a:prstGeom>
-          <a:noFill/>
-        </p:spPr>
-        <p:txBody>
-          <a:bodyPr wrap="square">
-            <a:spAutoFit/>
-          </a:bodyPr>
-          <a:lstStyle/>
-          <a:p>
-            <a:r>
-              <a:rPr sz="3000" b="0" i="0">
-                <a:solidFill>
-                  <a:srgbClr val="7A7A72"/>
-                </a:solidFill>
-                <a:latin typeface="Outfit"/>
-              </a:rPr>
-              <a:t>Causa, liderança e tribo</a:t>
-            </a:r>
-          </a:p>
-        </p:txBody>
-      </p:sp>
-      <p:sp>
-        <p:nvSpPr>
-          <p:cNvPr id="10" name="TextBox 9"/>
-          <p:cNvSpPr txBox="1"/>
-          <p:nvPr/>
-        </p:nvSpPr>
-        <p:spPr>
-          <a:xfrm>
-            <a:off x="1737360" y="5577840"/>
-            <a:ext cx="1280160" cy="914400"/>
-          </a:xfrm>
-          <a:prstGeom prst="rect">
-            <a:avLst/>
-          </a:prstGeom>
-          <a:noFill/>
-        </p:spPr>
-        <p:txBody>
-          <a:bodyPr wrap="square">
-            <a:spAutoFit/>
-          </a:bodyPr>
-          <a:lstStyle/>
-          <a:p>
-            <a:r>
-              <a:rPr sz="4300" b="1" i="0">
-                <a:solidFill>
-                  <a:srgbClr val="1A1A1A"/>
-                </a:solidFill>
-                <a:latin typeface="Outfit"/>
-              </a:rPr>
-              <a:t>04</a:t>
-            </a:r>
-          </a:p>
-        </p:txBody>
-      </p:sp>
-      <p:sp>
-        <p:nvSpPr>
-          <p:cNvPr id="11" name="TextBox 10"/>
-          <p:cNvSpPr txBox="1"/>
-          <p:nvPr/>
-        </p:nvSpPr>
-        <p:spPr>
-          <a:xfrm>
-            <a:off x="3063239" y="5742431"/>
-            <a:ext cx="6217920" cy="914400"/>
-          </a:xfrm>
-          <a:prstGeom prst="rect">
-            <a:avLst/>
-          </a:prstGeom>
-          <a:noFill/>
-        </p:spPr>
-        <p:txBody>
-          <a:bodyPr wrap="square">
-            <a:spAutoFit/>
-          </a:bodyPr>
-          <a:lstStyle/>
-          <a:p>
-            <a:r>
-              <a:rPr sz="3000" b="0" i="0">
-                <a:solidFill>
-                  <a:srgbClr val="7A7A72"/>
-                </a:solidFill>
-                <a:latin typeface="Outfit"/>
-              </a:rPr>
-              <a:t>Golden Circle</a:t>
-            </a:r>
-          </a:p>
-        </p:txBody>
-      </p:sp>
-      <p:sp>
-        <p:nvSpPr>
-          <p:cNvPr id="12" name="TextBox 11"/>
-          <p:cNvSpPr txBox="1"/>
-          <p:nvPr/>
-        </p:nvSpPr>
-        <p:spPr>
-          <a:xfrm>
-            <a:off x="1737360" y="6638544"/>
-            <a:ext cx="1280160" cy="914400"/>
-          </a:xfrm>
-          <a:prstGeom prst="rect">
-            <a:avLst/>
-          </a:prstGeom>
-          <a:noFill/>
-        </p:spPr>
-        <p:txBody>
-          <a:bodyPr wrap="square">
-            <a:spAutoFit/>
-          </a:bodyPr>
-          <a:lstStyle/>
-          <a:p>
-            <a:r>
-              <a:rPr sz="4300" b="1" i="0">
-                <a:solidFill>
-                  <a:srgbClr val="1A1A1A"/>
-                </a:solidFill>
-                <a:latin typeface="Outfit"/>
-              </a:rPr>
-              <a:t>05</a:t>
-            </a:r>
-          </a:p>
-        </p:txBody>
-      </p:sp>
-      <p:sp>
-        <p:nvSpPr>
-          <p:cNvPr id="13" name="TextBox 12"/>
-          <p:cNvSpPr txBox="1"/>
-          <p:nvPr/>
-        </p:nvSpPr>
-        <p:spPr>
-          <a:xfrm>
-            <a:off x="3063239" y="6803136"/>
-            <a:ext cx="6217920" cy="914400"/>
-          </a:xfrm>
-          <a:prstGeom prst="rect">
-            <a:avLst/>
-          </a:prstGeom>
-          <a:noFill/>
-        </p:spPr>
-        <p:txBody>
-          <a:bodyPr wrap="square">
-            <a:spAutoFit/>
-          </a:bodyPr>
-          <a:lstStyle/>
-          <a:p>
-            <a:r>
-              <a:rPr sz="3000" b="0" i="0">
-                <a:solidFill>
-                  <a:srgbClr val="7A7A72"/>
-                </a:solidFill>
-                <a:latin typeface="Outfit"/>
-              </a:rPr>
-              <a:t>Proposta de valor e posicionamento</a:t>
-            </a:r>
-          </a:p>
-        </p:txBody>
-      </p:sp>
-      <p:sp>
-        <p:nvSpPr>
-          <p:cNvPr id="14" name="TextBox 13"/>
-          <p:cNvSpPr txBox="1"/>
-          <p:nvPr/>
-        </p:nvSpPr>
-        <p:spPr>
-          <a:xfrm>
-            <a:off x="9701784" y="2395728"/>
-            <a:ext cx="1280160" cy="914400"/>
-          </a:xfrm>
-          <a:prstGeom prst="rect">
-            <a:avLst/>
-          </a:prstGeom>
-          <a:noFill/>
-        </p:spPr>
-        <p:txBody>
-          <a:bodyPr wrap="square">
-            <a:spAutoFit/>
-          </a:bodyPr>
-          <a:lstStyle/>
-          <a:p>
-            <a:r>
-              <a:rPr sz="4300" b="1" i="0">
-                <a:solidFill>
-                  <a:srgbClr val="1A1A1A"/>
-                </a:solidFill>
-                <a:latin typeface="Outfit"/>
-              </a:rPr>
-              <a:t>06</a:t>
-            </a:r>
-          </a:p>
-        </p:txBody>
-      </p:sp>
-      <p:sp>
-        <p:nvSpPr>
-          <p:cNvPr id="15" name="TextBox 14"/>
-          <p:cNvSpPr txBox="1"/>
-          <p:nvPr/>
-        </p:nvSpPr>
-        <p:spPr>
-          <a:xfrm>
-            <a:off x="11027663" y="2560320"/>
-            <a:ext cx="6217920" cy="914400"/>
-          </a:xfrm>
-          <a:prstGeom prst="rect">
-            <a:avLst/>
-          </a:prstGeom>
-          <a:noFill/>
-        </p:spPr>
-        <p:txBody>
-          <a:bodyPr wrap="square">
-            <a:spAutoFit/>
-          </a:bodyPr>
-          <a:lstStyle/>
-          <a:p>
-            <a:r>
-              <a:rPr sz="3000" b="0" i="0">
-                <a:solidFill>
-                  <a:srgbClr val="7A7A72"/>
-                </a:solidFill>
-                <a:latin typeface="Outfit"/>
-              </a:rPr>
-              <a:t>Arquitetura de marca</a:t>
-            </a:r>
-          </a:p>
-        </p:txBody>
-      </p:sp>
-      <p:sp>
-        <p:nvSpPr>
-          <p:cNvPr id="16" name="TextBox 15"/>
-          <p:cNvSpPr txBox="1"/>
-          <p:nvPr/>
-        </p:nvSpPr>
-        <p:spPr>
-          <a:xfrm>
-            <a:off x="9701784" y="3520440"/>
-            <a:ext cx="1280160" cy="914400"/>
-          </a:xfrm>
-          <a:prstGeom prst="rect">
-            <a:avLst/>
-          </a:prstGeom>
-          <a:noFill/>
-        </p:spPr>
-        <p:txBody>
-          <a:bodyPr wrap="square">
-            <a:spAutoFit/>
-          </a:bodyPr>
-          <a:lstStyle/>
-          <a:p>
-            <a:r>
-              <a:rPr sz="4300" b="1" i="0">
-                <a:solidFill>
-                  <a:srgbClr val="1A1A1A"/>
-                </a:solidFill>
-                <a:latin typeface="Outfit"/>
-              </a:rPr>
-              <a:t>07</a:t>
-            </a:r>
-          </a:p>
-        </p:txBody>
-      </p:sp>
-      <p:sp>
-        <p:nvSpPr>
-          <p:cNvPr id="17" name="TextBox 16"/>
-          <p:cNvSpPr txBox="1"/>
-          <p:nvPr/>
-        </p:nvSpPr>
-        <p:spPr>
-          <a:xfrm>
-            <a:off x="11027663" y="3685032"/>
-            <a:ext cx="6217920" cy="914400"/>
-          </a:xfrm>
-          <a:prstGeom prst="rect">
-            <a:avLst/>
-          </a:prstGeom>
-          <a:noFill/>
-        </p:spPr>
-        <p:txBody>
-          <a:bodyPr wrap="square">
-            <a:spAutoFit/>
-          </a:bodyPr>
-          <a:lstStyle/>
-          <a:p>
-            <a:r>
-              <a:rPr sz="3000" b="0" i="0">
-                <a:solidFill>
-                  <a:srgbClr val="7A7A72"/>
-                </a:solidFill>
-                <a:latin typeface="Outfit"/>
-              </a:rPr>
-              <a:t>Territórios, pilares e público</a:t>
-            </a:r>
-          </a:p>
-        </p:txBody>
-      </p:sp>
-      <p:sp>
-        <p:nvSpPr>
-          <p:cNvPr id="18" name="TextBox 17"/>
-          <p:cNvSpPr txBox="1"/>
-          <p:nvPr/>
-        </p:nvSpPr>
-        <p:spPr>
-          <a:xfrm>
-            <a:off x="9701784" y="4645152"/>
-            <a:ext cx="1280160" cy="914400"/>
-          </a:xfrm>
-          <a:prstGeom prst="rect">
-            <a:avLst/>
-          </a:prstGeom>
-          <a:noFill/>
-        </p:spPr>
-        <p:txBody>
-          <a:bodyPr wrap="square">
-            <a:spAutoFit/>
-          </a:bodyPr>
-          <a:lstStyle/>
-          <a:p>
-            <a:r>
-              <a:rPr sz="4300" b="1" i="0">
-                <a:solidFill>
-                  <a:srgbClr val="1A1A1A"/>
-                </a:solidFill>
-                <a:latin typeface="Outfit"/>
-              </a:rPr>
-              <a:t>08</a:t>
-            </a:r>
-          </a:p>
-        </p:txBody>
-      </p:sp>
-      <p:sp>
-        <p:nvSpPr>
-          <p:cNvPr id="19" name="TextBox 18"/>
-          <p:cNvSpPr txBox="1"/>
-          <p:nvPr/>
-        </p:nvSpPr>
-        <p:spPr>
-          <a:xfrm>
-            <a:off x="11027663" y="4809744"/>
-            <a:ext cx="6217920" cy="914400"/>
-          </a:xfrm>
-          <a:prstGeom prst="rect">
-            <a:avLst/>
-          </a:prstGeom>
-          <a:noFill/>
-        </p:spPr>
-        <p:txBody>
-          <a:bodyPr wrap="square">
-            <a:spAutoFit/>
-          </a:bodyPr>
-          <a:lstStyle/>
-          <a:p>
-            <a:r>
-              <a:rPr sz="3000" b="0" i="0">
-                <a:solidFill>
-                  <a:srgbClr val="7A7A72"/>
-                </a:solidFill>
-                <a:latin typeface="Outfit"/>
-              </a:rPr>
-              <a:t>Personalidade e tom de voz</a:t>
-            </a:r>
-          </a:p>
-        </p:txBody>
-      </p:sp>
-      <p:sp>
-        <p:nvSpPr>
-          <p:cNvPr id="20" name="TextBox 19"/>
-          <p:cNvSpPr txBox="1"/>
-          <p:nvPr/>
-        </p:nvSpPr>
-        <p:spPr>
-          <a:xfrm>
-            <a:off x="9701784" y="5989320"/>
-            <a:ext cx="1280160" cy="914400"/>
-          </a:xfrm>
-          <a:prstGeom prst="rect">
-            <a:avLst/>
-          </a:prstGeom>
-          <a:noFill/>
-        </p:spPr>
-        <p:txBody>
-          <a:bodyPr wrap="square">
-            <a:spAutoFit/>
-          </a:bodyPr>
-          <a:lstStyle/>
-          <a:p>
-            <a:r>
-              <a:rPr sz="4300" b="1" i="0">
-                <a:solidFill>
-                  <a:srgbClr val="1A1A1A"/>
-                </a:solidFill>
-                <a:latin typeface="Outfit"/>
-              </a:rPr>
-              <a:t>09</a:t>
-            </a:r>
-          </a:p>
-        </p:txBody>
-      </p:sp>
-      <p:sp>
-        <p:nvSpPr>
-          <p:cNvPr id="21" name="TextBox 20"/>
-          <p:cNvSpPr txBox="1"/>
-          <p:nvPr/>
-        </p:nvSpPr>
-        <p:spPr>
-          <a:xfrm>
-            <a:off x="11027663" y="6153912"/>
-            <a:ext cx="6217920" cy="914400"/>
-          </a:xfrm>
-          <a:prstGeom prst="rect">
-            <a:avLst/>
-          </a:prstGeom>
-          <a:noFill/>
-        </p:spPr>
-        <p:txBody>
-          <a:bodyPr wrap="square">
-            <a:spAutoFit/>
-          </a:bodyPr>
-          <a:lstStyle/>
-          <a:p>
-            <a:r>
-              <a:rPr sz="3000" b="0" i="0">
-                <a:solidFill>
-                  <a:srgbClr val="7A7A72"/>
-                </a:solidFill>
-                <a:latin typeface="Outfit"/>
-              </a:rPr>
-              <a:t>Manifesto e síntese final</a:t>
-            </a:r>
-          </a:p>
-        </p:txBody>
-      </p:sp>
-      <p:sp>
-        <p:nvSpPr>
-          <p:cNvPr id="22" name="TextBox 21"/>
-          <p:cNvSpPr txBox="1"/>
-          <p:nvPr/>
-        </p:nvSpPr>
-        <p:spPr>
-          <a:xfrm>
-            <a:off x="822960" y="9601200"/>
-            <a:ext cx="10424160" cy="457200"/>
-          </a:xfrm>
-          <a:prstGeom prst="rect">
-            <a:avLst/>
-          </a:prstGeom>
-          <a:noFill/>
-        </p:spPr>
-        <p:txBody>
-          <a:bodyPr wrap="square">
-            <a:spAutoFit/>
-          </a:bodyPr>
-          <a:lstStyle/>
-          <a:p>
-            <a:r>
-              <a:rPr sz="1300" b="0" i="0" spc="150">
-                <a:solidFill>
-                  <a:srgbClr val="000000"/>
-                </a:solidFill>
-                <a:latin typeface="Outfit"/>
-              </a:rPr>
-              <a:t>BASE ESTRATÉGICA DA MARCA</a:t>
-            </a:r>
-            <a:r>
-              <a:rPr sz="1300" b="0" i="0">
-                <a:solidFill>
-                  <a:srgbClr val="000000"/>
-                </a:solidFill>
-                <a:latin typeface="Outfit"/>
-              </a:rPr>
-              <a:t>   |   </a:t>
-            </a:r>
-            <a:r>
-              <a:rPr sz="1300" b="1" i="0" spc="150">
-                <a:solidFill>
-                  <a:srgbClr val="000000"/>
-                </a:solidFill>
-                <a:latin typeface="Outfit"/>
-              </a:rPr>
-              <a:t>YUFIL</a:t>
-            </a:r>
-          </a:p>
-        </p:txBody>
-      </p:sp>
-      <p:pic>
-        <p:nvPicPr>
-          <p:cNvPr id="23" name="Picture 22" descr="logo-ka.png"/>
-          <p:cNvPicPr>
-            <a:picLocks noChangeAspect="1"/>
-          </p:cNvPicPr>
-          <p:nvPr/>
-        </p:nvPicPr>
-        <p:blipFill>
-          <a:blip r:embed="rId3"/>
           <a:stretch>
             <a:fillRect/>
           </a:stretch>
@@ -4437,9 +4365,190 @@
         <p:nvPr/>
       </p:nvGrpSpPr>
       <p:grpSpPr/>
+      <p:sp>
+        <p:nvSpPr>
+          <p:cNvPr id="2" name="TextBox 1"/>
+          <p:cNvSpPr txBox="1"/>
+          <p:nvPr/>
+        </p:nvSpPr>
+        <p:spPr>
+          <a:xfrm>
+            <a:off x="1371600" y="1188720"/>
+            <a:ext cx="3657600" cy="2743200"/>
+          </a:xfrm>
+          <a:prstGeom prst="rect">
+            <a:avLst/>
+          </a:prstGeom>
+          <a:noFill/>
+        </p:spPr>
+        <p:txBody>
+          <a:bodyPr wrap="square">
+            <a:spAutoFit/>
+          </a:bodyPr>
+          <a:lstStyle/>
+          <a:p>
+            <a:r>
+              <a:rPr sz="13500" b="1" i="0">
+                <a:solidFill>
+                  <a:srgbClr val="1A1A1A"/>
+                </a:solidFill>
+                <a:latin typeface="Outfit"/>
+              </a:rPr>
+              <a:t>“</a:t>
+            </a:r>
+          </a:p>
+        </p:txBody>
+      </p:sp>
+      <p:sp>
+        <p:nvSpPr>
+          <p:cNvPr id="3" name="TextBox 2"/>
+          <p:cNvSpPr txBox="1"/>
+          <p:nvPr/>
+        </p:nvSpPr>
+        <p:spPr>
+          <a:xfrm>
+            <a:off x="3200400" y="3200400"/>
+            <a:ext cx="11887200" cy="3657600"/>
+          </a:xfrm>
+          <a:prstGeom prst="rect">
+            <a:avLst/>
+          </a:prstGeom>
+          <a:noFill/>
+        </p:spPr>
+        <p:txBody>
+          <a:bodyPr wrap="square">
+            <a:spAutoFit/>
+          </a:bodyPr>
+          <a:lstStyle/>
+          <a:p>
+            <a:r>
+              <a:rPr sz="4300" b="0" i="0">
+                <a:solidFill>
+                  <a:srgbClr val="1A1A1A"/>
+                </a:solidFill>
+                <a:latin typeface="Outfit"/>
+              </a:rPr>
+              <a:t>A YUFIL </a:t>
+            </a:r>
+            <a:r>
+              <a:rPr sz="4300" b="1" i="0">
+                <a:solidFill>
+                  <a:srgbClr val="1A1A1A"/>
+                </a:solidFill>
+                <a:latin typeface="Outfit"/>
+              </a:rPr>
+              <a:t>não nasce </a:t>
+            </a:r>
+            <a:r>
+              <a:rPr sz="4300" b="0" i="0">
+                <a:solidFill>
+                  <a:srgbClr val="1A1A1A"/>
+                </a:solidFill>
+                <a:latin typeface="Outfit"/>
+              </a:rPr>
+              <a:t>de uma oportunidade de mercado. Ela nasce do encontro entre </a:t>
+            </a:r>
+            <a:r>
+              <a:rPr sz="4300" b="1" i="0">
+                <a:solidFill>
+                  <a:srgbClr val="1A1A1A"/>
+                </a:solidFill>
+                <a:latin typeface="Outfit"/>
+              </a:rPr>
+              <a:t>duas forças complementares.</a:t>
+            </a:r>
+          </a:p>
+        </p:txBody>
+      </p:sp>
+      <p:sp>
+        <p:nvSpPr>
+          <p:cNvPr id="4" name="TextBox 3"/>
+          <p:cNvSpPr txBox="1"/>
+          <p:nvPr/>
+        </p:nvSpPr>
+        <p:spPr>
+          <a:xfrm>
+            <a:off x="3200400" y="6949440"/>
+            <a:ext cx="11887200" cy="548640"/>
+          </a:xfrm>
+          <a:prstGeom prst="rect">
+            <a:avLst/>
+          </a:prstGeom>
+          <a:noFill/>
+        </p:spPr>
+        <p:txBody>
+          <a:bodyPr wrap="square">
+            <a:spAutoFit/>
+          </a:bodyPr>
+          <a:lstStyle/>
+          <a:p>
+            <a:r>
+              <a:rPr sz="2100" b="1" i="0" spc="200">
+                <a:solidFill>
+                  <a:srgbClr val="7A7A72"/>
+                </a:solidFill>
+                <a:latin typeface="Outfit"/>
+              </a:rPr>
+              <a:t>ESSÊNCIA HUMANA + DIREÇÃO DE PROJETO</a:t>
+            </a:r>
+          </a:p>
+        </p:txBody>
+      </p:sp>
+      <p:sp>
+        <p:nvSpPr>
+          <p:cNvPr id="5" name="TextBox 4"/>
+          <p:cNvSpPr txBox="1"/>
+          <p:nvPr/>
+        </p:nvSpPr>
+        <p:spPr>
+          <a:xfrm>
+            <a:off x="822960" y="9601200"/>
+            <a:ext cx="10424160" cy="457200"/>
+          </a:xfrm>
+          <a:prstGeom prst="rect">
+            <a:avLst/>
+          </a:prstGeom>
+          <a:noFill/>
+        </p:spPr>
+        <p:txBody>
+          <a:bodyPr wrap="square">
+            <a:spAutoFit/>
+          </a:bodyPr>
+          <a:lstStyle/>
+          <a:p>
+            <a:r>
+              <a:rPr sz="1300" b="0" i="0" spc="150">
+                <a:solidFill>
+                  <a:srgbClr val="000000"/>
+                </a:solidFill>
+                <a:latin typeface="Outfit"/>
+              </a:rPr>
+              <a:t>BASE ESTRATÉGICA DA MARCA</a:t>
+            </a:r>
+            <a:r>
+              <a:rPr sz="1300" b="0" i="0">
+                <a:solidFill>
+                  <a:srgbClr val="000000"/>
+                </a:solidFill>
+                <a:latin typeface="Outfit"/>
+              </a:rPr>
+              <a:t>   |   </a:t>
+            </a:r>
+            <a:r>
+              <a:rPr sz="1300" b="1" i="0" spc="150">
+                <a:solidFill>
+                  <a:srgbClr val="000000"/>
+                </a:solidFill>
+                <a:latin typeface="Outfit"/>
+              </a:rPr>
+              <a:t>YUFIL</a:t>
+            </a:r>
+          </a:p>
+        </p:txBody>
+      </p:sp>
       <p:pic>
         <p:nvPicPr>
-          <p:cNvPr id="2" name="Picture 1" descr="textura-papel.jpeg"/>
+          <p:cNvPr id="6" name="Picture 5" descr="logo-ka.png"/>
           <p:cNvPicPr>
             <a:picLocks noChangeAspect="1"/>
           </p:cNvPicPr>
@@ -4447,211 +4556,6 @@
         </p:nvPicPr>
         <p:blipFill>
           <a:blip r:embed="rId2"/>
-          <a:stretch>
-            <a:fillRect/>
-          </a:stretch>
-        </p:blipFill>
-        <p:spPr>
-          <a:xfrm>
-            <a:off x="0" y="0"/>
-            <a:ext cx="18288000" cy="10287000"/>
-          </a:xfrm>
-          <a:prstGeom prst="rect">
-            <a:avLst/>
-          </a:prstGeom>
-        </p:spPr>
-      </p:pic>
-      <p:sp>
-        <p:nvSpPr>
-          <p:cNvPr id="3" name="TextBox 2"/>
-          <p:cNvSpPr txBox="1"/>
-          <p:nvPr/>
-        </p:nvSpPr>
-        <p:spPr>
-          <a:xfrm>
-            <a:off x="1371600" y="1188720"/>
-            <a:ext cx="3657600" cy="2743200"/>
-          </a:xfrm>
-          <a:prstGeom prst="rect">
-            <a:avLst/>
-          </a:prstGeom>
-          <a:noFill/>
-        </p:spPr>
-        <p:txBody>
-          <a:bodyPr wrap="square">
-            <a:spAutoFit/>
-          </a:bodyPr>
-          <a:lstStyle/>
-          <a:p>
-            <a:r>
-              <a:rPr sz="13500" b="1" i="0">
-                <a:solidFill>
-                  <a:srgbClr val="1A1A1A"/>
-                </a:solidFill>
-                <a:latin typeface="Outfit"/>
-              </a:rPr>
-              <a:t>“</a:t>
-            </a:r>
-          </a:p>
-        </p:txBody>
-      </p:sp>
-      <p:sp>
-        <p:nvSpPr>
-          <p:cNvPr id="4" name="TextBox 3"/>
-          <p:cNvSpPr txBox="1"/>
-          <p:nvPr/>
-        </p:nvSpPr>
-        <p:spPr>
-          <a:xfrm>
-            <a:off x="3200400" y="3200400"/>
-            <a:ext cx="11887200" cy="3657600"/>
-          </a:xfrm>
-          <a:prstGeom prst="rect">
-            <a:avLst/>
-          </a:prstGeom>
-          <a:noFill/>
-        </p:spPr>
-        <p:txBody>
-          <a:bodyPr wrap="square">
-            <a:spAutoFit/>
-          </a:bodyPr>
-          <a:lstStyle/>
-          <a:p>
-            <a:r>
-              <a:rPr sz="4300" b="0" i="0">
-                <a:solidFill>
-                  <a:srgbClr val="1A1A1A"/>
-                </a:solidFill>
-                <a:latin typeface="Outfit"/>
-              </a:rPr>
-              <a:t>A YUFIL </a:t>
-            </a:r>
-            <a:r>
-              <a:rPr sz="4300" b="1" i="0">
-                <a:solidFill>
-                  <a:srgbClr val="1A1A1A"/>
-                </a:solidFill>
-                <a:latin typeface="Outfit"/>
-              </a:rPr>
-              <a:t>não nasce </a:t>
-            </a:r>
-            <a:r>
-              <a:rPr sz="4300" b="0" i="0">
-                <a:solidFill>
-                  <a:srgbClr val="1A1A1A"/>
-                </a:solidFill>
-                <a:latin typeface="Outfit"/>
-              </a:rPr>
-              <a:t>de uma oportunidade de mercado. Ela nasce do encontro entre </a:t>
-            </a:r>
-            <a:r>
-              <a:rPr sz="4300" b="1" i="0">
-                <a:solidFill>
-                  <a:srgbClr val="1A1A1A"/>
-                </a:solidFill>
-                <a:latin typeface="Outfit"/>
-              </a:rPr>
-              <a:t>duas forças complementares.</a:t>
-            </a:r>
-          </a:p>
-        </p:txBody>
-      </p:sp>
-      <p:sp>
-        <p:nvSpPr>
-          <p:cNvPr id="5" name="TextBox 4"/>
-          <p:cNvSpPr txBox="1"/>
-          <p:nvPr/>
-        </p:nvSpPr>
-        <p:spPr>
-          <a:xfrm>
-            <a:off x="3200400" y="6949440"/>
-            <a:ext cx="11887200" cy="548640"/>
-          </a:xfrm>
-          <a:prstGeom prst="rect">
-            <a:avLst/>
-          </a:prstGeom>
-          <a:noFill/>
-        </p:spPr>
-        <p:txBody>
-          <a:bodyPr wrap="square">
-            <a:spAutoFit/>
-          </a:bodyPr>
-          <a:lstStyle/>
-          <a:p>
-            <a:r>
-              <a:rPr sz="2100" b="1" i="0" spc="200">
-                <a:solidFill>
-                  <a:srgbClr val="7A7A72"/>
-                </a:solidFill>
-                <a:latin typeface="Outfit"/>
-              </a:rPr>
-              <a:t>ESSÊNCIA HUMANA + DIREÇÃO DE PROJETO</a:t>
-            </a:r>
-          </a:p>
-        </p:txBody>
-      </p:sp>
-      <p:sp>
-        <p:nvSpPr>
-          <p:cNvPr id="6" name="TextBox 5"/>
-          <p:cNvSpPr txBox="1"/>
-          <p:nvPr/>
-        </p:nvSpPr>
-        <p:spPr>
-          <a:xfrm>
-            <a:off x="822960" y="9601200"/>
-            <a:ext cx="10424160" cy="457200"/>
-          </a:xfrm>
-          <a:prstGeom prst="rect">
-            <a:avLst/>
-          </a:prstGeom>
-          <a:noFill/>
-        </p:spPr>
-        <p:txBody>
-          <a:bodyPr wrap="square">
-            <a:spAutoFit/>
-          </a:bodyPr>
-          <a:lstStyle/>
-          <a:p>
-            <a:r>
-              <a:rPr sz="1300" b="0" i="0" spc="150">
-                <a:solidFill>
-                  <a:srgbClr val="000000"/>
-                </a:solidFill>
-                <a:latin typeface="Outfit"/>
-              </a:rPr>
-              <a:t>BASE ESTRATÉGICA DA MARCA</a:t>
-            </a:r>
-            <a:r>
-              <a:rPr sz="1300" b="0" i="0">
-                <a:solidFill>
-                  <a:srgbClr val="000000"/>
-                </a:solidFill>
-                <a:latin typeface="Outfit"/>
-              </a:rPr>
-              <a:t>   |   </a:t>
-            </a:r>
-            <a:r>
-              <a:rPr sz="1300" b="1" i="0" spc="150">
-                <a:solidFill>
-                  <a:srgbClr val="000000"/>
-                </a:solidFill>
-                <a:latin typeface="Outfit"/>
-              </a:rPr>
-              <a:t>YUFIL</a:t>
-            </a:r>
-          </a:p>
-        </p:txBody>
-      </p:sp>
-      <p:pic>
-        <p:nvPicPr>
-          <p:cNvPr id="7" name="Picture 6" descr="logo-ka.png"/>
-          <p:cNvPicPr>
-            <a:picLocks noChangeAspect="1"/>
-          </p:cNvPicPr>
-          <p:nvPr/>
-        </p:nvPicPr>
-        <p:blipFill>
-          <a:blip r:embed="rId3"/>
           <a:stretch>
             <a:fillRect/>
           </a:stretch>
@@ -4692,33 +4596,9 @@
         <p:nvPr/>
       </p:nvGrpSpPr>
       <p:grpSpPr/>
-      <p:pic>
-        <p:nvPicPr>
-          <p:cNvPr id="2" name="Picture 1" descr="textura-papel.jpeg"/>
-          <p:cNvPicPr>
-            <a:picLocks noChangeAspect="1"/>
-          </p:cNvPicPr>
-          <p:nvPr/>
-        </p:nvPicPr>
-        <p:blipFill>
-          <a:blip r:embed="rId2"/>
-          <a:stretch>
-            <a:fillRect/>
-          </a:stretch>
-        </p:blipFill>
-        <p:spPr>
-          <a:xfrm>
-            <a:off x="0" y="0"/>
-            <a:ext cx="18288000" cy="10287000"/>
-          </a:xfrm>
-          <a:prstGeom prst="rect">
-            <a:avLst/>
-          </a:prstGeom>
-        </p:spPr>
-      </p:pic>
-      <p:sp>
-        <p:nvSpPr>
-          <p:cNvPr id="3" name="Rectangle 2"/>
+      <p:sp>
+        <p:nvSpPr>
+          <p:cNvPr id="2" name="Rectangle 1"/>
           <p:cNvSpPr/>
           <p:nvPr/>
         </p:nvSpPr>
@@ -4762,7 +4642,7 @@
       </p:sp>
       <p:sp>
         <p:nvSpPr>
-          <p:cNvPr id="4" name="TextBox 3"/>
+          <p:cNvPr id="3" name="TextBox 2"/>
           <p:cNvSpPr txBox="1"/>
           <p:nvPr/>
         </p:nvSpPr>
@@ -4796,7 +4676,7 @@
       </p:sp>
       <p:sp>
         <p:nvSpPr>
-          <p:cNvPr id="5" name="TextBox 4"/>
+          <p:cNvPr id="4" name="TextBox 3"/>
           <p:cNvSpPr txBox="1"/>
           <p:nvPr/>
         </p:nvSpPr>
@@ -4841,7 +4721,7 @@
       </p:sp>
       <p:sp>
         <p:nvSpPr>
-          <p:cNvPr id="6" name="TextBox 5"/>
+          <p:cNvPr id="5" name="TextBox 4"/>
           <p:cNvSpPr txBox="1"/>
           <p:nvPr/>
         </p:nvSpPr>
@@ -4897,7 +4777,7 @@
       </p:sp>
       <p:sp>
         <p:nvSpPr>
-          <p:cNvPr id="7" name="TextBox 6"/>
+          <p:cNvPr id="6" name="TextBox 5"/>
           <p:cNvSpPr txBox="1"/>
           <p:nvPr/>
         </p:nvSpPr>
@@ -4931,7 +4811,7 @@
       </p:sp>
       <p:sp>
         <p:nvSpPr>
-          <p:cNvPr id="8" name="TextBox 7"/>
+          <p:cNvPr id="7" name="TextBox 6"/>
           <p:cNvSpPr txBox="1"/>
           <p:nvPr/>
         </p:nvSpPr>
@@ -4965,7 +4845,7 @@
       </p:sp>
       <p:sp>
         <p:nvSpPr>
-          <p:cNvPr id="9" name="TextBox 8"/>
+          <p:cNvPr id="8" name="TextBox 7"/>
           <p:cNvSpPr txBox="1"/>
           <p:nvPr/>
         </p:nvSpPr>
@@ -5017,14 +4897,14 @@
       </p:sp>
       <p:pic>
         <p:nvPicPr>
-          <p:cNvPr id="10" name="Picture 9" descr="logo-ka.png"/>
+          <p:cNvPr id="9" name="Picture 8" descr="logo-ka.png"/>
           <p:cNvPicPr>
             <a:picLocks noChangeAspect="1"/>
           </p:cNvPicPr>
           <p:nvPr/>
         </p:nvPicPr>
         <p:blipFill>
-          <a:blip r:embed="rId3"/>
+          <a:blip r:embed="rId2"/>
           <a:stretch>
             <a:fillRect/>
           </a:stretch>
@@ -5065,33 +4945,9 @@
         <p:nvPr/>
       </p:nvGrpSpPr>
       <p:grpSpPr/>
-      <p:pic>
-        <p:nvPicPr>
-          <p:cNvPr id="2" name="Picture 1" descr="textura-papel.jpeg"/>
-          <p:cNvPicPr>
-            <a:picLocks noChangeAspect="1"/>
-          </p:cNvPicPr>
-          <p:nvPr/>
-        </p:nvPicPr>
-        <p:blipFill>
-          <a:blip r:embed="rId2"/>
-          <a:stretch>
-            <a:fillRect/>
-          </a:stretch>
-        </p:blipFill>
-        <p:spPr>
-          <a:xfrm>
-            <a:off x="0" y="0"/>
-            <a:ext cx="18288000" cy="10287000"/>
-          </a:xfrm>
-          <a:prstGeom prst="rect">
-            <a:avLst/>
-          </a:prstGeom>
-        </p:spPr>
-      </p:pic>
-      <p:sp>
-        <p:nvSpPr>
-          <p:cNvPr id="3" name="Rectangle 2"/>
+      <p:sp>
+        <p:nvSpPr>
+          <p:cNvPr id="2" name="Rectangle 1"/>
           <p:cNvSpPr/>
           <p:nvPr/>
         </p:nvSpPr>
@@ -5135,7 +4991,7 @@
       </p:sp>
       <p:sp>
         <p:nvSpPr>
-          <p:cNvPr id="4" name="TextBox 3"/>
+          <p:cNvPr id="3" name="TextBox 2"/>
           <p:cNvSpPr txBox="1"/>
           <p:nvPr/>
         </p:nvSpPr>
@@ -5169,7 +5025,7 @@
       </p:sp>
       <p:sp>
         <p:nvSpPr>
-          <p:cNvPr id="5" name="TextBox 4"/>
+          <p:cNvPr id="4" name="TextBox 3"/>
           <p:cNvSpPr txBox="1"/>
           <p:nvPr/>
         </p:nvSpPr>
@@ -5203,7 +5059,7 @@
       </p:sp>
       <p:sp>
         <p:nvSpPr>
-          <p:cNvPr id="6" name="TextBox 5"/>
+          <p:cNvPr id="5" name="TextBox 4"/>
           <p:cNvSpPr txBox="1"/>
           <p:nvPr/>
         </p:nvSpPr>
@@ -5306,7 +5162,7 @@
       </p:sp>
       <p:sp>
         <p:nvSpPr>
-          <p:cNvPr id="7" name="TextBox 6"/>
+          <p:cNvPr id="6" name="TextBox 5"/>
           <p:cNvSpPr txBox="1"/>
           <p:nvPr/>
         </p:nvSpPr>
@@ -5349,7 +5205,7 @@
       </p:sp>
       <p:sp>
         <p:nvSpPr>
-          <p:cNvPr id="8" name="TextBox 7"/>
+          <p:cNvPr id="7" name="TextBox 6"/>
           <p:cNvSpPr txBox="1"/>
           <p:nvPr/>
         </p:nvSpPr>
@@ -5401,14 +5257,14 @@
       </p:sp>
       <p:pic>
         <p:nvPicPr>
-          <p:cNvPr id="9" name="Picture 8" descr="logo-ka.png"/>
+          <p:cNvPr id="8" name="Picture 7" descr="logo-ka.png"/>
           <p:cNvPicPr>
             <a:picLocks noChangeAspect="1"/>
           </p:cNvPicPr>
           <p:nvPr/>
         </p:nvPicPr>
         <p:blipFill>
-          <a:blip r:embed="rId3"/>
+          <a:blip r:embed="rId2"/>
           <a:stretch>
             <a:fillRect/>
           </a:stretch>
@@ -5449,33 +5305,9 @@
         <p:nvPr/>
       </p:nvGrpSpPr>
       <p:grpSpPr/>
-      <p:pic>
-        <p:nvPicPr>
-          <p:cNvPr id="2" name="Picture 1" descr="textura-papel.jpeg"/>
-          <p:cNvPicPr>
-            <a:picLocks noChangeAspect="1"/>
-          </p:cNvPicPr>
-          <p:nvPr/>
-        </p:nvPicPr>
-        <p:blipFill>
-          <a:blip r:embed="rId2"/>
-          <a:stretch>
-            <a:fillRect/>
-          </a:stretch>
-        </p:blipFill>
-        <p:spPr>
-          <a:xfrm>
-            <a:off x="0" y="0"/>
-            <a:ext cx="18288000" cy="10287000"/>
-          </a:xfrm>
-          <a:prstGeom prst="rect">
-            <a:avLst/>
-          </a:prstGeom>
-        </p:spPr>
-      </p:pic>
-      <p:sp>
-        <p:nvSpPr>
-          <p:cNvPr id="3" name="TextBox 2"/>
+      <p:sp>
+        <p:nvSpPr>
+          <p:cNvPr id="2" name="TextBox 1"/>
           <p:cNvSpPr txBox="1"/>
           <p:nvPr/>
         </p:nvSpPr>
@@ -5509,7 +5341,7 @@
       </p:sp>
       <p:sp>
         <p:nvSpPr>
-          <p:cNvPr id="4" name="TextBox 3"/>
+          <p:cNvPr id="3" name="TextBox 2"/>
           <p:cNvSpPr txBox="1"/>
           <p:nvPr/>
         </p:nvSpPr>
@@ -5561,7 +5393,7 @@
       </p:sp>
       <p:sp>
         <p:nvSpPr>
-          <p:cNvPr id="5" name="Rectangle 4"/>
+          <p:cNvPr id="4" name="Rectangle 3"/>
           <p:cNvSpPr/>
           <p:nvPr/>
         </p:nvSpPr>
@@ -5605,7 +5437,7 @@
       </p:sp>
       <p:sp>
         <p:nvSpPr>
-          <p:cNvPr id="6" name="TextBox 5"/>
+          <p:cNvPr id="5" name="TextBox 4"/>
           <p:cNvSpPr txBox="1"/>
           <p:nvPr/>
         </p:nvSpPr>
@@ -5639,7 +5471,7 @@
       </p:sp>
       <p:sp>
         <p:nvSpPr>
-          <p:cNvPr id="7" name="TextBox 6"/>
+          <p:cNvPr id="6" name="TextBox 5"/>
           <p:cNvSpPr txBox="1"/>
           <p:nvPr/>
         </p:nvSpPr>
@@ -5691,14 +5523,14 @@
       </p:sp>
       <p:pic>
         <p:nvPicPr>
-          <p:cNvPr id="8" name="Picture 7" descr="logo-ka.png"/>
+          <p:cNvPr id="7" name="Picture 6" descr="logo-ka.png"/>
           <p:cNvPicPr>
             <a:picLocks noChangeAspect="1"/>
           </p:cNvPicPr>
           <p:nvPr/>
         </p:nvPicPr>
         <p:blipFill>
-          <a:blip r:embed="rId3"/>
+          <a:blip r:embed="rId2"/>
           <a:stretch>
             <a:fillRect/>
           </a:stretch>
@@ -5739,33 +5571,9 @@
         <p:nvPr/>
       </p:nvGrpSpPr>
       <p:grpSpPr/>
-      <p:pic>
-        <p:nvPicPr>
-          <p:cNvPr id="2" name="Picture 1" descr="textura-papel.jpeg"/>
-          <p:cNvPicPr>
-            <a:picLocks noChangeAspect="1"/>
-          </p:cNvPicPr>
-          <p:nvPr/>
-        </p:nvPicPr>
-        <p:blipFill>
-          <a:blip r:embed="rId2"/>
-          <a:stretch>
-            <a:fillRect/>
-          </a:stretch>
-        </p:blipFill>
-        <p:spPr>
-          <a:xfrm>
-            <a:off x="0" y="0"/>
-            <a:ext cx="18288000" cy="10287000"/>
-          </a:xfrm>
-          <a:prstGeom prst="rect">
-            <a:avLst/>
-          </a:prstGeom>
-        </p:spPr>
-      </p:pic>
-      <p:sp>
-        <p:nvSpPr>
-          <p:cNvPr id="3" name="TextBox 2"/>
+      <p:sp>
+        <p:nvSpPr>
+          <p:cNvPr id="2" name="TextBox 1"/>
           <p:cNvSpPr txBox="1"/>
           <p:nvPr/>
         </p:nvSpPr>
@@ -5799,7 +5607,7 @@
       </p:sp>
       <p:sp>
         <p:nvSpPr>
-          <p:cNvPr id="4" name="TextBox 3"/>
+          <p:cNvPr id="3" name="TextBox 2"/>
           <p:cNvSpPr txBox="1"/>
           <p:nvPr/>
         </p:nvSpPr>
@@ -5833,7 +5641,7 @@
       </p:sp>
       <p:sp>
         <p:nvSpPr>
-          <p:cNvPr id="5" name="Rectangle 4"/>
+          <p:cNvPr id="4" name="Rectangle 3"/>
           <p:cNvSpPr/>
           <p:nvPr/>
         </p:nvSpPr>
@@ -5877,7 +5685,7 @@
       </p:sp>
       <p:sp>
         <p:nvSpPr>
-          <p:cNvPr id="6" name="TextBox 5"/>
+          <p:cNvPr id="5" name="TextBox 4"/>
           <p:cNvSpPr txBox="1"/>
           <p:nvPr/>
         </p:nvSpPr>
@@ -5933,7 +5741,7 @@
       </p:sp>
       <p:sp>
         <p:nvSpPr>
-          <p:cNvPr id="7" name="Rectangle 6"/>
+          <p:cNvPr id="6" name="Rectangle 5"/>
           <p:cNvSpPr/>
           <p:nvPr/>
         </p:nvSpPr>
@@ -5977,7 +5785,7 @@
       </p:sp>
       <p:sp>
         <p:nvSpPr>
-          <p:cNvPr id="8" name="TextBox 7"/>
+          <p:cNvPr id="7" name="TextBox 6"/>
           <p:cNvSpPr txBox="1"/>
           <p:nvPr/>
         </p:nvSpPr>
@@ -6033,7 +5841,7 @@
       </p:sp>
       <p:sp>
         <p:nvSpPr>
-          <p:cNvPr id="9" name="Rectangle 8"/>
+          <p:cNvPr id="8" name="Rectangle 7"/>
           <p:cNvSpPr/>
           <p:nvPr/>
         </p:nvSpPr>
@@ -6077,7 +5885,7 @@
       </p:sp>
       <p:sp>
         <p:nvSpPr>
-          <p:cNvPr id="10" name="TextBox 9"/>
+          <p:cNvPr id="9" name="TextBox 8"/>
           <p:cNvSpPr txBox="1"/>
           <p:nvPr/>
         </p:nvSpPr>
@@ -6133,7 +5941,7 @@
       </p:sp>
       <p:sp>
         <p:nvSpPr>
-          <p:cNvPr id="11" name="Rectangle 10"/>
+          <p:cNvPr id="10" name="Rectangle 9"/>
           <p:cNvSpPr/>
           <p:nvPr/>
         </p:nvSpPr>
@@ -6177,7 +5985,7 @@
       </p:sp>
       <p:sp>
         <p:nvSpPr>
-          <p:cNvPr id="12" name="TextBox 11"/>
+          <p:cNvPr id="11" name="TextBox 10"/>
           <p:cNvSpPr txBox="1"/>
           <p:nvPr/>
         </p:nvSpPr>
@@ -6233,7 +6041,7 @@
       </p:sp>
       <p:sp>
         <p:nvSpPr>
-          <p:cNvPr id="13" name="TextBox 12"/>
+          <p:cNvPr id="12" name="TextBox 11"/>
           <p:cNvSpPr txBox="1"/>
           <p:nvPr/>
         </p:nvSpPr>
@@ -6285,14 +6093,14 @@
       </p:sp>
       <p:pic>
         <p:nvPicPr>
-          <p:cNvPr id="14" name="Picture 13" descr="logo-ka.png"/>
+          <p:cNvPr id="13" name="Picture 12" descr="logo-ka.png"/>
           <p:cNvPicPr>
             <a:picLocks noChangeAspect="1"/>
           </p:cNvPicPr>
           <p:nvPr/>
         </p:nvPicPr>
         <p:blipFill>
-          <a:blip r:embed="rId3"/>
+          <a:blip r:embed="rId2"/>
           <a:stretch>
             <a:fillRect/>
           </a:stretch>
@@ -6333,33 +6141,9 @@
         <p:nvPr/>
       </p:nvGrpSpPr>
       <p:grpSpPr/>
-      <p:pic>
-        <p:nvPicPr>
-          <p:cNvPr id="2" name="Picture 1" descr="textura-papel.jpeg"/>
-          <p:cNvPicPr>
-            <a:picLocks noChangeAspect="1"/>
-          </p:cNvPicPr>
-          <p:nvPr/>
-        </p:nvPicPr>
-        <p:blipFill>
-          <a:blip r:embed="rId2"/>
-          <a:stretch>
-            <a:fillRect/>
-          </a:stretch>
-        </p:blipFill>
-        <p:spPr>
-          <a:xfrm>
-            <a:off x="0" y="0"/>
-            <a:ext cx="18288000" cy="10287000"/>
-          </a:xfrm>
-          <a:prstGeom prst="rect">
-            <a:avLst/>
-          </a:prstGeom>
-        </p:spPr>
-      </p:pic>
-      <p:sp>
-        <p:nvSpPr>
-          <p:cNvPr id="3" name="TextBox 2"/>
+      <p:sp>
+        <p:nvSpPr>
+          <p:cNvPr id="2" name="TextBox 1"/>
           <p:cNvSpPr txBox="1"/>
           <p:nvPr/>
         </p:nvSpPr>
@@ -6393,7 +6177,7 @@
       </p:sp>
       <p:sp>
         <p:nvSpPr>
-          <p:cNvPr id="4" name="TextBox 3"/>
+          <p:cNvPr id="3" name="TextBox 2"/>
           <p:cNvSpPr txBox="1"/>
           <p:nvPr/>
         </p:nvSpPr>
@@ -6427,7 +6211,7 @@
       </p:sp>
       <p:sp>
         <p:nvSpPr>
-          <p:cNvPr id="5" name="Rectangle 4"/>
+          <p:cNvPr id="4" name="Rectangle 3"/>
           <p:cNvSpPr/>
           <p:nvPr/>
         </p:nvSpPr>
@@ -6471,7 +6255,7 @@
       </p:sp>
       <p:sp>
         <p:nvSpPr>
-          <p:cNvPr id="6" name="TextBox 5"/>
+          <p:cNvPr id="5" name="TextBox 4"/>
           <p:cNvSpPr txBox="1"/>
           <p:nvPr/>
         </p:nvSpPr>
@@ -6505,7 +6289,7 @@
       </p:sp>
       <p:sp>
         <p:nvSpPr>
-          <p:cNvPr id="7" name="TextBox 6"/>
+          <p:cNvPr id="6" name="TextBox 5"/>
           <p:cNvSpPr txBox="1"/>
           <p:nvPr/>
         </p:nvSpPr>
@@ -6583,7 +6367,7 @@
       </p:sp>
       <p:sp>
         <p:nvSpPr>
-          <p:cNvPr id="8" name="Rectangle 7"/>
+          <p:cNvPr id="7" name="Rectangle 6"/>
           <p:cNvSpPr/>
           <p:nvPr/>
         </p:nvSpPr>
@@ -6627,7 +6411,7 @@
       </p:sp>
       <p:sp>
         <p:nvSpPr>
-          <p:cNvPr id="9" name="TextBox 8"/>
+          <p:cNvPr id="8" name="TextBox 7"/>
           <p:cNvSpPr txBox="1"/>
           <p:nvPr/>
         </p:nvSpPr>
@@ -6661,7 +6445,7 @@
       </p:sp>
       <p:sp>
         <p:nvSpPr>
-          <p:cNvPr id="10" name="TextBox 9"/>
+          <p:cNvPr id="9" name="TextBox 8"/>
           <p:cNvSpPr txBox="1"/>
           <p:nvPr/>
         </p:nvSpPr>
@@ -6739,7 +6523,7 @@
       </p:sp>
       <p:sp>
         <p:nvSpPr>
-          <p:cNvPr id="11" name="TextBox 10"/>
+          <p:cNvPr id="10" name="TextBox 9"/>
           <p:cNvSpPr txBox="1"/>
           <p:nvPr/>
         </p:nvSpPr>
@@ -6791,14 +6575,14 @@
       </p:sp>
       <p:pic>
         <p:nvPicPr>
-          <p:cNvPr id="12" name="Picture 11" descr="logo-ka.png"/>
+          <p:cNvPr id="11" name="Picture 10" descr="logo-ka.png"/>
           <p:cNvPicPr>
             <a:picLocks noChangeAspect="1"/>
           </p:cNvPicPr>
           <p:nvPr/>
         </p:nvPicPr>
         <p:blipFill>
-          <a:blip r:embed="rId3"/>
+          <a:blip r:embed="rId2"/>
           <a:stretch>
             <a:fillRect/>
           </a:stretch>

</xml_diff>

<commit_message>
Ajusta fundos, remove rodapé/logo e unifica fonte Outfit
Capa e sumário passam a usar fundo cinza (como os divisores), remove o
texto de rodapé e o logotipo KA de todos os slides e padroniza toda a
tipografia na fonte Outfit.

https://claude.ai/code/session_01ESkoLizKf58nxwpm6ofywL
</commit_message>
<xml_diff>
--- a/MODELO-BASE-ESTRATEGICA.pptx
+++ b/MODELO-BASE-ESTRATEGICA.pptx
@@ -3107,7 +3107,7 @@
       <p:grpSpPr/>
       <p:pic>
         <p:nvPicPr>
-          <p:cNvPr id="2" name="Picture 1" descr="logo-ka.png"/>
+          <p:cNvPr id="2" name="Picture 1" descr="textura-papel.jpeg"/>
           <p:cNvPicPr>
             <a:picLocks noChangeAspect="1"/>
           </p:cNvPicPr>
@@ -3121,8 +3121,8 @@
         </p:blipFill>
         <p:spPr>
           <a:xfrm>
-            <a:off x="365760" y="274320"/>
-            <a:ext cx="2926080" cy="914400"/>
+            <a:off x="0" y="0"/>
+            <a:ext cx="18288000" cy="10287000"/>
           </a:xfrm>
           <a:prstGeom prst="rect">
             <a:avLst/>
@@ -3297,7 +3297,7 @@
                 <a:solidFill>
                   <a:srgbClr val="1A1A1A"/>
                 </a:solidFill>
-                <a:latin typeface="Playfair Display"/>
+                <a:latin typeface="Outfit"/>
               </a:rPr>
               <a:t>©</a:t>
             </a:r>
@@ -3398,30 +3398,6 @@
           </a:p>
         </p:txBody>
       </p:sp>
-      <p:pic>
-        <p:nvPicPr>
-          <p:cNvPr id="4" name="Picture 3" descr="logo-ka.png"/>
-          <p:cNvPicPr>
-            <a:picLocks noChangeAspect="1"/>
-          </p:cNvPicPr>
-          <p:nvPr/>
-        </p:nvPicPr>
-        <p:blipFill>
-          <a:blip r:embed="rId2"/>
-          <a:stretch>
-            <a:fillRect/>
-          </a:stretch>
-        </p:blipFill>
-        <p:spPr>
-          <a:xfrm>
-            <a:off x="1554480" y="8046720"/>
-            <a:ext cx="2926080" cy="914400"/>
-          </a:xfrm>
-          <a:prstGeom prst="rect">
-            <a:avLst/>
-          </a:prstGeom>
-        </p:spPr>
-      </p:pic>
     </p:spTree>
   </p:cSld>
   <p:clrMapOvr>
@@ -3448,707 +3424,9 @@
         <p:nvPr/>
       </p:nvGrpSpPr>
       <p:grpSpPr/>
-      <p:sp>
-        <p:nvSpPr>
-          <p:cNvPr id="2" name="TextBox 1"/>
-          <p:cNvSpPr txBox="1"/>
-          <p:nvPr/>
-        </p:nvSpPr>
-        <p:spPr>
-          <a:xfrm>
-            <a:off x="1737360" y="822960"/>
-            <a:ext cx="9144000" cy="1463040"/>
-          </a:xfrm>
-          <a:prstGeom prst="rect">
-            <a:avLst/>
-          </a:prstGeom>
-          <a:noFill/>
-        </p:spPr>
-        <p:txBody>
-          <a:bodyPr wrap="square">
-            <a:spAutoFit/>
-          </a:bodyPr>
-          <a:lstStyle/>
-          <a:p>
-            <a:r>
-              <a:rPr sz="7800" b="1" i="0">
-                <a:solidFill>
-                  <a:srgbClr val="000000"/>
-                </a:solidFill>
-                <a:latin typeface="Outfit"/>
-              </a:rPr>
-              <a:t>SUMÁRIO</a:t>
-            </a:r>
-          </a:p>
-        </p:txBody>
-      </p:sp>
-      <p:sp>
-        <p:nvSpPr>
-          <p:cNvPr id="3" name="TextBox 2"/>
-          <p:cNvSpPr txBox="1"/>
-          <p:nvPr/>
-        </p:nvSpPr>
-        <p:spPr>
-          <a:xfrm>
-            <a:off x="1737360" y="2395728"/>
-            <a:ext cx="1280160" cy="914400"/>
-          </a:xfrm>
-          <a:prstGeom prst="rect">
-            <a:avLst/>
-          </a:prstGeom>
-          <a:noFill/>
-        </p:spPr>
-        <p:txBody>
-          <a:bodyPr wrap="square">
-            <a:spAutoFit/>
-          </a:bodyPr>
-          <a:lstStyle/>
-          <a:p>
-            <a:r>
-              <a:rPr sz="4300" b="1" i="0">
-                <a:solidFill>
-                  <a:srgbClr val="1A1A1A"/>
-                </a:solidFill>
-                <a:latin typeface="Outfit"/>
-              </a:rPr>
-              <a:t>01</a:t>
-            </a:r>
-          </a:p>
-        </p:txBody>
-      </p:sp>
-      <p:sp>
-        <p:nvSpPr>
-          <p:cNvPr id="4" name="TextBox 3"/>
-          <p:cNvSpPr txBox="1"/>
-          <p:nvPr/>
-        </p:nvSpPr>
-        <p:spPr>
-          <a:xfrm>
-            <a:off x="3063239" y="2560320"/>
-            <a:ext cx="6217920" cy="914400"/>
-          </a:xfrm>
-          <a:prstGeom prst="rect">
-            <a:avLst/>
-          </a:prstGeom>
-          <a:noFill/>
-        </p:spPr>
-        <p:txBody>
-          <a:bodyPr wrap="square">
-            <a:spAutoFit/>
-          </a:bodyPr>
-          <a:lstStyle/>
-          <a:p>
-            <a:r>
-              <a:rPr sz="3000" b="0" i="0">
-                <a:solidFill>
-                  <a:srgbClr val="7A7A72"/>
-                </a:solidFill>
-                <a:latin typeface="Outfit"/>
-              </a:rPr>
-              <a:t>Leitura do momento da marca</a:t>
-            </a:r>
-          </a:p>
-        </p:txBody>
-      </p:sp>
-      <p:sp>
-        <p:nvSpPr>
-          <p:cNvPr id="5" name="TextBox 4"/>
-          <p:cNvSpPr txBox="1"/>
-          <p:nvPr/>
-        </p:nvSpPr>
-        <p:spPr>
-          <a:xfrm>
-            <a:off x="1737360" y="3456432"/>
-            <a:ext cx="1280160" cy="914400"/>
-          </a:xfrm>
-          <a:prstGeom prst="rect">
-            <a:avLst/>
-          </a:prstGeom>
-          <a:noFill/>
-        </p:spPr>
-        <p:txBody>
-          <a:bodyPr wrap="square">
-            <a:spAutoFit/>
-          </a:bodyPr>
-          <a:lstStyle/>
-          <a:p>
-            <a:r>
-              <a:rPr sz="4300" b="1" i="0">
-                <a:solidFill>
-                  <a:srgbClr val="1A1A1A"/>
-                </a:solidFill>
-                <a:latin typeface="Outfit"/>
-              </a:rPr>
-              <a:t>02</a:t>
-            </a:r>
-          </a:p>
-        </p:txBody>
-      </p:sp>
-      <p:sp>
-        <p:nvSpPr>
-          <p:cNvPr id="6" name="TextBox 5"/>
-          <p:cNvSpPr txBox="1"/>
-          <p:nvPr/>
-        </p:nvSpPr>
-        <p:spPr>
-          <a:xfrm>
-            <a:off x="3063239" y="3621024"/>
-            <a:ext cx="6217920" cy="914400"/>
-          </a:xfrm>
-          <a:prstGeom prst="rect">
-            <a:avLst/>
-          </a:prstGeom>
-          <a:noFill/>
-        </p:spPr>
-        <p:txBody>
-          <a:bodyPr wrap="square">
-            <a:spAutoFit/>
-          </a:bodyPr>
-          <a:lstStyle/>
-          <a:p>
-            <a:r>
-              <a:rPr sz="3000" b="0" i="0">
-                <a:solidFill>
-                  <a:srgbClr val="7A7A72"/>
-                </a:solidFill>
-                <a:latin typeface="Outfit"/>
-              </a:rPr>
-              <a:t>Definição central da marca</a:t>
-            </a:r>
-          </a:p>
-        </p:txBody>
-      </p:sp>
-      <p:sp>
-        <p:nvSpPr>
-          <p:cNvPr id="7" name="TextBox 6"/>
-          <p:cNvSpPr txBox="1"/>
-          <p:nvPr/>
-        </p:nvSpPr>
-        <p:spPr>
-          <a:xfrm>
-            <a:off x="1737360" y="4517136"/>
-            <a:ext cx="1280160" cy="914400"/>
-          </a:xfrm>
-          <a:prstGeom prst="rect">
-            <a:avLst/>
-          </a:prstGeom>
-          <a:noFill/>
-        </p:spPr>
-        <p:txBody>
-          <a:bodyPr wrap="square">
-            <a:spAutoFit/>
-          </a:bodyPr>
-          <a:lstStyle/>
-          <a:p>
-            <a:r>
-              <a:rPr sz="4300" b="1" i="0">
-                <a:solidFill>
-                  <a:srgbClr val="1A1A1A"/>
-                </a:solidFill>
-                <a:latin typeface="Outfit"/>
-              </a:rPr>
-              <a:t>03</a:t>
-            </a:r>
-          </a:p>
-        </p:txBody>
-      </p:sp>
-      <p:sp>
-        <p:nvSpPr>
-          <p:cNvPr id="8" name="TextBox 7"/>
-          <p:cNvSpPr txBox="1"/>
-          <p:nvPr/>
-        </p:nvSpPr>
-        <p:spPr>
-          <a:xfrm>
-            <a:off x="3063239" y="4681728"/>
-            <a:ext cx="6217920" cy="914400"/>
-          </a:xfrm>
-          <a:prstGeom prst="rect">
-            <a:avLst/>
-          </a:prstGeom>
-          <a:noFill/>
-        </p:spPr>
-        <p:txBody>
-          <a:bodyPr wrap="square">
-            <a:spAutoFit/>
-          </a:bodyPr>
-          <a:lstStyle/>
-          <a:p>
-            <a:r>
-              <a:rPr sz="3000" b="0" i="0">
-                <a:solidFill>
-                  <a:srgbClr val="7A7A72"/>
-                </a:solidFill>
-                <a:latin typeface="Outfit"/>
-              </a:rPr>
-              <a:t>Causa, liderança e tribo</a:t>
-            </a:r>
-          </a:p>
-        </p:txBody>
-      </p:sp>
-      <p:sp>
-        <p:nvSpPr>
-          <p:cNvPr id="9" name="TextBox 8"/>
-          <p:cNvSpPr txBox="1"/>
-          <p:nvPr/>
-        </p:nvSpPr>
-        <p:spPr>
-          <a:xfrm>
-            <a:off x="1737360" y="5577840"/>
-            <a:ext cx="1280160" cy="914400"/>
-          </a:xfrm>
-          <a:prstGeom prst="rect">
-            <a:avLst/>
-          </a:prstGeom>
-          <a:noFill/>
-        </p:spPr>
-        <p:txBody>
-          <a:bodyPr wrap="square">
-            <a:spAutoFit/>
-          </a:bodyPr>
-          <a:lstStyle/>
-          <a:p>
-            <a:r>
-              <a:rPr sz="4300" b="1" i="0">
-                <a:solidFill>
-                  <a:srgbClr val="1A1A1A"/>
-                </a:solidFill>
-                <a:latin typeface="Outfit"/>
-              </a:rPr>
-              <a:t>04</a:t>
-            </a:r>
-          </a:p>
-        </p:txBody>
-      </p:sp>
-      <p:sp>
-        <p:nvSpPr>
-          <p:cNvPr id="10" name="TextBox 9"/>
-          <p:cNvSpPr txBox="1"/>
-          <p:nvPr/>
-        </p:nvSpPr>
-        <p:spPr>
-          <a:xfrm>
-            <a:off x="3063239" y="5742431"/>
-            <a:ext cx="6217920" cy="914400"/>
-          </a:xfrm>
-          <a:prstGeom prst="rect">
-            <a:avLst/>
-          </a:prstGeom>
-          <a:noFill/>
-        </p:spPr>
-        <p:txBody>
-          <a:bodyPr wrap="square">
-            <a:spAutoFit/>
-          </a:bodyPr>
-          <a:lstStyle/>
-          <a:p>
-            <a:r>
-              <a:rPr sz="3000" b="0" i="0">
-                <a:solidFill>
-                  <a:srgbClr val="7A7A72"/>
-                </a:solidFill>
-                <a:latin typeface="Outfit"/>
-              </a:rPr>
-              <a:t>Golden Circle</a:t>
-            </a:r>
-          </a:p>
-        </p:txBody>
-      </p:sp>
-      <p:sp>
-        <p:nvSpPr>
-          <p:cNvPr id="11" name="TextBox 10"/>
-          <p:cNvSpPr txBox="1"/>
-          <p:nvPr/>
-        </p:nvSpPr>
-        <p:spPr>
-          <a:xfrm>
-            <a:off x="1737360" y="6638544"/>
-            <a:ext cx="1280160" cy="914400"/>
-          </a:xfrm>
-          <a:prstGeom prst="rect">
-            <a:avLst/>
-          </a:prstGeom>
-          <a:noFill/>
-        </p:spPr>
-        <p:txBody>
-          <a:bodyPr wrap="square">
-            <a:spAutoFit/>
-          </a:bodyPr>
-          <a:lstStyle/>
-          <a:p>
-            <a:r>
-              <a:rPr sz="4300" b="1" i="0">
-                <a:solidFill>
-                  <a:srgbClr val="1A1A1A"/>
-                </a:solidFill>
-                <a:latin typeface="Outfit"/>
-              </a:rPr>
-              <a:t>05</a:t>
-            </a:r>
-          </a:p>
-        </p:txBody>
-      </p:sp>
-      <p:sp>
-        <p:nvSpPr>
-          <p:cNvPr id="12" name="TextBox 11"/>
-          <p:cNvSpPr txBox="1"/>
-          <p:nvPr/>
-        </p:nvSpPr>
-        <p:spPr>
-          <a:xfrm>
-            <a:off x="3063239" y="6803136"/>
-            <a:ext cx="6217920" cy="914400"/>
-          </a:xfrm>
-          <a:prstGeom prst="rect">
-            <a:avLst/>
-          </a:prstGeom>
-          <a:noFill/>
-        </p:spPr>
-        <p:txBody>
-          <a:bodyPr wrap="square">
-            <a:spAutoFit/>
-          </a:bodyPr>
-          <a:lstStyle/>
-          <a:p>
-            <a:r>
-              <a:rPr sz="3000" b="0" i="0">
-                <a:solidFill>
-                  <a:srgbClr val="7A7A72"/>
-                </a:solidFill>
-                <a:latin typeface="Outfit"/>
-              </a:rPr>
-              <a:t>Proposta de valor e posicionamento</a:t>
-            </a:r>
-          </a:p>
-        </p:txBody>
-      </p:sp>
-      <p:sp>
-        <p:nvSpPr>
-          <p:cNvPr id="13" name="TextBox 12"/>
-          <p:cNvSpPr txBox="1"/>
-          <p:nvPr/>
-        </p:nvSpPr>
-        <p:spPr>
-          <a:xfrm>
-            <a:off x="9701784" y="2395728"/>
-            <a:ext cx="1280160" cy="914400"/>
-          </a:xfrm>
-          <a:prstGeom prst="rect">
-            <a:avLst/>
-          </a:prstGeom>
-          <a:noFill/>
-        </p:spPr>
-        <p:txBody>
-          <a:bodyPr wrap="square">
-            <a:spAutoFit/>
-          </a:bodyPr>
-          <a:lstStyle/>
-          <a:p>
-            <a:r>
-              <a:rPr sz="4300" b="1" i="0">
-                <a:solidFill>
-                  <a:srgbClr val="1A1A1A"/>
-                </a:solidFill>
-                <a:latin typeface="Outfit"/>
-              </a:rPr>
-              <a:t>06</a:t>
-            </a:r>
-          </a:p>
-        </p:txBody>
-      </p:sp>
-      <p:sp>
-        <p:nvSpPr>
-          <p:cNvPr id="14" name="TextBox 13"/>
-          <p:cNvSpPr txBox="1"/>
-          <p:nvPr/>
-        </p:nvSpPr>
-        <p:spPr>
-          <a:xfrm>
-            <a:off x="11027663" y="2560320"/>
-            <a:ext cx="6217920" cy="914400"/>
-          </a:xfrm>
-          <a:prstGeom prst="rect">
-            <a:avLst/>
-          </a:prstGeom>
-          <a:noFill/>
-        </p:spPr>
-        <p:txBody>
-          <a:bodyPr wrap="square">
-            <a:spAutoFit/>
-          </a:bodyPr>
-          <a:lstStyle/>
-          <a:p>
-            <a:r>
-              <a:rPr sz="3000" b="0" i="0">
-                <a:solidFill>
-                  <a:srgbClr val="7A7A72"/>
-                </a:solidFill>
-                <a:latin typeface="Outfit"/>
-              </a:rPr>
-              <a:t>Arquitetura de marca</a:t>
-            </a:r>
-          </a:p>
-        </p:txBody>
-      </p:sp>
-      <p:sp>
-        <p:nvSpPr>
-          <p:cNvPr id="15" name="TextBox 14"/>
-          <p:cNvSpPr txBox="1"/>
-          <p:nvPr/>
-        </p:nvSpPr>
-        <p:spPr>
-          <a:xfrm>
-            <a:off x="9701784" y="3520440"/>
-            <a:ext cx="1280160" cy="914400"/>
-          </a:xfrm>
-          <a:prstGeom prst="rect">
-            <a:avLst/>
-          </a:prstGeom>
-          <a:noFill/>
-        </p:spPr>
-        <p:txBody>
-          <a:bodyPr wrap="square">
-            <a:spAutoFit/>
-          </a:bodyPr>
-          <a:lstStyle/>
-          <a:p>
-            <a:r>
-              <a:rPr sz="4300" b="1" i="0">
-                <a:solidFill>
-                  <a:srgbClr val="1A1A1A"/>
-                </a:solidFill>
-                <a:latin typeface="Outfit"/>
-              </a:rPr>
-              <a:t>07</a:t>
-            </a:r>
-          </a:p>
-        </p:txBody>
-      </p:sp>
-      <p:sp>
-        <p:nvSpPr>
-          <p:cNvPr id="16" name="TextBox 15"/>
-          <p:cNvSpPr txBox="1"/>
-          <p:nvPr/>
-        </p:nvSpPr>
-        <p:spPr>
-          <a:xfrm>
-            <a:off x="11027663" y="3685032"/>
-            <a:ext cx="6217920" cy="914400"/>
-          </a:xfrm>
-          <a:prstGeom prst="rect">
-            <a:avLst/>
-          </a:prstGeom>
-          <a:noFill/>
-        </p:spPr>
-        <p:txBody>
-          <a:bodyPr wrap="square">
-            <a:spAutoFit/>
-          </a:bodyPr>
-          <a:lstStyle/>
-          <a:p>
-            <a:r>
-              <a:rPr sz="3000" b="0" i="0">
-                <a:solidFill>
-                  <a:srgbClr val="7A7A72"/>
-                </a:solidFill>
-                <a:latin typeface="Outfit"/>
-              </a:rPr>
-              <a:t>Territórios, pilares e público</a:t>
-            </a:r>
-          </a:p>
-        </p:txBody>
-      </p:sp>
-      <p:sp>
-        <p:nvSpPr>
-          <p:cNvPr id="17" name="TextBox 16"/>
-          <p:cNvSpPr txBox="1"/>
-          <p:nvPr/>
-        </p:nvSpPr>
-        <p:spPr>
-          <a:xfrm>
-            <a:off x="9701784" y="4645152"/>
-            <a:ext cx="1280160" cy="914400"/>
-          </a:xfrm>
-          <a:prstGeom prst="rect">
-            <a:avLst/>
-          </a:prstGeom>
-          <a:noFill/>
-        </p:spPr>
-        <p:txBody>
-          <a:bodyPr wrap="square">
-            <a:spAutoFit/>
-          </a:bodyPr>
-          <a:lstStyle/>
-          <a:p>
-            <a:r>
-              <a:rPr sz="4300" b="1" i="0">
-                <a:solidFill>
-                  <a:srgbClr val="1A1A1A"/>
-                </a:solidFill>
-                <a:latin typeface="Outfit"/>
-              </a:rPr>
-              <a:t>08</a:t>
-            </a:r>
-          </a:p>
-        </p:txBody>
-      </p:sp>
-      <p:sp>
-        <p:nvSpPr>
-          <p:cNvPr id="18" name="TextBox 17"/>
-          <p:cNvSpPr txBox="1"/>
-          <p:nvPr/>
-        </p:nvSpPr>
-        <p:spPr>
-          <a:xfrm>
-            <a:off x="11027663" y="4809744"/>
-            <a:ext cx="6217920" cy="914400"/>
-          </a:xfrm>
-          <a:prstGeom prst="rect">
-            <a:avLst/>
-          </a:prstGeom>
-          <a:noFill/>
-        </p:spPr>
-        <p:txBody>
-          <a:bodyPr wrap="square">
-            <a:spAutoFit/>
-          </a:bodyPr>
-          <a:lstStyle/>
-          <a:p>
-            <a:r>
-              <a:rPr sz="3000" b="0" i="0">
-                <a:solidFill>
-                  <a:srgbClr val="7A7A72"/>
-                </a:solidFill>
-                <a:latin typeface="Outfit"/>
-              </a:rPr>
-              <a:t>Personalidade e tom de voz</a:t>
-            </a:r>
-          </a:p>
-        </p:txBody>
-      </p:sp>
-      <p:sp>
-        <p:nvSpPr>
-          <p:cNvPr id="19" name="TextBox 18"/>
-          <p:cNvSpPr txBox="1"/>
-          <p:nvPr/>
-        </p:nvSpPr>
-        <p:spPr>
-          <a:xfrm>
-            <a:off x="9701784" y="5989320"/>
-            <a:ext cx="1280160" cy="914400"/>
-          </a:xfrm>
-          <a:prstGeom prst="rect">
-            <a:avLst/>
-          </a:prstGeom>
-          <a:noFill/>
-        </p:spPr>
-        <p:txBody>
-          <a:bodyPr wrap="square">
-            <a:spAutoFit/>
-          </a:bodyPr>
-          <a:lstStyle/>
-          <a:p>
-            <a:r>
-              <a:rPr sz="4300" b="1" i="0">
-                <a:solidFill>
-                  <a:srgbClr val="1A1A1A"/>
-                </a:solidFill>
-                <a:latin typeface="Outfit"/>
-              </a:rPr>
-              <a:t>09</a:t>
-            </a:r>
-          </a:p>
-        </p:txBody>
-      </p:sp>
-      <p:sp>
-        <p:nvSpPr>
-          <p:cNvPr id="20" name="TextBox 19"/>
-          <p:cNvSpPr txBox="1"/>
-          <p:nvPr/>
-        </p:nvSpPr>
-        <p:spPr>
-          <a:xfrm>
-            <a:off x="11027663" y="6153912"/>
-            <a:ext cx="6217920" cy="914400"/>
-          </a:xfrm>
-          <a:prstGeom prst="rect">
-            <a:avLst/>
-          </a:prstGeom>
-          <a:noFill/>
-        </p:spPr>
-        <p:txBody>
-          <a:bodyPr wrap="square">
-            <a:spAutoFit/>
-          </a:bodyPr>
-          <a:lstStyle/>
-          <a:p>
-            <a:r>
-              <a:rPr sz="3000" b="0" i="0">
-                <a:solidFill>
-                  <a:srgbClr val="7A7A72"/>
-                </a:solidFill>
-                <a:latin typeface="Outfit"/>
-              </a:rPr>
-              <a:t>Manifesto e síntese final</a:t>
-            </a:r>
-          </a:p>
-        </p:txBody>
-      </p:sp>
-      <p:sp>
-        <p:nvSpPr>
-          <p:cNvPr id="21" name="TextBox 20"/>
-          <p:cNvSpPr txBox="1"/>
-          <p:nvPr/>
-        </p:nvSpPr>
-        <p:spPr>
-          <a:xfrm>
-            <a:off x="822960" y="9601200"/>
-            <a:ext cx="10424160" cy="457200"/>
-          </a:xfrm>
-          <a:prstGeom prst="rect">
-            <a:avLst/>
-          </a:prstGeom>
-          <a:noFill/>
-        </p:spPr>
-        <p:txBody>
-          <a:bodyPr wrap="square">
-            <a:spAutoFit/>
-          </a:bodyPr>
-          <a:lstStyle/>
-          <a:p>
-            <a:r>
-              <a:rPr sz="1300" b="0" i="0" spc="150">
-                <a:solidFill>
-                  <a:srgbClr val="000000"/>
-                </a:solidFill>
-                <a:latin typeface="Outfit"/>
-              </a:rPr>
-              <a:t>BASE ESTRATÉGICA DA MARCA</a:t>
-            </a:r>
-            <a:r>
-              <a:rPr sz="1300" b="0" i="0">
-                <a:solidFill>
-                  <a:srgbClr val="000000"/>
-                </a:solidFill>
-                <a:latin typeface="Outfit"/>
-              </a:rPr>
-              <a:t>   |   </a:t>
-            </a:r>
-            <a:r>
-              <a:rPr sz="1300" b="1" i="0" spc="150">
-                <a:solidFill>
-                  <a:srgbClr val="000000"/>
-                </a:solidFill>
-                <a:latin typeface="Outfit"/>
-              </a:rPr>
-              <a:t>YUFIL</a:t>
-            </a:r>
-          </a:p>
-        </p:txBody>
-      </p:sp>
       <p:pic>
         <p:nvPicPr>
-          <p:cNvPr id="22" name="Picture 21" descr="logo-ka.png"/>
+          <p:cNvPr id="2" name="Picture 1" descr="textura-papel.jpeg"/>
           <p:cNvPicPr>
             <a:picLocks noChangeAspect="1"/>
           </p:cNvPicPr>
@@ -4162,14 +3440,660 @@
         </p:blipFill>
         <p:spPr>
           <a:xfrm>
-            <a:off x="16093440" y="9464040"/>
-            <a:ext cx="1737360" cy="566928"/>
+            <a:off x="0" y="0"/>
+            <a:ext cx="18288000" cy="10287000"/>
           </a:xfrm>
           <a:prstGeom prst="rect">
             <a:avLst/>
           </a:prstGeom>
         </p:spPr>
       </p:pic>
+      <p:sp>
+        <p:nvSpPr>
+          <p:cNvPr id="3" name="TextBox 2"/>
+          <p:cNvSpPr txBox="1"/>
+          <p:nvPr/>
+        </p:nvSpPr>
+        <p:spPr>
+          <a:xfrm>
+            <a:off x="1737360" y="822960"/>
+            <a:ext cx="9144000" cy="1463040"/>
+          </a:xfrm>
+          <a:prstGeom prst="rect">
+            <a:avLst/>
+          </a:prstGeom>
+          <a:noFill/>
+        </p:spPr>
+        <p:txBody>
+          <a:bodyPr wrap="square">
+            <a:spAutoFit/>
+          </a:bodyPr>
+          <a:lstStyle/>
+          <a:p>
+            <a:r>
+              <a:rPr sz="7800" b="1" i="0">
+                <a:solidFill>
+                  <a:srgbClr val="000000"/>
+                </a:solidFill>
+                <a:latin typeface="Outfit"/>
+              </a:rPr>
+              <a:t>SUMÁRIO</a:t>
+            </a:r>
+          </a:p>
+        </p:txBody>
+      </p:sp>
+      <p:sp>
+        <p:nvSpPr>
+          <p:cNvPr id="4" name="TextBox 3"/>
+          <p:cNvSpPr txBox="1"/>
+          <p:nvPr/>
+        </p:nvSpPr>
+        <p:spPr>
+          <a:xfrm>
+            <a:off x="1737360" y="2395728"/>
+            <a:ext cx="1280160" cy="914400"/>
+          </a:xfrm>
+          <a:prstGeom prst="rect">
+            <a:avLst/>
+          </a:prstGeom>
+          <a:noFill/>
+        </p:spPr>
+        <p:txBody>
+          <a:bodyPr wrap="square">
+            <a:spAutoFit/>
+          </a:bodyPr>
+          <a:lstStyle/>
+          <a:p>
+            <a:r>
+              <a:rPr sz="4300" b="1" i="0">
+                <a:solidFill>
+                  <a:srgbClr val="1A1A1A"/>
+                </a:solidFill>
+                <a:latin typeface="Outfit"/>
+              </a:rPr>
+              <a:t>01</a:t>
+            </a:r>
+          </a:p>
+        </p:txBody>
+      </p:sp>
+      <p:sp>
+        <p:nvSpPr>
+          <p:cNvPr id="5" name="TextBox 4"/>
+          <p:cNvSpPr txBox="1"/>
+          <p:nvPr/>
+        </p:nvSpPr>
+        <p:spPr>
+          <a:xfrm>
+            <a:off x="3063239" y="2560320"/>
+            <a:ext cx="6217920" cy="914400"/>
+          </a:xfrm>
+          <a:prstGeom prst="rect">
+            <a:avLst/>
+          </a:prstGeom>
+          <a:noFill/>
+        </p:spPr>
+        <p:txBody>
+          <a:bodyPr wrap="square">
+            <a:spAutoFit/>
+          </a:bodyPr>
+          <a:lstStyle/>
+          <a:p>
+            <a:r>
+              <a:rPr sz="3000" b="0" i="0">
+                <a:solidFill>
+                  <a:srgbClr val="7A7A72"/>
+                </a:solidFill>
+                <a:latin typeface="Outfit"/>
+              </a:rPr>
+              <a:t>Leitura do momento da marca</a:t>
+            </a:r>
+          </a:p>
+        </p:txBody>
+      </p:sp>
+      <p:sp>
+        <p:nvSpPr>
+          <p:cNvPr id="6" name="TextBox 5"/>
+          <p:cNvSpPr txBox="1"/>
+          <p:nvPr/>
+        </p:nvSpPr>
+        <p:spPr>
+          <a:xfrm>
+            <a:off x="1737360" y="3456432"/>
+            <a:ext cx="1280160" cy="914400"/>
+          </a:xfrm>
+          <a:prstGeom prst="rect">
+            <a:avLst/>
+          </a:prstGeom>
+          <a:noFill/>
+        </p:spPr>
+        <p:txBody>
+          <a:bodyPr wrap="square">
+            <a:spAutoFit/>
+          </a:bodyPr>
+          <a:lstStyle/>
+          <a:p>
+            <a:r>
+              <a:rPr sz="4300" b="1" i="0">
+                <a:solidFill>
+                  <a:srgbClr val="1A1A1A"/>
+                </a:solidFill>
+                <a:latin typeface="Outfit"/>
+              </a:rPr>
+              <a:t>02</a:t>
+            </a:r>
+          </a:p>
+        </p:txBody>
+      </p:sp>
+      <p:sp>
+        <p:nvSpPr>
+          <p:cNvPr id="7" name="TextBox 6"/>
+          <p:cNvSpPr txBox="1"/>
+          <p:nvPr/>
+        </p:nvSpPr>
+        <p:spPr>
+          <a:xfrm>
+            <a:off x="3063239" y="3621024"/>
+            <a:ext cx="6217920" cy="914400"/>
+          </a:xfrm>
+          <a:prstGeom prst="rect">
+            <a:avLst/>
+          </a:prstGeom>
+          <a:noFill/>
+        </p:spPr>
+        <p:txBody>
+          <a:bodyPr wrap="square">
+            <a:spAutoFit/>
+          </a:bodyPr>
+          <a:lstStyle/>
+          <a:p>
+            <a:r>
+              <a:rPr sz="3000" b="0" i="0">
+                <a:solidFill>
+                  <a:srgbClr val="7A7A72"/>
+                </a:solidFill>
+                <a:latin typeface="Outfit"/>
+              </a:rPr>
+              <a:t>Definição central da marca</a:t>
+            </a:r>
+          </a:p>
+        </p:txBody>
+      </p:sp>
+      <p:sp>
+        <p:nvSpPr>
+          <p:cNvPr id="8" name="TextBox 7"/>
+          <p:cNvSpPr txBox="1"/>
+          <p:nvPr/>
+        </p:nvSpPr>
+        <p:spPr>
+          <a:xfrm>
+            <a:off x="1737360" y="4517136"/>
+            <a:ext cx="1280160" cy="914400"/>
+          </a:xfrm>
+          <a:prstGeom prst="rect">
+            <a:avLst/>
+          </a:prstGeom>
+          <a:noFill/>
+        </p:spPr>
+        <p:txBody>
+          <a:bodyPr wrap="square">
+            <a:spAutoFit/>
+          </a:bodyPr>
+          <a:lstStyle/>
+          <a:p>
+            <a:r>
+              <a:rPr sz="4300" b="1" i="0">
+                <a:solidFill>
+                  <a:srgbClr val="1A1A1A"/>
+                </a:solidFill>
+                <a:latin typeface="Outfit"/>
+              </a:rPr>
+              <a:t>03</a:t>
+            </a:r>
+          </a:p>
+        </p:txBody>
+      </p:sp>
+      <p:sp>
+        <p:nvSpPr>
+          <p:cNvPr id="9" name="TextBox 8"/>
+          <p:cNvSpPr txBox="1"/>
+          <p:nvPr/>
+        </p:nvSpPr>
+        <p:spPr>
+          <a:xfrm>
+            <a:off x="3063239" y="4681728"/>
+            <a:ext cx="6217920" cy="914400"/>
+          </a:xfrm>
+          <a:prstGeom prst="rect">
+            <a:avLst/>
+          </a:prstGeom>
+          <a:noFill/>
+        </p:spPr>
+        <p:txBody>
+          <a:bodyPr wrap="square">
+            <a:spAutoFit/>
+          </a:bodyPr>
+          <a:lstStyle/>
+          <a:p>
+            <a:r>
+              <a:rPr sz="3000" b="0" i="0">
+                <a:solidFill>
+                  <a:srgbClr val="7A7A72"/>
+                </a:solidFill>
+                <a:latin typeface="Outfit"/>
+              </a:rPr>
+              <a:t>Causa, liderança e tribo</a:t>
+            </a:r>
+          </a:p>
+        </p:txBody>
+      </p:sp>
+      <p:sp>
+        <p:nvSpPr>
+          <p:cNvPr id="10" name="TextBox 9"/>
+          <p:cNvSpPr txBox="1"/>
+          <p:nvPr/>
+        </p:nvSpPr>
+        <p:spPr>
+          <a:xfrm>
+            <a:off x="1737360" y="5577840"/>
+            <a:ext cx="1280160" cy="914400"/>
+          </a:xfrm>
+          <a:prstGeom prst="rect">
+            <a:avLst/>
+          </a:prstGeom>
+          <a:noFill/>
+        </p:spPr>
+        <p:txBody>
+          <a:bodyPr wrap="square">
+            <a:spAutoFit/>
+          </a:bodyPr>
+          <a:lstStyle/>
+          <a:p>
+            <a:r>
+              <a:rPr sz="4300" b="1" i="0">
+                <a:solidFill>
+                  <a:srgbClr val="1A1A1A"/>
+                </a:solidFill>
+                <a:latin typeface="Outfit"/>
+              </a:rPr>
+              <a:t>04</a:t>
+            </a:r>
+          </a:p>
+        </p:txBody>
+      </p:sp>
+      <p:sp>
+        <p:nvSpPr>
+          <p:cNvPr id="11" name="TextBox 10"/>
+          <p:cNvSpPr txBox="1"/>
+          <p:nvPr/>
+        </p:nvSpPr>
+        <p:spPr>
+          <a:xfrm>
+            <a:off x="3063239" y="5742431"/>
+            <a:ext cx="6217920" cy="914400"/>
+          </a:xfrm>
+          <a:prstGeom prst="rect">
+            <a:avLst/>
+          </a:prstGeom>
+          <a:noFill/>
+        </p:spPr>
+        <p:txBody>
+          <a:bodyPr wrap="square">
+            <a:spAutoFit/>
+          </a:bodyPr>
+          <a:lstStyle/>
+          <a:p>
+            <a:r>
+              <a:rPr sz="3000" b="0" i="0">
+                <a:solidFill>
+                  <a:srgbClr val="7A7A72"/>
+                </a:solidFill>
+                <a:latin typeface="Outfit"/>
+              </a:rPr>
+              <a:t>Golden Circle</a:t>
+            </a:r>
+          </a:p>
+        </p:txBody>
+      </p:sp>
+      <p:sp>
+        <p:nvSpPr>
+          <p:cNvPr id="12" name="TextBox 11"/>
+          <p:cNvSpPr txBox="1"/>
+          <p:nvPr/>
+        </p:nvSpPr>
+        <p:spPr>
+          <a:xfrm>
+            <a:off x="1737360" y="6638544"/>
+            <a:ext cx="1280160" cy="914400"/>
+          </a:xfrm>
+          <a:prstGeom prst="rect">
+            <a:avLst/>
+          </a:prstGeom>
+          <a:noFill/>
+        </p:spPr>
+        <p:txBody>
+          <a:bodyPr wrap="square">
+            <a:spAutoFit/>
+          </a:bodyPr>
+          <a:lstStyle/>
+          <a:p>
+            <a:r>
+              <a:rPr sz="4300" b="1" i="0">
+                <a:solidFill>
+                  <a:srgbClr val="1A1A1A"/>
+                </a:solidFill>
+                <a:latin typeface="Outfit"/>
+              </a:rPr>
+              <a:t>05</a:t>
+            </a:r>
+          </a:p>
+        </p:txBody>
+      </p:sp>
+      <p:sp>
+        <p:nvSpPr>
+          <p:cNvPr id="13" name="TextBox 12"/>
+          <p:cNvSpPr txBox="1"/>
+          <p:nvPr/>
+        </p:nvSpPr>
+        <p:spPr>
+          <a:xfrm>
+            <a:off x="3063239" y="6803136"/>
+            <a:ext cx="6217920" cy="914400"/>
+          </a:xfrm>
+          <a:prstGeom prst="rect">
+            <a:avLst/>
+          </a:prstGeom>
+          <a:noFill/>
+        </p:spPr>
+        <p:txBody>
+          <a:bodyPr wrap="square">
+            <a:spAutoFit/>
+          </a:bodyPr>
+          <a:lstStyle/>
+          <a:p>
+            <a:r>
+              <a:rPr sz="3000" b="0" i="0">
+                <a:solidFill>
+                  <a:srgbClr val="7A7A72"/>
+                </a:solidFill>
+                <a:latin typeface="Outfit"/>
+              </a:rPr>
+              <a:t>Proposta de valor e posicionamento</a:t>
+            </a:r>
+          </a:p>
+        </p:txBody>
+      </p:sp>
+      <p:sp>
+        <p:nvSpPr>
+          <p:cNvPr id="14" name="TextBox 13"/>
+          <p:cNvSpPr txBox="1"/>
+          <p:nvPr/>
+        </p:nvSpPr>
+        <p:spPr>
+          <a:xfrm>
+            <a:off x="9701784" y="2395728"/>
+            <a:ext cx="1280160" cy="914400"/>
+          </a:xfrm>
+          <a:prstGeom prst="rect">
+            <a:avLst/>
+          </a:prstGeom>
+          <a:noFill/>
+        </p:spPr>
+        <p:txBody>
+          <a:bodyPr wrap="square">
+            <a:spAutoFit/>
+          </a:bodyPr>
+          <a:lstStyle/>
+          <a:p>
+            <a:r>
+              <a:rPr sz="4300" b="1" i="0">
+                <a:solidFill>
+                  <a:srgbClr val="1A1A1A"/>
+                </a:solidFill>
+                <a:latin typeface="Outfit"/>
+              </a:rPr>
+              <a:t>06</a:t>
+            </a:r>
+          </a:p>
+        </p:txBody>
+      </p:sp>
+      <p:sp>
+        <p:nvSpPr>
+          <p:cNvPr id="15" name="TextBox 14"/>
+          <p:cNvSpPr txBox="1"/>
+          <p:nvPr/>
+        </p:nvSpPr>
+        <p:spPr>
+          <a:xfrm>
+            <a:off x="11027663" y="2560320"/>
+            <a:ext cx="6217920" cy="914400"/>
+          </a:xfrm>
+          <a:prstGeom prst="rect">
+            <a:avLst/>
+          </a:prstGeom>
+          <a:noFill/>
+        </p:spPr>
+        <p:txBody>
+          <a:bodyPr wrap="square">
+            <a:spAutoFit/>
+          </a:bodyPr>
+          <a:lstStyle/>
+          <a:p>
+            <a:r>
+              <a:rPr sz="3000" b="0" i="0">
+                <a:solidFill>
+                  <a:srgbClr val="7A7A72"/>
+                </a:solidFill>
+                <a:latin typeface="Outfit"/>
+              </a:rPr>
+              <a:t>Arquitetura de marca</a:t>
+            </a:r>
+          </a:p>
+        </p:txBody>
+      </p:sp>
+      <p:sp>
+        <p:nvSpPr>
+          <p:cNvPr id="16" name="TextBox 15"/>
+          <p:cNvSpPr txBox="1"/>
+          <p:nvPr/>
+        </p:nvSpPr>
+        <p:spPr>
+          <a:xfrm>
+            <a:off x="9701784" y="3520440"/>
+            <a:ext cx="1280160" cy="914400"/>
+          </a:xfrm>
+          <a:prstGeom prst="rect">
+            <a:avLst/>
+          </a:prstGeom>
+          <a:noFill/>
+        </p:spPr>
+        <p:txBody>
+          <a:bodyPr wrap="square">
+            <a:spAutoFit/>
+          </a:bodyPr>
+          <a:lstStyle/>
+          <a:p>
+            <a:r>
+              <a:rPr sz="4300" b="1" i="0">
+                <a:solidFill>
+                  <a:srgbClr val="1A1A1A"/>
+                </a:solidFill>
+                <a:latin typeface="Outfit"/>
+              </a:rPr>
+              <a:t>07</a:t>
+            </a:r>
+          </a:p>
+        </p:txBody>
+      </p:sp>
+      <p:sp>
+        <p:nvSpPr>
+          <p:cNvPr id="17" name="TextBox 16"/>
+          <p:cNvSpPr txBox="1"/>
+          <p:nvPr/>
+        </p:nvSpPr>
+        <p:spPr>
+          <a:xfrm>
+            <a:off x="11027663" y="3685032"/>
+            <a:ext cx="6217920" cy="914400"/>
+          </a:xfrm>
+          <a:prstGeom prst="rect">
+            <a:avLst/>
+          </a:prstGeom>
+          <a:noFill/>
+        </p:spPr>
+        <p:txBody>
+          <a:bodyPr wrap="square">
+            <a:spAutoFit/>
+          </a:bodyPr>
+          <a:lstStyle/>
+          <a:p>
+            <a:r>
+              <a:rPr sz="3000" b="0" i="0">
+                <a:solidFill>
+                  <a:srgbClr val="7A7A72"/>
+                </a:solidFill>
+                <a:latin typeface="Outfit"/>
+              </a:rPr>
+              <a:t>Territórios, pilares e público</a:t>
+            </a:r>
+          </a:p>
+        </p:txBody>
+      </p:sp>
+      <p:sp>
+        <p:nvSpPr>
+          <p:cNvPr id="18" name="TextBox 17"/>
+          <p:cNvSpPr txBox="1"/>
+          <p:nvPr/>
+        </p:nvSpPr>
+        <p:spPr>
+          <a:xfrm>
+            <a:off x="9701784" y="4645152"/>
+            <a:ext cx="1280160" cy="914400"/>
+          </a:xfrm>
+          <a:prstGeom prst="rect">
+            <a:avLst/>
+          </a:prstGeom>
+          <a:noFill/>
+        </p:spPr>
+        <p:txBody>
+          <a:bodyPr wrap="square">
+            <a:spAutoFit/>
+          </a:bodyPr>
+          <a:lstStyle/>
+          <a:p>
+            <a:r>
+              <a:rPr sz="4300" b="1" i="0">
+                <a:solidFill>
+                  <a:srgbClr val="1A1A1A"/>
+                </a:solidFill>
+                <a:latin typeface="Outfit"/>
+              </a:rPr>
+              <a:t>08</a:t>
+            </a:r>
+          </a:p>
+        </p:txBody>
+      </p:sp>
+      <p:sp>
+        <p:nvSpPr>
+          <p:cNvPr id="19" name="TextBox 18"/>
+          <p:cNvSpPr txBox="1"/>
+          <p:nvPr/>
+        </p:nvSpPr>
+        <p:spPr>
+          <a:xfrm>
+            <a:off x="11027663" y="4809744"/>
+            <a:ext cx="6217920" cy="914400"/>
+          </a:xfrm>
+          <a:prstGeom prst="rect">
+            <a:avLst/>
+          </a:prstGeom>
+          <a:noFill/>
+        </p:spPr>
+        <p:txBody>
+          <a:bodyPr wrap="square">
+            <a:spAutoFit/>
+          </a:bodyPr>
+          <a:lstStyle/>
+          <a:p>
+            <a:r>
+              <a:rPr sz="3000" b="0" i="0">
+                <a:solidFill>
+                  <a:srgbClr val="7A7A72"/>
+                </a:solidFill>
+                <a:latin typeface="Outfit"/>
+              </a:rPr>
+              <a:t>Personalidade e tom de voz</a:t>
+            </a:r>
+          </a:p>
+        </p:txBody>
+      </p:sp>
+      <p:sp>
+        <p:nvSpPr>
+          <p:cNvPr id="20" name="TextBox 19"/>
+          <p:cNvSpPr txBox="1"/>
+          <p:nvPr/>
+        </p:nvSpPr>
+        <p:spPr>
+          <a:xfrm>
+            <a:off x="9701784" y="5989320"/>
+            <a:ext cx="1280160" cy="914400"/>
+          </a:xfrm>
+          <a:prstGeom prst="rect">
+            <a:avLst/>
+          </a:prstGeom>
+          <a:noFill/>
+        </p:spPr>
+        <p:txBody>
+          <a:bodyPr wrap="square">
+            <a:spAutoFit/>
+          </a:bodyPr>
+          <a:lstStyle/>
+          <a:p>
+            <a:r>
+              <a:rPr sz="4300" b="1" i="0">
+                <a:solidFill>
+                  <a:srgbClr val="1A1A1A"/>
+                </a:solidFill>
+                <a:latin typeface="Outfit"/>
+              </a:rPr>
+              <a:t>09</a:t>
+            </a:r>
+          </a:p>
+        </p:txBody>
+      </p:sp>
+      <p:sp>
+        <p:nvSpPr>
+          <p:cNvPr id="21" name="TextBox 20"/>
+          <p:cNvSpPr txBox="1"/>
+          <p:nvPr/>
+        </p:nvSpPr>
+        <p:spPr>
+          <a:xfrm>
+            <a:off x="11027663" y="6153912"/>
+            <a:ext cx="6217920" cy="914400"/>
+          </a:xfrm>
+          <a:prstGeom prst="rect">
+            <a:avLst/>
+          </a:prstGeom>
+          <a:noFill/>
+        </p:spPr>
+        <p:txBody>
+          <a:bodyPr wrap="square">
+            <a:spAutoFit/>
+          </a:bodyPr>
+          <a:lstStyle/>
+          <a:p>
+            <a:r>
+              <a:rPr sz="3000" b="0" i="0">
+                <a:solidFill>
+                  <a:srgbClr val="7A7A72"/>
+                </a:solidFill>
+                <a:latin typeface="Outfit"/>
+              </a:rPr>
+              <a:t>Manifesto e síntese final</a:t>
+            </a:r>
+          </a:p>
+        </p:txBody>
+      </p:sp>
     </p:spTree>
   </p:cSld>
   <p:clrMapOvr>
@@ -4263,82 +4187,6 @@
           </a:p>
         </p:txBody>
       </p:sp>
-      <p:sp>
-        <p:nvSpPr>
-          <p:cNvPr id="4" name="TextBox 3"/>
-          <p:cNvSpPr txBox="1"/>
-          <p:nvPr/>
-        </p:nvSpPr>
-        <p:spPr>
-          <a:xfrm>
-            <a:off x="822960" y="9601200"/>
-            <a:ext cx="10424160" cy="457200"/>
-          </a:xfrm>
-          <a:prstGeom prst="rect">
-            <a:avLst/>
-          </a:prstGeom>
-          <a:noFill/>
-        </p:spPr>
-        <p:txBody>
-          <a:bodyPr wrap="square">
-            <a:spAutoFit/>
-          </a:bodyPr>
-          <a:lstStyle/>
-          <a:p>
-            <a:r>
-              <a:rPr sz="1300" b="0" i="0" spc="150">
-                <a:solidFill>
-                  <a:srgbClr val="000000"/>
-                </a:solidFill>
-                <a:latin typeface="Outfit"/>
-              </a:rPr>
-              <a:t>BASE ESTRATÉGICA DA MARCA</a:t>
-            </a:r>
-            <a:r>
-              <a:rPr sz="1300" b="0" i="0">
-                <a:solidFill>
-                  <a:srgbClr val="000000"/>
-                </a:solidFill>
-                <a:latin typeface="Outfit"/>
-              </a:rPr>
-              <a:t>   |   </a:t>
-            </a:r>
-            <a:r>
-              <a:rPr sz="1300" b="1" i="0" spc="150">
-                <a:solidFill>
-                  <a:srgbClr val="000000"/>
-                </a:solidFill>
-                <a:latin typeface="Outfit"/>
-              </a:rPr>
-              <a:t>YUFIL</a:t>
-            </a:r>
-          </a:p>
-        </p:txBody>
-      </p:sp>
-      <p:pic>
-        <p:nvPicPr>
-          <p:cNvPr id="5" name="Picture 4" descr="logo-ka.png"/>
-          <p:cNvPicPr>
-            <a:picLocks noChangeAspect="1"/>
-          </p:cNvPicPr>
-          <p:nvPr/>
-        </p:nvPicPr>
-        <p:blipFill>
-          <a:blip r:embed="rId3"/>
-          <a:stretch>
-            <a:fillRect/>
-          </a:stretch>
-        </p:blipFill>
-        <p:spPr>
-          <a:xfrm>
-            <a:off x="16093440" y="9464040"/>
-            <a:ext cx="1737360" cy="566928"/>
-          </a:xfrm>
-          <a:prstGeom prst="rect">
-            <a:avLst/>
-          </a:prstGeom>
-        </p:spPr>
-      </p:pic>
     </p:spTree>
   </p:cSld>
   <p:clrMapOvr>
@@ -4494,82 +4342,6 @@
           </a:p>
         </p:txBody>
       </p:sp>
-      <p:sp>
-        <p:nvSpPr>
-          <p:cNvPr id="5" name="TextBox 4"/>
-          <p:cNvSpPr txBox="1"/>
-          <p:nvPr/>
-        </p:nvSpPr>
-        <p:spPr>
-          <a:xfrm>
-            <a:off x="822960" y="9601200"/>
-            <a:ext cx="10424160" cy="457200"/>
-          </a:xfrm>
-          <a:prstGeom prst="rect">
-            <a:avLst/>
-          </a:prstGeom>
-          <a:noFill/>
-        </p:spPr>
-        <p:txBody>
-          <a:bodyPr wrap="square">
-            <a:spAutoFit/>
-          </a:bodyPr>
-          <a:lstStyle/>
-          <a:p>
-            <a:r>
-              <a:rPr sz="1300" b="0" i="0" spc="150">
-                <a:solidFill>
-                  <a:srgbClr val="000000"/>
-                </a:solidFill>
-                <a:latin typeface="Outfit"/>
-              </a:rPr>
-              <a:t>BASE ESTRATÉGICA DA MARCA</a:t>
-            </a:r>
-            <a:r>
-              <a:rPr sz="1300" b="0" i="0">
-                <a:solidFill>
-                  <a:srgbClr val="000000"/>
-                </a:solidFill>
-                <a:latin typeface="Outfit"/>
-              </a:rPr>
-              <a:t>   |   </a:t>
-            </a:r>
-            <a:r>
-              <a:rPr sz="1300" b="1" i="0" spc="150">
-                <a:solidFill>
-                  <a:srgbClr val="000000"/>
-                </a:solidFill>
-                <a:latin typeface="Outfit"/>
-              </a:rPr>
-              <a:t>YUFIL</a:t>
-            </a:r>
-          </a:p>
-        </p:txBody>
-      </p:sp>
-      <p:pic>
-        <p:nvPicPr>
-          <p:cNvPr id="6" name="Picture 5" descr="logo-ka.png"/>
-          <p:cNvPicPr>
-            <a:picLocks noChangeAspect="1"/>
-          </p:cNvPicPr>
-          <p:nvPr/>
-        </p:nvPicPr>
-        <p:blipFill>
-          <a:blip r:embed="rId2"/>
-          <a:stretch>
-            <a:fillRect/>
-          </a:stretch>
-        </p:blipFill>
-        <p:spPr>
-          <a:xfrm>
-            <a:off x="16093440" y="9464040"/>
-            <a:ext cx="1737360" cy="566928"/>
-          </a:xfrm>
-          <a:prstGeom prst="rect">
-            <a:avLst/>
-          </a:prstGeom>
-        </p:spPr>
-      </p:pic>
     </p:spTree>
   </p:cSld>
   <p:clrMapOvr>
@@ -4802,7 +4574,7 @@
                 <a:solidFill>
                   <a:srgbClr val="1A1A1A"/>
                 </a:solidFill>
-                <a:latin typeface="Calibri"/>
+                <a:latin typeface="Outfit"/>
               </a:rPr>
               <a:t>“A mesma tesoura que tirou a minha visão foi a ferramenta que mudou a minha vida.”</a:t>
             </a:r>
@@ -4843,82 +4615,6 @@
           </a:p>
         </p:txBody>
       </p:sp>
-      <p:sp>
-        <p:nvSpPr>
-          <p:cNvPr id="8" name="TextBox 7"/>
-          <p:cNvSpPr txBox="1"/>
-          <p:nvPr/>
-        </p:nvSpPr>
-        <p:spPr>
-          <a:xfrm>
-            <a:off x="822960" y="9601200"/>
-            <a:ext cx="10424160" cy="457200"/>
-          </a:xfrm>
-          <a:prstGeom prst="rect">
-            <a:avLst/>
-          </a:prstGeom>
-          <a:noFill/>
-        </p:spPr>
-        <p:txBody>
-          <a:bodyPr wrap="square">
-            <a:spAutoFit/>
-          </a:bodyPr>
-          <a:lstStyle/>
-          <a:p>
-            <a:r>
-              <a:rPr sz="1300" b="0" i="0" spc="150">
-                <a:solidFill>
-                  <a:srgbClr val="000000"/>
-                </a:solidFill>
-                <a:latin typeface="Outfit"/>
-              </a:rPr>
-              <a:t>BASE ESTRATÉGICA DA MARCA</a:t>
-            </a:r>
-            <a:r>
-              <a:rPr sz="1300" b="0" i="0">
-                <a:solidFill>
-                  <a:srgbClr val="000000"/>
-                </a:solidFill>
-                <a:latin typeface="Outfit"/>
-              </a:rPr>
-              <a:t>   |   </a:t>
-            </a:r>
-            <a:r>
-              <a:rPr sz="1300" b="1" i="0" spc="150">
-                <a:solidFill>
-                  <a:srgbClr val="000000"/>
-                </a:solidFill>
-                <a:latin typeface="Outfit"/>
-              </a:rPr>
-              <a:t>YUFIL</a:t>
-            </a:r>
-          </a:p>
-        </p:txBody>
-      </p:sp>
-      <p:pic>
-        <p:nvPicPr>
-          <p:cNvPr id="9" name="Picture 8" descr="logo-ka.png"/>
-          <p:cNvPicPr>
-            <a:picLocks noChangeAspect="1"/>
-          </p:cNvPicPr>
-          <p:nvPr/>
-        </p:nvPicPr>
-        <p:blipFill>
-          <a:blip r:embed="rId2"/>
-          <a:stretch>
-            <a:fillRect/>
-          </a:stretch>
-        </p:blipFill>
-        <p:spPr>
-          <a:xfrm>
-            <a:off x="16093440" y="9464040"/>
-            <a:ext cx="1737360" cy="566928"/>
-          </a:xfrm>
-          <a:prstGeom prst="rect">
-            <a:avLst/>
-          </a:prstGeom>
-        </p:spPr>
-      </p:pic>
     </p:spTree>
   </p:cSld>
   <p:clrMapOvr>
@@ -5203,82 +4899,6 @@
           </a:p>
         </p:txBody>
       </p:sp>
-      <p:sp>
-        <p:nvSpPr>
-          <p:cNvPr id="7" name="TextBox 6"/>
-          <p:cNvSpPr txBox="1"/>
-          <p:nvPr/>
-        </p:nvSpPr>
-        <p:spPr>
-          <a:xfrm>
-            <a:off x="822960" y="9601200"/>
-            <a:ext cx="10424160" cy="457200"/>
-          </a:xfrm>
-          <a:prstGeom prst="rect">
-            <a:avLst/>
-          </a:prstGeom>
-          <a:noFill/>
-        </p:spPr>
-        <p:txBody>
-          <a:bodyPr wrap="square">
-            <a:spAutoFit/>
-          </a:bodyPr>
-          <a:lstStyle/>
-          <a:p>
-            <a:r>
-              <a:rPr sz="1300" b="0" i="0" spc="150">
-                <a:solidFill>
-                  <a:srgbClr val="000000"/>
-                </a:solidFill>
-                <a:latin typeface="Outfit"/>
-              </a:rPr>
-              <a:t>BASE ESTRATÉGICA DA MARCA</a:t>
-            </a:r>
-            <a:r>
-              <a:rPr sz="1300" b="0" i="0">
-                <a:solidFill>
-                  <a:srgbClr val="000000"/>
-                </a:solidFill>
-                <a:latin typeface="Outfit"/>
-              </a:rPr>
-              <a:t>   |   </a:t>
-            </a:r>
-            <a:r>
-              <a:rPr sz="1300" b="1" i="0" spc="150">
-                <a:solidFill>
-                  <a:srgbClr val="000000"/>
-                </a:solidFill>
-                <a:latin typeface="Outfit"/>
-              </a:rPr>
-              <a:t>YUFIL</a:t>
-            </a:r>
-          </a:p>
-        </p:txBody>
-      </p:sp>
-      <p:pic>
-        <p:nvPicPr>
-          <p:cNvPr id="8" name="Picture 7" descr="logo-ka.png"/>
-          <p:cNvPicPr>
-            <a:picLocks noChangeAspect="1"/>
-          </p:cNvPicPr>
-          <p:nvPr/>
-        </p:nvPicPr>
-        <p:blipFill>
-          <a:blip r:embed="rId2"/>
-          <a:stretch>
-            <a:fillRect/>
-          </a:stretch>
-        </p:blipFill>
-        <p:spPr>
-          <a:xfrm>
-            <a:off x="16093440" y="9464040"/>
-            <a:ext cx="1737360" cy="566928"/>
-          </a:xfrm>
-          <a:prstGeom prst="rect">
-            <a:avLst/>
-          </a:prstGeom>
-        </p:spPr>
-      </p:pic>
     </p:spTree>
   </p:cSld>
   <p:clrMapOvr>
@@ -5469,82 +5089,6 @@
           </a:p>
         </p:txBody>
       </p:sp>
-      <p:sp>
-        <p:nvSpPr>
-          <p:cNvPr id="6" name="TextBox 5"/>
-          <p:cNvSpPr txBox="1"/>
-          <p:nvPr/>
-        </p:nvSpPr>
-        <p:spPr>
-          <a:xfrm>
-            <a:off x="822960" y="9601200"/>
-            <a:ext cx="10424160" cy="457200"/>
-          </a:xfrm>
-          <a:prstGeom prst="rect">
-            <a:avLst/>
-          </a:prstGeom>
-          <a:noFill/>
-        </p:spPr>
-        <p:txBody>
-          <a:bodyPr wrap="square">
-            <a:spAutoFit/>
-          </a:bodyPr>
-          <a:lstStyle/>
-          <a:p>
-            <a:r>
-              <a:rPr sz="1300" b="0" i="0" spc="150">
-                <a:solidFill>
-                  <a:srgbClr val="000000"/>
-                </a:solidFill>
-                <a:latin typeface="Outfit"/>
-              </a:rPr>
-              <a:t>BASE ESTRATÉGICA DA MARCA</a:t>
-            </a:r>
-            <a:r>
-              <a:rPr sz="1300" b="0" i="0">
-                <a:solidFill>
-                  <a:srgbClr val="000000"/>
-                </a:solidFill>
-                <a:latin typeface="Outfit"/>
-              </a:rPr>
-              <a:t>   |   </a:t>
-            </a:r>
-            <a:r>
-              <a:rPr sz="1300" b="1" i="0" spc="150">
-                <a:solidFill>
-                  <a:srgbClr val="000000"/>
-                </a:solidFill>
-                <a:latin typeface="Outfit"/>
-              </a:rPr>
-              <a:t>YUFIL</a:t>
-            </a:r>
-          </a:p>
-        </p:txBody>
-      </p:sp>
-      <p:pic>
-        <p:nvPicPr>
-          <p:cNvPr id="7" name="Picture 6" descr="logo-ka.png"/>
-          <p:cNvPicPr>
-            <a:picLocks noChangeAspect="1"/>
-          </p:cNvPicPr>
-          <p:nvPr/>
-        </p:nvPicPr>
-        <p:blipFill>
-          <a:blip r:embed="rId2"/>
-          <a:stretch>
-            <a:fillRect/>
-          </a:stretch>
-        </p:blipFill>
-        <p:spPr>
-          <a:xfrm>
-            <a:off x="16093440" y="9464040"/>
-            <a:ext cx="1737360" cy="566928"/>
-          </a:xfrm>
-          <a:prstGeom prst="rect">
-            <a:avLst/>
-          </a:prstGeom>
-        </p:spPr>
-      </p:pic>
     </p:spTree>
   </p:cSld>
   <p:clrMapOvr>
@@ -6039,82 +5583,6 @@
           </a:p>
         </p:txBody>
       </p:sp>
-      <p:sp>
-        <p:nvSpPr>
-          <p:cNvPr id="12" name="TextBox 11"/>
-          <p:cNvSpPr txBox="1"/>
-          <p:nvPr/>
-        </p:nvSpPr>
-        <p:spPr>
-          <a:xfrm>
-            <a:off x="822960" y="9601200"/>
-            <a:ext cx="10424160" cy="457200"/>
-          </a:xfrm>
-          <a:prstGeom prst="rect">
-            <a:avLst/>
-          </a:prstGeom>
-          <a:noFill/>
-        </p:spPr>
-        <p:txBody>
-          <a:bodyPr wrap="square">
-            <a:spAutoFit/>
-          </a:bodyPr>
-          <a:lstStyle/>
-          <a:p>
-            <a:r>
-              <a:rPr sz="1300" b="0" i="0" spc="150">
-                <a:solidFill>
-                  <a:srgbClr val="000000"/>
-                </a:solidFill>
-                <a:latin typeface="Outfit"/>
-              </a:rPr>
-              <a:t>BASE ESTRATÉGICA DA MARCA</a:t>
-            </a:r>
-            <a:r>
-              <a:rPr sz="1300" b="0" i="0">
-                <a:solidFill>
-                  <a:srgbClr val="000000"/>
-                </a:solidFill>
-                <a:latin typeface="Outfit"/>
-              </a:rPr>
-              <a:t>   |   </a:t>
-            </a:r>
-            <a:r>
-              <a:rPr sz="1300" b="1" i="0" spc="150">
-                <a:solidFill>
-                  <a:srgbClr val="000000"/>
-                </a:solidFill>
-                <a:latin typeface="Outfit"/>
-              </a:rPr>
-              <a:t>YUFIL</a:t>
-            </a:r>
-          </a:p>
-        </p:txBody>
-      </p:sp>
-      <p:pic>
-        <p:nvPicPr>
-          <p:cNvPr id="13" name="Picture 12" descr="logo-ka.png"/>
-          <p:cNvPicPr>
-            <a:picLocks noChangeAspect="1"/>
-          </p:cNvPicPr>
-          <p:nvPr/>
-        </p:nvPicPr>
-        <p:blipFill>
-          <a:blip r:embed="rId2"/>
-          <a:stretch>
-            <a:fillRect/>
-          </a:stretch>
-        </p:blipFill>
-        <p:spPr>
-          <a:xfrm>
-            <a:off x="16093440" y="9464040"/>
-            <a:ext cx="1737360" cy="566928"/>
-          </a:xfrm>
-          <a:prstGeom prst="rect">
-            <a:avLst/>
-          </a:prstGeom>
-        </p:spPr>
-      </p:pic>
     </p:spTree>
   </p:cSld>
   <p:clrMapOvr>
@@ -6521,82 +5989,6 @@
           </a:p>
         </p:txBody>
       </p:sp>
-      <p:sp>
-        <p:nvSpPr>
-          <p:cNvPr id="10" name="TextBox 9"/>
-          <p:cNvSpPr txBox="1"/>
-          <p:nvPr/>
-        </p:nvSpPr>
-        <p:spPr>
-          <a:xfrm>
-            <a:off x="822960" y="9601200"/>
-            <a:ext cx="10424160" cy="457200"/>
-          </a:xfrm>
-          <a:prstGeom prst="rect">
-            <a:avLst/>
-          </a:prstGeom>
-          <a:noFill/>
-        </p:spPr>
-        <p:txBody>
-          <a:bodyPr wrap="square">
-            <a:spAutoFit/>
-          </a:bodyPr>
-          <a:lstStyle/>
-          <a:p>
-            <a:r>
-              <a:rPr sz="1300" b="0" i="0" spc="150">
-                <a:solidFill>
-                  <a:srgbClr val="000000"/>
-                </a:solidFill>
-                <a:latin typeface="Outfit"/>
-              </a:rPr>
-              <a:t>BASE ESTRATÉGICA DA MARCA</a:t>
-            </a:r>
-            <a:r>
-              <a:rPr sz="1300" b="0" i="0">
-                <a:solidFill>
-                  <a:srgbClr val="000000"/>
-                </a:solidFill>
-                <a:latin typeface="Outfit"/>
-              </a:rPr>
-              <a:t>   |   </a:t>
-            </a:r>
-            <a:r>
-              <a:rPr sz="1300" b="1" i="0" spc="150">
-                <a:solidFill>
-                  <a:srgbClr val="000000"/>
-                </a:solidFill>
-                <a:latin typeface="Outfit"/>
-              </a:rPr>
-              <a:t>YUFIL</a:t>
-            </a:r>
-          </a:p>
-        </p:txBody>
-      </p:sp>
-      <p:pic>
-        <p:nvPicPr>
-          <p:cNvPr id="11" name="Picture 10" descr="logo-ka.png"/>
-          <p:cNvPicPr>
-            <a:picLocks noChangeAspect="1"/>
-          </p:cNvPicPr>
-          <p:nvPr/>
-        </p:nvPicPr>
-        <p:blipFill>
-          <a:blip r:embed="rId2"/>
-          <a:stretch>
-            <a:fillRect/>
-          </a:stretch>
-        </p:blipFill>
-        <p:spPr>
-          <a:xfrm>
-            <a:off x="16093440" y="9464040"/>
-            <a:ext cx="1737360" cy="566928"/>
-          </a:xfrm>
-          <a:prstGeom prst="rect">
-            <a:avLst/>
-          </a:prstGeom>
-        </p:spPr>
-      </p:pic>
     </p:spTree>
   </p:cSld>
   <p:clrMapOvr>

</xml_diff>